<commit_message>
Link benefit steps 2 and 3: six pools stack into the haircut funnel
Step 2 shows all six activities with their addressable pools; step 3
opens with those pools stacked into one ~$17M bar in matching colors,
so the funnel visibly starts from the sum of step 2.

Co-Authored-By: Claude <noreply@anthropic.com>
Claude-Session: https://claude.ai/code/session_01NFmLfQt1gGoL7VkhSjRDgY
</commit_message>
<xml_diff>
--- a/docs/sizing-example/ds-sizing-example.pptx
+++ b/docs/sizing-example/ds-sizing-example.pptx
@@ -1290,7 +1290,7 @@
         </p:nvSpPr>
         <p:spPr>
           <a:xfrm>
-            <a:off x="502920" y="2139696"/>
+            <a:off x="502920" y="2121408"/>
             <a:ext cx="219456" cy="219456"/>
           </a:xfrm>
           <a:prstGeom prst="ellipse">
@@ -1310,7 +1310,7 @@
         </p:nvSpPr>
         <p:spPr>
           <a:xfrm>
-            <a:off x="502920" y="2139696"/>
+            <a:off x="502920" y="2121408"/>
             <a:ext cx="219456" cy="219456"/>
           </a:xfrm>
           <a:prstGeom prst="rect">
@@ -1349,7 +1349,7 @@
         </p:nvSpPr>
         <p:spPr>
           <a:xfrm>
-            <a:off x="813816" y="2121408"/>
+            <a:off x="813816" y="2103120"/>
             <a:ext cx="5486400" cy="256032"/>
           </a:xfrm>
           <a:prstGeom prst="rect">
@@ -1388,7 +1388,7 @@
         </p:nvSpPr>
         <p:spPr>
           <a:xfrm>
-            <a:off x="813816" y="2377440"/>
+            <a:off x="813816" y="2340864"/>
             <a:ext cx="5486400" cy="182880"/>
           </a:xfrm>
           <a:prstGeom prst="rect">
@@ -1427,24 +1427,24 @@
         </p:nvSpPr>
         <p:spPr>
           <a:xfrm>
-            <a:off x="813816" y="2633472"/>
-            <a:ext cx="1847088" cy="310896"/>
-          </a:xfrm>
-          <a:prstGeom prst="rect">
-            <a:avLst/>
-          </a:prstGeom>
-          <a:noFill/>
-          <a:ln/>
-        </p:spPr>
-        <p:txBody>
-          <a:bodyPr wrap="square" lIns="0" tIns="0" rIns="0" bIns="0" rtlCol="0" anchor="ctr"/>
-          <a:lstStyle/>
-          <a:p>
-            <a:pPr indent="0" marL="0">
-              <a:buNone/>
-            </a:pPr>
-            <a:r>
-              <a:rPr lang="en-US" sz="1250" dirty="0">
+            <a:off x="813816" y="2542032"/>
+            <a:ext cx="1847088" cy="237744"/>
+          </a:xfrm>
+          <a:prstGeom prst="rect">
+            <a:avLst/>
+          </a:prstGeom>
+          <a:noFill/>
+          <a:ln/>
+        </p:spPr>
+        <p:txBody>
+          <a:bodyPr wrap="square" lIns="0" tIns="0" rIns="0" bIns="0" rtlCol="0" anchor="ctr"/>
+          <a:lstStyle/>
+          <a:p>
+            <a:pPr indent="0" marL="0">
+              <a:buNone/>
+            </a:pPr>
+            <a:r>
+              <a:rPr lang="en-US" sz="1050" dirty="0">
                 <a:solidFill>
                   <a:srgbClr val="1F2A33"/>
                 </a:solidFill>
@@ -1454,7 +1454,7 @@
               </a:rPr>
               <a:t>Data prep &amp; cleaning</a:t>
             </a:r>
-            <a:endParaRPr lang="en-US" sz="1250" dirty="0"/>
+            <a:endParaRPr lang="en-US" sz="1050" dirty="0"/>
           </a:p>
         </p:txBody>
       </p:sp>
@@ -1466,8 +1466,8 @@
         </p:nvSpPr>
         <p:spPr>
           <a:xfrm>
-            <a:off x="2715768" y="2688336"/>
-            <a:ext cx="2286000" cy="201168"/>
+            <a:off x="2715768" y="2592324"/>
+            <a:ext cx="2286000" cy="146304"/>
           </a:xfrm>
           <a:prstGeom prst="rect">
             <a:avLst/>
@@ -1486,8 +1486,8 @@
         </p:nvSpPr>
         <p:spPr>
           <a:xfrm>
-            <a:off x="2715768" y="2688336"/>
-            <a:ext cx="1371600" cy="201168"/>
+            <a:off x="2715768" y="2592324"/>
+            <a:ext cx="1371600" cy="146304"/>
           </a:xfrm>
           <a:prstGeom prst="rect">
             <a:avLst/>
@@ -1506,24 +1506,24 @@
         </p:nvSpPr>
         <p:spPr>
           <a:xfrm>
-            <a:off x="5111496" y="2633472"/>
-            <a:ext cx="868680" cy="310896"/>
-          </a:xfrm>
-          <a:prstGeom prst="rect">
-            <a:avLst/>
-          </a:prstGeom>
-          <a:noFill/>
-          <a:ln/>
-        </p:spPr>
-        <p:txBody>
-          <a:bodyPr wrap="square" lIns="0" tIns="0" rIns="0" bIns="0" rtlCol="0" anchor="ctr"/>
-          <a:lstStyle/>
-          <a:p>
-            <a:pPr indent="0" marL="0">
-              <a:buNone/>
-            </a:pPr>
-            <a:r>
-              <a:rPr lang="en-US" sz="1300" b="1" dirty="0">
+            <a:off x="5093208" y="2542032"/>
+            <a:ext cx="868680" cy="237744"/>
+          </a:xfrm>
+          <a:prstGeom prst="rect">
+            <a:avLst/>
+          </a:prstGeom>
+          <a:noFill/>
+          <a:ln/>
+        </p:spPr>
+        <p:txBody>
+          <a:bodyPr wrap="square" lIns="0" tIns="0" rIns="0" bIns="0" rtlCol="0" anchor="ctr"/>
+          <a:lstStyle/>
+          <a:p>
+            <a:pPr indent="0" marL="0">
+              <a:buNone/>
+            </a:pPr>
+            <a:r>
+              <a:rPr lang="en-US" sz="1100" b="1" dirty="0">
                 <a:solidFill>
                   <a:srgbClr val="0B6B5D"/>
                 </a:solidFill>
@@ -1533,7 +1533,7 @@
               </a:rPr>
               <a:t>$6.8M</a:t>
             </a:r>
-            <a:endParaRPr lang="en-US" sz="1300" dirty="0"/>
+            <a:endParaRPr lang="en-US" sz="1100" dirty="0"/>
           </a:p>
         </p:txBody>
       </p:sp>
@@ -1545,24 +1545,24 @@
         </p:nvSpPr>
         <p:spPr>
           <a:xfrm>
-            <a:off x="813816" y="3054096"/>
-            <a:ext cx="1847088" cy="310896"/>
-          </a:xfrm>
-          <a:prstGeom prst="rect">
-            <a:avLst/>
-          </a:prstGeom>
-          <a:noFill/>
-          <a:ln/>
-        </p:spPr>
-        <p:txBody>
-          <a:bodyPr wrap="square" lIns="0" tIns="0" rIns="0" bIns="0" rtlCol="0" anchor="ctr"/>
-          <a:lstStyle/>
-          <a:p>
-            <a:pPr indent="0" marL="0">
-              <a:buNone/>
-            </a:pPr>
-            <a:r>
-              <a:rPr lang="en-US" sz="1250" dirty="0">
+            <a:off x="813816" y="2807208"/>
+            <a:ext cx="1847088" cy="237744"/>
+          </a:xfrm>
+          <a:prstGeom prst="rect">
+            <a:avLst/>
+          </a:prstGeom>
+          <a:noFill/>
+          <a:ln/>
+        </p:spPr>
+        <p:txBody>
+          <a:bodyPr wrap="square" lIns="0" tIns="0" rIns="0" bIns="0" rtlCol="0" anchor="ctr"/>
+          <a:lstStyle/>
+          <a:p>
+            <a:pPr indent="0" marL="0">
+              <a:buNone/>
+            </a:pPr>
+            <a:r>
+              <a:rPr lang="en-US" sz="1050" dirty="0">
                 <a:solidFill>
                   <a:srgbClr val="1F2A33"/>
                 </a:solidFill>
@@ -1570,9 +1570,9 @@
                 <a:ea typeface="Arial" pitchFamily="34" charset="-122"/>
                 <a:cs typeface="Arial" pitchFamily="34" charset="-120"/>
               </a:rPr>
-              <a:t>Exploratory analysis</a:t>
-            </a:r>
-            <a:endParaRPr lang="en-US" sz="1250" dirty="0"/>
+              <a:t>Model build &amp; experiments</a:t>
+            </a:r>
+            <a:endParaRPr lang="en-US" sz="1050" dirty="0"/>
           </a:p>
         </p:txBody>
       </p:sp>
@@ -1584,8 +1584,8 @@
         </p:nvSpPr>
         <p:spPr>
           <a:xfrm>
-            <a:off x="2715768" y="3108960"/>
-            <a:ext cx="1143000" cy="201168"/>
+            <a:off x="2715768" y="2857500"/>
+            <a:ext cx="1524000" cy="146304"/>
           </a:xfrm>
           <a:prstGeom prst="rect">
             <a:avLst/>
@@ -1604,8 +1604,8 @@
         </p:nvSpPr>
         <p:spPr>
           <a:xfrm>
-            <a:off x="2715768" y="3108960"/>
-            <a:ext cx="457200" cy="201168"/>
+            <a:off x="2715768" y="2857500"/>
+            <a:ext cx="533400" cy="146304"/>
           </a:xfrm>
           <a:prstGeom prst="rect">
             <a:avLst/>
@@ -1624,24 +1624,24 @@
         </p:nvSpPr>
         <p:spPr>
           <a:xfrm>
-            <a:off x="3968496" y="3054096"/>
-            <a:ext cx="868680" cy="310896"/>
-          </a:xfrm>
-          <a:prstGeom prst="rect">
-            <a:avLst/>
-          </a:prstGeom>
-          <a:noFill/>
-          <a:ln/>
-        </p:spPr>
-        <p:txBody>
-          <a:bodyPr wrap="square" lIns="0" tIns="0" rIns="0" bIns="0" rtlCol="0" anchor="ctr"/>
-          <a:lstStyle/>
-          <a:p>
-            <a:pPr indent="0" marL="0">
-              <a:buNone/>
-            </a:pPr>
-            <a:r>
-              <a:rPr lang="en-US" sz="1300" b="1" dirty="0">
+            <a:off x="4331208" y="2807208"/>
+            <a:ext cx="868680" cy="237744"/>
+          </a:xfrm>
+          <a:prstGeom prst="rect">
+            <a:avLst/>
+          </a:prstGeom>
+          <a:noFill/>
+          <a:ln/>
+        </p:spPr>
+        <p:txBody>
+          <a:bodyPr wrap="square" lIns="0" tIns="0" rIns="0" bIns="0" rtlCol="0" anchor="ctr"/>
+          <a:lstStyle/>
+          <a:p>
+            <a:pPr indent="0" marL="0">
+              <a:buNone/>
+            </a:pPr>
+            <a:r>
+              <a:rPr lang="en-US" sz="1100" b="1" dirty="0">
                 <a:solidFill>
                   <a:srgbClr val="9A5A0B"/>
                 </a:solidFill>
@@ -1649,9 +1649,9 @@
                 <a:ea typeface="Arial" pitchFamily="34" charset="-122"/>
                 <a:cs typeface="Arial" pitchFamily="34" charset="-120"/>
               </a:rPr>
-              <a:t>$2.3M</a:t>
-            </a:r>
-            <a:endParaRPr lang="en-US" sz="1300" dirty="0"/>
+              <a:t>$2.7M</a:t>
+            </a:r>
+            <a:endParaRPr lang="en-US" sz="1100" dirty="0"/>
           </a:p>
         </p:txBody>
       </p:sp>
@@ -1663,24 +1663,24 @@
         </p:nvSpPr>
         <p:spPr>
           <a:xfrm>
-            <a:off x="813816" y="3474720"/>
-            <a:ext cx="1847088" cy="310896"/>
-          </a:xfrm>
-          <a:prstGeom prst="rect">
-            <a:avLst/>
-          </a:prstGeom>
-          <a:noFill/>
-          <a:ln/>
-        </p:spPr>
-        <p:txBody>
-          <a:bodyPr wrap="square" lIns="0" tIns="0" rIns="0" bIns="0" rtlCol="0" anchor="ctr"/>
-          <a:lstStyle/>
-          <a:p>
-            <a:pPr indent="0" marL="0">
-              <a:buNone/>
-            </a:pPr>
-            <a:r>
-              <a:rPr lang="en-US" sz="1250" dirty="0">
+            <a:off x="813816" y="3072384"/>
+            <a:ext cx="1847088" cy="237744"/>
+          </a:xfrm>
+          <a:prstGeom prst="rect">
+            <a:avLst/>
+          </a:prstGeom>
+          <a:noFill/>
+          <a:ln/>
+        </p:spPr>
+        <p:txBody>
+          <a:bodyPr wrap="square" lIns="0" tIns="0" rIns="0" bIns="0" rtlCol="0" anchor="ctr"/>
+          <a:lstStyle/>
+          <a:p>
+            <a:pPr indent="0" marL="0">
+              <a:buNone/>
+            </a:pPr>
+            <a:r>
+              <a:rPr lang="en-US" sz="1050" dirty="0">
                 <a:solidFill>
                   <a:srgbClr val="1F2A33"/>
                 </a:solidFill>
@@ -1688,9 +1688,9 @@
                 <a:ea typeface="Arial" pitchFamily="34" charset="-122"/>
                 <a:cs typeface="Arial" pitchFamily="34" charset="-120"/>
               </a:rPr>
-              <a:t>Stakeholder alignment</a:t>
-            </a:r>
-            <a:endParaRPr lang="en-US" sz="1250" dirty="0"/>
+              <a:t>Exploratory analysis</a:t>
+            </a:r>
+            <a:endParaRPr lang="en-US" sz="1050" dirty="0"/>
           </a:p>
         </p:txBody>
       </p:sp>
@@ -1702,8 +1702,244 @@
         </p:nvSpPr>
         <p:spPr>
           <a:xfrm>
-            <a:off x="2715768" y="3529584"/>
-            <a:ext cx="914400" cy="201168"/>
+            <a:off x="2715768" y="3122676"/>
+            <a:ext cx="1143000" cy="146304"/>
+          </a:xfrm>
+          <a:prstGeom prst="rect">
+            <a:avLst/>
+          </a:prstGeom>
+          <a:solidFill>
+            <a:srgbClr val="EFD9B8"/>
+          </a:solidFill>
+          <a:ln/>
+        </p:spPr>
+      </p:sp>
+      <p:sp>
+        <p:nvSpPr>
+          <p:cNvPr id="25" name="Shape 22"/>
+          <p:cNvSpPr/>
+          <p:nvPr/>
+        </p:nvSpPr>
+        <p:spPr>
+          <a:xfrm>
+            <a:off x="2715768" y="3122676"/>
+            <a:ext cx="457200" cy="146304"/>
+          </a:xfrm>
+          <a:prstGeom prst="rect">
+            <a:avLst/>
+          </a:prstGeom>
+          <a:solidFill>
+            <a:srgbClr val="9A5A0B"/>
+          </a:solidFill>
+          <a:ln/>
+        </p:spPr>
+      </p:sp>
+      <p:sp>
+        <p:nvSpPr>
+          <p:cNvPr id="26" name="Text 23"/>
+          <p:cNvSpPr txBox="1"/>
+          <p:nvPr/>
+        </p:nvSpPr>
+        <p:spPr>
+          <a:xfrm>
+            <a:off x="3950208" y="3072384"/>
+            <a:ext cx="868680" cy="237744"/>
+          </a:xfrm>
+          <a:prstGeom prst="rect">
+            <a:avLst/>
+          </a:prstGeom>
+          <a:noFill/>
+          <a:ln/>
+        </p:spPr>
+        <p:txBody>
+          <a:bodyPr wrap="square" lIns="0" tIns="0" rIns="0" bIns="0" rtlCol="0" anchor="ctr"/>
+          <a:lstStyle/>
+          <a:p>
+            <a:pPr indent="0" marL="0">
+              <a:buNone/>
+            </a:pPr>
+            <a:r>
+              <a:rPr lang="en-US" sz="1100" b="1" dirty="0">
+                <a:solidFill>
+                  <a:srgbClr val="9A5A0B"/>
+                </a:solidFill>
+                <a:latin typeface="Arial" pitchFamily="34" charset="0"/>
+                <a:ea typeface="Arial" pitchFamily="34" charset="-122"/>
+                <a:cs typeface="Arial" pitchFamily="34" charset="-120"/>
+              </a:rPr>
+              <a:t>$2.3M</a:t>
+            </a:r>
+            <a:endParaRPr lang="en-US" sz="1100" dirty="0"/>
+          </a:p>
+        </p:txBody>
+      </p:sp>
+      <p:sp>
+        <p:nvSpPr>
+          <p:cNvPr id="27" name="Text 24"/>
+          <p:cNvSpPr txBox="1"/>
+          <p:nvPr/>
+        </p:nvSpPr>
+        <p:spPr>
+          <a:xfrm>
+            <a:off x="813816" y="3337560"/>
+            <a:ext cx="1847088" cy="237744"/>
+          </a:xfrm>
+          <a:prstGeom prst="rect">
+            <a:avLst/>
+          </a:prstGeom>
+          <a:noFill/>
+          <a:ln/>
+        </p:spPr>
+        <p:txBody>
+          <a:bodyPr wrap="square" lIns="0" tIns="0" rIns="0" bIns="0" rtlCol="0" anchor="ctr"/>
+          <a:lstStyle/>
+          <a:p>
+            <a:pPr indent="0" marL="0">
+              <a:buNone/>
+            </a:pPr>
+            <a:r>
+              <a:rPr lang="en-US" sz="1050" dirty="0">
+                <a:solidFill>
+                  <a:srgbClr val="1F2A33"/>
+                </a:solidFill>
+                <a:latin typeface="Arial" pitchFamily="34" charset="0"/>
+                <a:ea typeface="Arial" pitchFamily="34" charset="-122"/>
+                <a:cs typeface="Arial" pitchFamily="34" charset="-120"/>
+              </a:rPr>
+              <a:t>Reporting &amp; documentation</a:t>
+            </a:r>
+            <a:endParaRPr lang="en-US" sz="1050" dirty="0"/>
+          </a:p>
+        </p:txBody>
+      </p:sp>
+      <p:sp>
+        <p:nvSpPr>
+          <p:cNvPr id="28" name="Shape 25"/>
+          <p:cNvSpPr/>
+          <p:nvPr/>
+        </p:nvSpPr>
+        <p:spPr>
+          <a:xfrm>
+            <a:off x="2715768" y="3387852"/>
+            <a:ext cx="1143000" cy="146304"/>
+          </a:xfrm>
+          <a:prstGeom prst="rect">
+            <a:avLst/>
+          </a:prstGeom>
+          <a:solidFill>
+            <a:srgbClr val="BFE0D8"/>
+          </a:solidFill>
+          <a:ln/>
+        </p:spPr>
+      </p:sp>
+      <p:sp>
+        <p:nvSpPr>
+          <p:cNvPr id="29" name="Shape 26"/>
+          <p:cNvSpPr/>
+          <p:nvPr/>
+        </p:nvSpPr>
+        <p:spPr>
+          <a:xfrm>
+            <a:off x="2715768" y="3387852"/>
+            <a:ext cx="685800" cy="146304"/>
+          </a:xfrm>
+          <a:prstGeom prst="rect">
+            <a:avLst/>
+          </a:prstGeom>
+          <a:solidFill>
+            <a:srgbClr val="0B6B5D"/>
+          </a:solidFill>
+          <a:ln/>
+        </p:spPr>
+      </p:sp>
+      <p:sp>
+        <p:nvSpPr>
+          <p:cNvPr id="30" name="Text 27"/>
+          <p:cNvSpPr txBox="1"/>
+          <p:nvPr/>
+        </p:nvSpPr>
+        <p:spPr>
+          <a:xfrm>
+            <a:off x="3950208" y="3337560"/>
+            <a:ext cx="868680" cy="237744"/>
+          </a:xfrm>
+          <a:prstGeom prst="rect">
+            <a:avLst/>
+          </a:prstGeom>
+          <a:noFill/>
+          <a:ln/>
+        </p:spPr>
+        <p:txBody>
+          <a:bodyPr wrap="square" lIns="0" tIns="0" rIns="0" bIns="0" rtlCol="0" anchor="ctr"/>
+          <a:lstStyle/>
+          <a:p>
+            <a:pPr indent="0" marL="0">
+              <a:buNone/>
+            </a:pPr>
+            <a:r>
+              <a:rPr lang="en-US" sz="1100" b="1" dirty="0">
+                <a:solidFill>
+                  <a:srgbClr val="0B6B5D"/>
+                </a:solidFill>
+                <a:latin typeface="Arial" pitchFamily="34" charset="0"/>
+                <a:ea typeface="Arial" pitchFamily="34" charset="-122"/>
+                <a:cs typeface="Arial" pitchFamily="34" charset="-120"/>
+              </a:rPr>
+              <a:t>$3.4M</a:t>
+            </a:r>
+            <a:endParaRPr lang="en-US" sz="1100" dirty="0"/>
+          </a:p>
+        </p:txBody>
+      </p:sp>
+      <p:sp>
+        <p:nvSpPr>
+          <p:cNvPr id="31" name="Text 28"/>
+          <p:cNvSpPr txBox="1"/>
+          <p:nvPr/>
+        </p:nvSpPr>
+        <p:spPr>
+          <a:xfrm>
+            <a:off x="813816" y="3602736"/>
+            <a:ext cx="1847088" cy="237744"/>
+          </a:xfrm>
+          <a:prstGeom prst="rect">
+            <a:avLst/>
+          </a:prstGeom>
+          <a:noFill/>
+          <a:ln/>
+        </p:spPr>
+        <p:txBody>
+          <a:bodyPr wrap="square" lIns="0" tIns="0" rIns="0" bIns="0" rtlCol="0" anchor="ctr"/>
+          <a:lstStyle/>
+          <a:p>
+            <a:pPr indent="0" marL="0">
+              <a:buNone/>
+            </a:pPr>
+            <a:r>
+              <a:rPr lang="en-US" sz="1050" dirty="0">
+                <a:solidFill>
+                  <a:srgbClr val="1F2A33"/>
+                </a:solidFill>
+                <a:latin typeface="Arial" pitchFamily="34" charset="0"/>
+                <a:ea typeface="Arial" pitchFamily="34" charset="-122"/>
+                <a:cs typeface="Arial" pitchFamily="34" charset="-120"/>
+              </a:rPr>
+              <a:t>Stakeholder alignment</a:t>
+            </a:r>
+            <a:endParaRPr lang="en-US" sz="1050" dirty="0"/>
+          </a:p>
+        </p:txBody>
+      </p:sp>
+      <p:sp>
+        <p:nvSpPr>
+          <p:cNvPr id="32" name="Shape 29"/>
+          <p:cNvSpPr/>
+          <p:nvPr/>
+        </p:nvSpPr>
+        <p:spPr>
+          <a:xfrm>
+            <a:off x="2715768" y="3653028"/>
+            <a:ext cx="914400" cy="146304"/>
           </a:xfrm>
           <a:prstGeom prst="rect">
             <a:avLst/>
@@ -1716,14 +1952,14 @@
       </p:sp>
       <p:sp>
         <p:nvSpPr>
-          <p:cNvPr id="25" name="Shape 22"/>
+          <p:cNvPr id="33" name="Shape 30"/>
           <p:cNvSpPr/>
           <p:nvPr/>
         </p:nvSpPr>
         <p:spPr>
           <a:xfrm>
-            <a:off x="2715768" y="3529584"/>
-            <a:ext cx="91440" cy="201168"/>
+            <a:off x="2715768" y="3653028"/>
+            <a:ext cx="91440" cy="146304"/>
           </a:xfrm>
           <a:prstGeom prst="rect">
             <a:avLst/>
@@ -1736,30 +1972,30 @@
       </p:sp>
       <p:sp>
         <p:nvSpPr>
-          <p:cNvPr id="26" name="Text 23"/>
-          <p:cNvSpPr txBox="1"/>
-          <p:nvPr/>
-        </p:nvSpPr>
-        <p:spPr>
-          <a:xfrm>
-            <a:off x="3739896" y="3474720"/>
-            <a:ext cx="868680" cy="310896"/>
-          </a:xfrm>
-          <a:prstGeom prst="rect">
-            <a:avLst/>
-          </a:prstGeom>
-          <a:noFill/>
-          <a:ln/>
-        </p:spPr>
-        <p:txBody>
-          <a:bodyPr wrap="square" lIns="0" tIns="0" rIns="0" bIns="0" rtlCol="0" anchor="ctr"/>
-          <a:lstStyle/>
-          <a:p>
-            <a:pPr indent="0" marL="0">
-              <a:buNone/>
-            </a:pPr>
-            <a:r>
-              <a:rPr lang="en-US" sz="1300" b="1" dirty="0">
+          <p:cNvPr id="34" name="Text 31"/>
+          <p:cNvSpPr txBox="1"/>
+          <p:nvPr/>
+        </p:nvSpPr>
+        <p:spPr>
+          <a:xfrm>
+            <a:off x="3721608" y="3602736"/>
+            <a:ext cx="868680" cy="237744"/>
+          </a:xfrm>
+          <a:prstGeom prst="rect">
+            <a:avLst/>
+          </a:prstGeom>
+          <a:noFill/>
+          <a:ln/>
+        </p:spPr>
+        <p:txBody>
+          <a:bodyPr wrap="square" lIns="0" tIns="0" rIns="0" bIns="0" rtlCol="0" anchor="ctr"/>
+          <a:lstStyle/>
+          <a:p>
+            <a:pPr indent="0" marL="0">
+              <a:buNone/>
+            </a:pPr>
+            <a:r>
+              <a:rPr lang="en-US" sz="1100" b="1" dirty="0">
                 <a:solidFill>
                   <a:srgbClr val="9A4E58"/>
                 </a:solidFill>
@@ -1769,58 +2005,137 @@
               </a:rPr>
               <a:t>$0.5M</a:t>
             </a:r>
-            <a:endParaRPr lang="en-US" sz="1300" dirty="0"/>
-          </a:p>
-        </p:txBody>
-      </p:sp>
-      <p:sp>
-        <p:nvSpPr>
-          <p:cNvPr id="27" name="Text 24"/>
-          <p:cNvSpPr txBox="1"/>
-          <p:nvPr/>
-        </p:nvSpPr>
-        <p:spPr>
-          <a:xfrm>
-            <a:off x="813816" y="3913632"/>
-            <a:ext cx="5486400" cy="182880"/>
-          </a:xfrm>
-          <a:prstGeom prst="rect">
-            <a:avLst/>
-          </a:prstGeom>
-          <a:noFill/>
-          <a:ln/>
-        </p:spPr>
-        <p:txBody>
-          <a:bodyPr wrap="square" lIns="0" tIns="0" rIns="0" bIns="0" rtlCol="0" anchor="ctr"/>
-          <a:lstStyle/>
-          <a:p>
-            <a:pPr indent="0" marL="0">
-              <a:buNone/>
-            </a:pPr>
-            <a:r>
-              <a:rPr lang="en-US" sz="950" i="1" dirty="0">
-                <a:solidFill>
-                  <a:srgbClr val="5C6B77"/>
-                </a:solidFill>
-                <a:latin typeface="Arial" pitchFamily="34" charset="0"/>
-                <a:ea typeface="Arial" pitchFamily="34" charset="-122"/>
-                <a:cs typeface="Arial" pitchFamily="34" charset="-120"/>
-              </a:rPr>
-              <a:t>…plus model build, reporting and ad-hoc work — all six pools together: $17M</a:t>
-            </a:r>
-            <a:endParaRPr lang="en-US" sz="950" dirty="0"/>
-          </a:p>
-        </p:txBody>
-      </p:sp>
-      <p:sp>
-        <p:nvSpPr>
-          <p:cNvPr id="28" name="Shape 25"/>
+            <a:endParaRPr lang="en-US" sz="1100" dirty="0"/>
+          </a:p>
+        </p:txBody>
+      </p:sp>
+      <p:sp>
+        <p:nvSpPr>
+          <p:cNvPr id="35" name="Text 32"/>
+          <p:cNvSpPr txBox="1"/>
+          <p:nvPr/>
+        </p:nvSpPr>
+        <p:spPr>
+          <a:xfrm>
+            <a:off x="813816" y="3867912"/>
+            <a:ext cx="1847088" cy="237744"/>
+          </a:xfrm>
+          <a:prstGeom prst="rect">
+            <a:avLst/>
+          </a:prstGeom>
+          <a:noFill/>
+          <a:ln/>
+        </p:spPr>
+        <p:txBody>
+          <a:bodyPr wrap="square" lIns="0" tIns="0" rIns="0" bIns="0" rtlCol="0" anchor="ctr"/>
+          <a:lstStyle/>
+          <a:p>
+            <a:pPr indent="0" marL="0">
+              <a:buNone/>
+            </a:pPr>
+            <a:r>
+              <a:rPr lang="en-US" sz="1050" dirty="0">
+                <a:solidFill>
+                  <a:srgbClr val="1F2A33"/>
+                </a:solidFill>
+                <a:latin typeface="Arial" pitchFamily="34" charset="0"/>
+                <a:ea typeface="Arial" pitchFamily="34" charset="-122"/>
+                <a:cs typeface="Arial" pitchFamily="34" charset="-120"/>
+              </a:rPr>
+              <a:t>Ad-hoc requests</a:t>
+            </a:r>
+            <a:endParaRPr lang="en-US" sz="1050" dirty="0"/>
+          </a:p>
+        </p:txBody>
+      </p:sp>
+      <p:sp>
+        <p:nvSpPr>
+          <p:cNvPr id="36" name="Shape 33"/>
           <p:cNvSpPr/>
           <p:nvPr/>
         </p:nvSpPr>
         <p:spPr>
           <a:xfrm>
-            <a:off x="502920" y="4187952"/>
+            <a:off x="2715768" y="3918204"/>
+            <a:ext cx="609600" cy="146304"/>
+          </a:xfrm>
+          <a:prstGeom prst="rect">
+            <a:avLst/>
+          </a:prstGeom>
+          <a:solidFill>
+            <a:srgbClr val="EFD9B8"/>
+          </a:solidFill>
+          <a:ln/>
+        </p:spPr>
+      </p:sp>
+      <p:sp>
+        <p:nvSpPr>
+          <p:cNvPr id="37" name="Shape 34"/>
+          <p:cNvSpPr/>
+          <p:nvPr/>
+        </p:nvSpPr>
+        <p:spPr>
+          <a:xfrm>
+            <a:off x="2715768" y="3918204"/>
+            <a:ext cx="274320" cy="146304"/>
+          </a:xfrm>
+          <a:prstGeom prst="rect">
+            <a:avLst/>
+          </a:prstGeom>
+          <a:solidFill>
+            <a:srgbClr val="9A5A0B"/>
+          </a:solidFill>
+          <a:ln/>
+        </p:spPr>
+      </p:sp>
+      <p:sp>
+        <p:nvSpPr>
+          <p:cNvPr id="38" name="Text 35"/>
+          <p:cNvSpPr txBox="1"/>
+          <p:nvPr/>
+        </p:nvSpPr>
+        <p:spPr>
+          <a:xfrm>
+            <a:off x="3416808" y="3867912"/>
+            <a:ext cx="868680" cy="237744"/>
+          </a:xfrm>
+          <a:prstGeom prst="rect">
+            <a:avLst/>
+          </a:prstGeom>
+          <a:noFill/>
+          <a:ln/>
+        </p:spPr>
+        <p:txBody>
+          <a:bodyPr wrap="square" lIns="0" tIns="0" rIns="0" bIns="0" rtlCol="0" anchor="ctr"/>
+          <a:lstStyle/>
+          <a:p>
+            <a:pPr indent="0" marL="0">
+              <a:buNone/>
+            </a:pPr>
+            <a:r>
+              <a:rPr lang="en-US" sz="1100" b="1" dirty="0">
+                <a:solidFill>
+                  <a:srgbClr val="9A5A0B"/>
+                </a:solidFill>
+                <a:latin typeface="Arial" pitchFamily="34" charset="0"/>
+                <a:ea typeface="Arial" pitchFamily="34" charset="-122"/>
+                <a:cs typeface="Arial" pitchFamily="34" charset="-120"/>
+              </a:rPr>
+              <a:t>$1.4M</a:t>
+            </a:r>
+            <a:endParaRPr lang="en-US" sz="1100" dirty="0"/>
+          </a:p>
+        </p:txBody>
+      </p:sp>
+      <p:sp>
+        <p:nvSpPr>
+          <p:cNvPr id="39" name="Shape 36"/>
+          <p:cNvSpPr/>
+          <p:nvPr/>
+        </p:nvSpPr>
+        <p:spPr>
+          <a:xfrm>
+            <a:off x="502920" y="4224528"/>
             <a:ext cx="219456" cy="219456"/>
           </a:xfrm>
           <a:prstGeom prst="ellipse">
@@ -1834,13 +2149,13 @@
       </p:sp>
       <p:sp>
         <p:nvSpPr>
-          <p:cNvPr id="29" name="Text 26"/>
-          <p:cNvSpPr txBox="1"/>
-          <p:nvPr/>
-        </p:nvSpPr>
-        <p:spPr>
-          <a:xfrm>
-            <a:off x="502920" y="4187952"/>
+          <p:cNvPr id="40" name="Text 37"/>
+          <p:cNvSpPr txBox="1"/>
+          <p:nvPr/>
+        </p:nvSpPr>
+        <p:spPr>
+          <a:xfrm>
+            <a:off x="502920" y="4224528"/>
             <a:ext cx="219456" cy="219456"/>
           </a:xfrm>
           <a:prstGeom prst="rect">
@@ -1873,13 +2188,13 @@
       </p:sp>
       <p:sp>
         <p:nvSpPr>
-          <p:cNvPr id="30" name="Text 27"/>
-          <p:cNvSpPr txBox="1"/>
-          <p:nvPr/>
-        </p:nvSpPr>
-        <p:spPr>
-          <a:xfrm>
-            <a:off x="813816" y="4169664"/>
+          <p:cNvPr id="41" name="Text 38"/>
+          <p:cNvSpPr txBox="1"/>
+          <p:nvPr/>
+        </p:nvSpPr>
+        <p:spPr>
+          <a:xfrm>
+            <a:off x="813816" y="4206240"/>
             <a:ext cx="5486400" cy="256032"/>
           </a:xfrm>
           <a:prstGeom prst="rect">
@@ -1904,7 +2219,7 @@
                 <a:ea typeface="Arial" pitchFamily="34" charset="-122"/>
                 <a:cs typeface="Arial" pitchFamily="34" charset="-120"/>
               </a:rPr>
-              <a:t>Haircut it to what you can actually capture</a:t>
+              <a:t>Add the pools up — then haircut to what you can capture</a:t>
             </a:r>
             <a:endParaRPr lang="en-US" sz="1350" dirty="0"/>
           </a:p>
@@ -1912,13 +2227,13 @@
       </p:sp>
       <p:sp>
         <p:nvSpPr>
-          <p:cNvPr id="31" name="Text 28"/>
-          <p:cNvSpPr txBox="1"/>
-          <p:nvPr/>
-        </p:nvSpPr>
-        <p:spPr>
-          <a:xfrm>
-            <a:off x="813816" y="4443984"/>
+          <p:cNvPr id="42" name="Text 39"/>
+          <p:cNvSpPr txBox="1"/>
+          <p:nvPr/>
+        </p:nvSpPr>
+        <p:spPr>
+          <a:xfrm>
+            <a:off x="813816" y="4480560"/>
             <a:ext cx="1847088" cy="237744"/>
           </a:xfrm>
           <a:prstGeom prst="rect">
@@ -1943,7 +2258,7 @@
                 <a:ea typeface="Arial" pitchFamily="34" charset="-122"/>
                 <a:cs typeface="Arial" pitchFamily="34" charset="-120"/>
               </a:rPr>
-              <a:t>All six activity pools</a:t>
+              <a:t>All six pools added up</a:t>
             </a:r>
             <a:endParaRPr lang="en-US" sz="1100" dirty="0"/>
           </a:p>
@@ -1951,14 +2266,251 @@
       </p:sp>
       <p:sp>
         <p:nvSpPr>
-          <p:cNvPr id="32" name="Shape 29"/>
+          <p:cNvPr id="43" name="Shape 40"/>
           <p:cNvSpPr/>
           <p:nvPr/>
         </p:nvSpPr>
         <p:spPr>
           <a:xfrm>
-            <a:off x="2715768" y="4485132"/>
-            <a:ext cx="2286000" cy="164592"/>
+            <a:off x="2715768" y="4521708"/>
+            <a:ext cx="890765" cy="164592"/>
+          </a:xfrm>
+          <a:prstGeom prst="rect">
+            <a:avLst/>
+          </a:prstGeom>
+          <a:solidFill>
+            <a:srgbClr val="0B6B5D"/>
+          </a:solidFill>
+          <a:ln/>
+        </p:spPr>
+      </p:sp>
+      <p:sp>
+        <p:nvSpPr>
+          <p:cNvPr id="44" name="Shape 41"/>
+          <p:cNvSpPr/>
+          <p:nvPr/>
+        </p:nvSpPr>
+        <p:spPr>
+          <a:xfrm>
+            <a:off x="3624821" y="4521708"/>
+            <a:ext cx="342659" cy="164592"/>
+          </a:xfrm>
+          <a:prstGeom prst="rect">
+            <a:avLst/>
+          </a:prstGeom>
+          <a:solidFill>
+            <a:srgbClr val="9A5A0B"/>
+          </a:solidFill>
+          <a:ln/>
+        </p:spPr>
+      </p:sp>
+      <p:sp>
+        <p:nvSpPr>
+          <p:cNvPr id="45" name="Shape 42"/>
+          <p:cNvSpPr/>
+          <p:nvPr/>
+        </p:nvSpPr>
+        <p:spPr>
+          <a:xfrm>
+            <a:off x="3985768" y="4521708"/>
+            <a:ext cx="289186" cy="164592"/>
+          </a:xfrm>
+          <a:prstGeom prst="rect">
+            <a:avLst/>
+          </a:prstGeom>
+          <a:solidFill>
+            <a:srgbClr val="9A5A0B"/>
+          </a:solidFill>
+          <a:ln/>
+        </p:spPr>
+      </p:sp>
+      <p:sp>
+        <p:nvSpPr>
+          <p:cNvPr id="46" name="Shape 43"/>
+          <p:cNvSpPr/>
+          <p:nvPr/>
+        </p:nvSpPr>
+        <p:spPr>
+          <a:xfrm>
+            <a:off x="4293242" y="4521708"/>
+            <a:ext cx="436238" cy="164592"/>
+          </a:xfrm>
+          <a:prstGeom prst="rect">
+            <a:avLst/>
+          </a:prstGeom>
+          <a:solidFill>
+            <a:srgbClr val="0B6B5D"/>
+          </a:solidFill>
+          <a:ln/>
+        </p:spPr>
+      </p:sp>
+      <p:sp>
+        <p:nvSpPr>
+          <p:cNvPr id="47" name="Shape 44"/>
+          <p:cNvSpPr/>
+          <p:nvPr/>
+        </p:nvSpPr>
+        <p:spPr>
+          <a:xfrm>
+            <a:off x="4747768" y="4521708"/>
+            <a:ext cx="48554" cy="164592"/>
+          </a:xfrm>
+          <a:prstGeom prst="rect">
+            <a:avLst/>
+          </a:prstGeom>
+          <a:solidFill>
+            <a:srgbClr val="9A4E58"/>
+          </a:solidFill>
+          <a:ln/>
+        </p:spPr>
+      </p:sp>
+      <p:sp>
+        <p:nvSpPr>
+          <p:cNvPr id="48" name="Shape 45"/>
+          <p:cNvSpPr/>
+          <p:nvPr/>
+        </p:nvSpPr>
+        <p:spPr>
+          <a:xfrm>
+            <a:off x="4814610" y="4521708"/>
+            <a:ext cx="168870" cy="164592"/>
+          </a:xfrm>
+          <a:prstGeom prst="rect">
+            <a:avLst/>
+          </a:prstGeom>
+          <a:solidFill>
+            <a:srgbClr val="9A5A0B"/>
+          </a:solidFill>
+          <a:ln/>
+        </p:spPr>
+      </p:sp>
+      <p:sp>
+        <p:nvSpPr>
+          <p:cNvPr id="49" name="Text 46"/>
+          <p:cNvSpPr txBox="1"/>
+          <p:nvPr/>
+        </p:nvSpPr>
+        <p:spPr>
+          <a:xfrm>
+            <a:off x="5074920" y="4480560"/>
+            <a:ext cx="2011680" cy="237744"/>
+          </a:xfrm>
+          <a:prstGeom prst="rect">
+            <a:avLst/>
+          </a:prstGeom>
+          <a:noFill/>
+          <a:ln/>
+        </p:spPr>
+        <p:txBody>
+          <a:bodyPr wrap="square" lIns="0" tIns="0" rIns="0" bIns="0" rtlCol="0" anchor="ctr"/>
+          <a:lstStyle/>
+          <a:p>
+            <a:pPr indent="0" marL="0">
+              <a:buNone/>
+            </a:pPr>
+            <a:r>
+              <a:rPr lang="en-US" sz="1150" b="1" dirty="0">
+                <a:solidFill>
+                  <a:srgbClr val="0B6B5D"/>
+                </a:solidFill>
+                <a:latin typeface="Arial" pitchFamily="34" charset="0"/>
+                <a:ea typeface="Arial" pitchFamily="34" charset="-122"/>
+                <a:cs typeface="Arial" pitchFamily="34" charset="-120"/>
+              </a:rPr>
+              <a:t>≈$17M</a:t>
+            </a:r>
+            <a:endParaRPr lang="en-US" sz="1150" dirty="0"/>
+          </a:p>
+        </p:txBody>
+      </p:sp>
+      <p:sp>
+        <p:nvSpPr>
+          <p:cNvPr id="50" name="Text 47"/>
+          <p:cNvSpPr txBox="1"/>
+          <p:nvPr/>
+        </p:nvSpPr>
+        <p:spPr>
+          <a:xfrm>
+            <a:off x="1527048" y="4736592"/>
+            <a:ext cx="4937760" cy="182880"/>
+          </a:xfrm>
+          <a:prstGeom prst="rect">
+            <a:avLst/>
+          </a:prstGeom>
+          <a:noFill/>
+          <a:ln/>
+        </p:spPr>
+        <p:txBody>
+          <a:bodyPr wrap="square" lIns="0" tIns="0" rIns="0" bIns="0" rtlCol="0" anchor="ctr"/>
+          <a:lstStyle/>
+          <a:p>
+            <a:pPr indent="0" marL="0">
+              <a:buNone/>
+            </a:pPr>
+            <a:r>
+              <a:rPr lang="en-US" sz="950" i="1" dirty="0">
+                <a:solidFill>
+                  <a:srgbClr val="5C6B77"/>
+                </a:solidFill>
+                <a:latin typeface="Arial" pitchFamily="34" charset="0"/>
+                <a:ea typeface="Arial" pitchFamily="34" charset="-122"/>
+                <a:cs typeface="Arial" pitchFamily="34" charset="-120"/>
+              </a:rPr>
+              <a:t>− you already cover some of this today — tools in place, learned via interviews  (−25%)</a:t>
+            </a:r>
+            <a:endParaRPr lang="en-US" sz="950" dirty="0"/>
+          </a:p>
+        </p:txBody>
+      </p:sp>
+      <p:sp>
+        <p:nvSpPr>
+          <p:cNvPr id="51" name="Text 48"/>
+          <p:cNvSpPr txBox="1"/>
+          <p:nvPr/>
+        </p:nvSpPr>
+        <p:spPr>
+          <a:xfrm>
+            <a:off x="813816" y="4919472"/>
+            <a:ext cx="1847088" cy="237744"/>
+          </a:xfrm>
+          <a:prstGeom prst="rect">
+            <a:avLst/>
+          </a:prstGeom>
+          <a:noFill/>
+          <a:ln/>
+        </p:spPr>
+        <p:txBody>
+          <a:bodyPr wrap="square" lIns="0" tIns="0" rIns="0" bIns="0" rtlCol="0" anchor="ctr"/>
+          <a:lstStyle/>
+          <a:p>
+            <a:pPr indent="0" marL="0">
+              <a:buNone/>
+            </a:pPr>
+            <a:r>
+              <a:rPr lang="en-US" sz="1100" dirty="0">
+                <a:solidFill>
+                  <a:srgbClr val="1F2A33"/>
+                </a:solidFill>
+                <a:latin typeface="Arial" pitchFamily="34" charset="0"/>
+                <a:ea typeface="Arial" pitchFamily="34" charset="-122"/>
+                <a:cs typeface="Arial" pitchFamily="34" charset="-120"/>
+              </a:rPr>
+              <a:t>Truly new opportunity</a:t>
+            </a:r>
+            <a:endParaRPr lang="en-US" sz="1100" dirty="0"/>
+          </a:p>
+        </p:txBody>
+      </p:sp>
+      <p:sp>
+        <p:nvSpPr>
+          <p:cNvPr id="52" name="Shape 49"/>
+          <p:cNvSpPr/>
+          <p:nvPr/>
+        </p:nvSpPr>
+        <p:spPr>
+          <a:xfrm>
+            <a:off x="2715768" y="4960620"/>
+            <a:ext cx="1711158" cy="164592"/>
           </a:xfrm>
           <a:prstGeom prst="rect">
             <a:avLst/>
@@ -1971,13 +2523,13 @@
       </p:sp>
       <p:sp>
         <p:nvSpPr>
-          <p:cNvPr id="33" name="Text 30"/>
-          <p:cNvSpPr txBox="1"/>
-          <p:nvPr/>
-        </p:nvSpPr>
-        <p:spPr>
-          <a:xfrm>
-            <a:off x="5093208" y="4443984"/>
+          <p:cNvPr id="53" name="Text 50"/>
+          <p:cNvSpPr txBox="1"/>
+          <p:nvPr/>
+        </p:nvSpPr>
+        <p:spPr>
+          <a:xfrm>
+            <a:off x="4518366" y="4919472"/>
             <a:ext cx="2011680" cy="237744"/>
           </a:xfrm>
           <a:prstGeom prst="rect">
@@ -2002,7 +2554,7 @@
                 <a:ea typeface="Arial" pitchFamily="34" charset="-122"/>
                 <a:cs typeface="Arial" pitchFamily="34" charset="-120"/>
               </a:rPr>
-              <a:t>$17.0M</a:t>
+              <a:t>$12.8M</a:t>
             </a:r>
             <a:endParaRPr lang="en-US" sz="1150" dirty="0"/>
           </a:p>
@@ -2010,13 +2562,13 @@
       </p:sp>
       <p:sp>
         <p:nvSpPr>
-          <p:cNvPr id="34" name="Text 31"/>
-          <p:cNvSpPr txBox="1"/>
-          <p:nvPr/>
-        </p:nvSpPr>
-        <p:spPr>
-          <a:xfrm>
-            <a:off x="1527048" y="4700016"/>
+          <p:cNvPr id="54" name="Text 51"/>
+          <p:cNvSpPr txBox="1"/>
+          <p:nvPr/>
+        </p:nvSpPr>
+        <p:spPr>
+          <a:xfrm>
+            <a:off x="1527048" y="5175504"/>
             <a:ext cx="4937760" cy="182880"/>
           </a:xfrm>
           <a:prstGeom prst="rect">
@@ -2041,7 +2593,7 @@
                 <a:ea typeface="Arial" pitchFamily="34" charset="-122"/>
                 <a:cs typeface="Arial" pitchFamily="34" charset="-120"/>
               </a:rPr>
-              <a:t>− you already cover some of this today — tools in place, learned via interviews  (−25%)</a:t>
+              <a:t>− not everything gets captured — people adopt gradually, freed time is reinvested  (−35%)</a:t>
             </a:r>
             <a:endParaRPr lang="en-US" sz="950" dirty="0"/>
           </a:p>
@@ -2049,13 +2601,13 @@
       </p:sp>
       <p:sp>
         <p:nvSpPr>
-          <p:cNvPr id="35" name="Text 32"/>
-          <p:cNvSpPr txBox="1"/>
-          <p:nvPr/>
-        </p:nvSpPr>
-        <p:spPr>
-          <a:xfrm>
-            <a:off x="813816" y="4882896"/>
+          <p:cNvPr id="55" name="Text 52"/>
+          <p:cNvSpPr txBox="1"/>
+          <p:nvPr/>
+        </p:nvSpPr>
+        <p:spPr>
+          <a:xfrm>
+            <a:off x="813816" y="5358384"/>
             <a:ext cx="1847088" cy="237744"/>
           </a:xfrm>
           <a:prstGeom prst="rect">
@@ -2072,15 +2624,15 @@
               <a:buNone/>
             </a:pPr>
             <a:r>
-              <a:rPr lang="en-US" sz="1100" dirty="0">
-                <a:solidFill>
-                  <a:srgbClr val="1F2A33"/>
-                </a:solidFill>
-                <a:latin typeface="Arial" pitchFamily="34" charset="0"/>
-                <a:ea typeface="Arial" pitchFamily="34" charset="-122"/>
-                <a:cs typeface="Arial" pitchFamily="34" charset="-120"/>
-              </a:rPr>
-              <a:t>Truly new opportunity</a:t>
+              <a:rPr lang="en-US" sz="1100" b="1" dirty="0">
+                <a:solidFill>
+                  <a:srgbClr val="9A5A0B"/>
+                </a:solidFill>
+                <a:latin typeface="Arial" pitchFamily="34" charset="0"/>
+                <a:ea typeface="Arial" pitchFamily="34" charset="-122"/>
+                <a:cs typeface="Arial" pitchFamily="34" charset="-120"/>
+              </a:rPr>
+              <a:t>Capturable</a:t>
             </a:r>
             <a:endParaRPr lang="en-US" sz="1100" dirty="0"/>
           </a:p>
@@ -2088,151 +2640,14 @@
       </p:sp>
       <p:sp>
         <p:nvSpPr>
-          <p:cNvPr id="36" name="Shape 33"/>
+          <p:cNvPr id="56" name="Shape 53"/>
           <p:cNvSpPr/>
           <p:nvPr/>
         </p:nvSpPr>
         <p:spPr>
           <a:xfrm>
-            <a:off x="2715768" y="4924044"/>
-            <a:ext cx="1721224" cy="164592"/>
-          </a:xfrm>
-          <a:prstGeom prst="rect">
-            <a:avLst/>
-          </a:prstGeom>
-          <a:solidFill>
-            <a:srgbClr val="129682"/>
-          </a:solidFill>
-          <a:ln/>
-        </p:spPr>
-      </p:sp>
-      <p:sp>
-        <p:nvSpPr>
-          <p:cNvPr id="37" name="Text 34"/>
-          <p:cNvSpPr txBox="1"/>
-          <p:nvPr/>
-        </p:nvSpPr>
-        <p:spPr>
-          <a:xfrm>
-            <a:off x="4528432" y="4882896"/>
-            <a:ext cx="2011680" cy="237744"/>
-          </a:xfrm>
-          <a:prstGeom prst="rect">
-            <a:avLst/>
-          </a:prstGeom>
-          <a:noFill/>
-          <a:ln/>
-        </p:spPr>
-        <p:txBody>
-          <a:bodyPr wrap="square" lIns="0" tIns="0" rIns="0" bIns="0" rtlCol="0" anchor="ctr"/>
-          <a:lstStyle/>
-          <a:p>
-            <a:pPr indent="0" marL="0">
-              <a:buNone/>
-            </a:pPr>
-            <a:r>
-              <a:rPr lang="en-US" sz="1150" b="1" dirty="0">
-                <a:solidFill>
-                  <a:srgbClr val="0B6B5D"/>
-                </a:solidFill>
-                <a:latin typeface="Arial" pitchFamily="34" charset="0"/>
-                <a:ea typeface="Arial" pitchFamily="34" charset="-122"/>
-                <a:cs typeface="Arial" pitchFamily="34" charset="-120"/>
-              </a:rPr>
-              <a:t>$12.8M</a:t>
-            </a:r>
-            <a:endParaRPr lang="en-US" sz="1150" dirty="0"/>
-          </a:p>
-        </p:txBody>
-      </p:sp>
-      <p:sp>
-        <p:nvSpPr>
-          <p:cNvPr id="38" name="Text 35"/>
-          <p:cNvSpPr txBox="1"/>
-          <p:nvPr/>
-        </p:nvSpPr>
-        <p:spPr>
-          <a:xfrm>
-            <a:off x="1527048" y="5138928"/>
-            <a:ext cx="4937760" cy="182880"/>
-          </a:xfrm>
-          <a:prstGeom prst="rect">
-            <a:avLst/>
-          </a:prstGeom>
-          <a:noFill/>
-          <a:ln/>
-        </p:spPr>
-        <p:txBody>
-          <a:bodyPr wrap="square" lIns="0" tIns="0" rIns="0" bIns="0" rtlCol="0" anchor="ctr"/>
-          <a:lstStyle/>
-          <a:p>
-            <a:pPr indent="0" marL="0">
-              <a:buNone/>
-            </a:pPr>
-            <a:r>
-              <a:rPr lang="en-US" sz="950" i="1" dirty="0">
-                <a:solidFill>
-                  <a:srgbClr val="5C6B77"/>
-                </a:solidFill>
-                <a:latin typeface="Arial" pitchFamily="34" charset="0"/>
-                <a:ea typeface="Arial" pitchFamily="34" charset="-122"/>
-                <a:cs typeface="Arial" pitchFamily="34" charset="-120"/>
-              </a:rPr>
-              <a:t>− not everything gets captured — people adopt gradually, freed time is reinvested  (−35%)</a:t>
-            </a:r>
-            <a:endParaRPr lang="en-US" sz="950" dirty="0"/>
-          </a:p>
-        </p:txBody>
-      </p:sp>
-      <p:sp>
-        <p:nvSpPr>
-          <p:cNvPr id="39" name="Text 36"/>
-          <p:cNvSpPr txBox="1"/>
-          <p:nvPr/>
-        </p:nvSpPr>
-        <p:spPr>
-          <a:xfrm>
-            <a:off x="813816" y="5321808"/>
-            <a:ext cx="1847088" cy="237744"/>
-          </a:xfrm>
-          <a:prstGeom prst="rect">
-            <a:avLst/>
-          </a:prstGeom>
-          <a:noFill/>
-          <a:ln/>
-        </p:spPr>
-        <p:txBody>
-          <a:bodyPr wrap="square" lIns="0" tIns="0" rIns="0" bIns="0" rtlCol="0" anchor="ctr"/>
-          <a:lstStyle/>
-          <a:p>
-            <a:pPr indent="0" marL="0">
-              <a:buNone/>
-            </a:pPr>
-            <a:r>
-              <a:rPr lang="en-US" sz="1100" b="1" dirty="0">
-                <a:solidFill>
-                  <a:srgbClr val="9A5A0B"/>
-                </a:solidFill>
-                <a:latin typeface="Arial" pitchFamily="34" charset="0"/>
-                <a:ea typeface="Arial" pitchFamily="34" charset="-122"/>
-                <a:cs typeface="Arial" pitchFamily="34" charset="-120"/>
-              </a:rPr>
-              <a:t>Capturable</a:t>
-            </a:r>
-            <a:endParaRPr lang="en-US" sz="1100" dirty="0"/>
-          </a:p>
-        </p:txBody>
-      </p:sp>
-      <p:sp>
-        <p:nvSpPr>
-          <p:cNvPr id="40" name="Shape 37"/>
-          <p:cNvSpPr/>
-          <p:nvPr/>
-        </p:nvSpPr>
-        <p:spPr>
-          <a:xfrm>
-            <a:off x="2715768" y="5362956"/>
-            <a:ext cx="1116106" cy="164592"/>
+            <a:off x="2715768" y="5399532"/>
+            <a:ext cx="1109579" cy="164592"/>
           </a:xfrm>
           <a:prstGeom prst="rect">
             <a:avLst/>
@@ -2245,13 +2660,13 @@
       </p:sp>
       <p:sp>
         <p:nvSpPr>
-          <p:cNvPr id="41" name="Text 38"/>
-          <p:cNvSpPr txBox="1"/>
-          <p:nvPr/>
-        </p:nvSpPr>
-        <p:spPr>
-          <a:xfrm>
-            <a:off x="3923314" y="5321808"/>
+          <p:cNvPr id="57" name="Text 54"/>
+          <p:cNvSpPr txBox="1"/>
+          <p:nvPr/>
+        </p:nvSpPr>
+        <p:spPr>
+          <a:xfrm>
+            <a:off x="3916787" y="5358384"/>
             <a:ext cx="2011680" cy="237744"/>
           </a:xfrm>
           <a:prstGeom prst="rect">
@@ -2284,7 +2699,7 @@
       </p:sp>
       <p:sp>
         <p:nvSpPr>
-          <p:cNvPr id="42" name="Shape 39"/>
+          <p:cNvPr id="58" name="Shape 55"/>
           <p:cNvSpPr/>
           <p:nvPr/>
         </p:nvSpPr>
@@ -2304,7 +2719,7 @@
       </p:sp>
       <p:sp>
         <p:nvSpPr>
-          <p:cNvPr id="43" name="Text 40"/>
+          <p:cNvPr id="59" name="Text 56"/>
           <p:cNvSpPr txBox="1"/>
           <p:nvPr/>
         </p:nvSpPr>
@@ -2343,7 +2758,7 @@
       </p:sp>
       <p:sp>
         <p:nvSpPr>
-          <p:cNvPr id="44" name="Text 41"/>
+          <p:cNvPr id="60" name="Text 57"/>
           <p:cNvSpPr txBox="1"/>
           <p:nvPr/>
         </p:nvSpPr>
@@ -2382,7 +2797,7 @@
       </p:sp>
       <p:sp>
         <p:nvSpPr>
-          <p:cNvPr id="45" name="Text 42"/>
+          <p:cNvPr id="61" name="Text 58"/>
           <p:cNvSpPr txBox="1"/>
           <p:nvPr/>
         </p:nvSpPr>
@@ -2421,7 +2836,7 @@
       </p:sp>
       <p:sp>
         <p:nvSpPr>
-          <p:cNvPr id="46" name="Text 43"/>
+          <p:cNvPr id="62" name="Text 59"/>
           <p:cNvSpPr txBox="1"/>
           <p:nvPr/>
         </p:nvSpPr>
@@ -2474,7 +2889,7 @@
       </p:sp>
       <p:sp>
         <p:nvSpPr>
-          <p:cNvPr id="47" name="Text 44"/>
+          <p:cNvPr id="63" name="Text 60"/>
           <p:cNvSpPr txBox="1"/>
           <p:nvPr/>
         </p:nvSpPr>
@@ -2513,7 +2928,7 @@
       </p:sp>
       <p:sp>
         <p:nvSpPr>
-          <p:cNvPr id="48" name="Text 45"/>
+          <p:cNvPr id="64" name="Text 61"/>
           <p:cNvSpPr txBox="1"/>
           <p:nvPr/>
         </p:nvSpPr>
@@ -2566,7 +2981,7 @@
       </p:sp>
       <p:sp>
         <p:nvSpPr>
-          <p:cNvPr id="49" name="Text 46"/>
+          <p:cNvPr id="65" name="Text 62"/>
           <p:cNvSpPr txBox="1"/>
           <p:nvPr/>
         </p:nvSpPr>
@@ -2605,7 +3020,7 @@
       </p:sp>
       <p:sp>
         <p:nvSpPr>
-          <p:cNvPr id="50" name="Text 47"/>
+          <p:cNvPr id="66" name="Text 63"/>
           <p:cNvSpPr txBox="1"/>
           <p:nvPr/>
         </p:nvSpPr>
@@ -2658,7 +3073,7 @@
       </p:sp>
       <p:sp>
         <p:nvSpPr>
-          <p:cNvPr id="51" name="Shape 48"/>
+          <p:cNvPr id="67" name="Shape 64"/>
           <p:cNvSpPr/>
           <p:nvPr/>
         </p:nvSpPr>
@@ -2680,7 +3095,7 @@
       </p:sp>
       <p:sp>
         <p:nvSpPr>
-          <p:cNvPr id="52" name="Text 49"/>
+          <p:cNvPr id="68" name="Text 65"/>
           <p:cNvSpPr txBox="1"/>
           <p:nvPr/>
         </p:nvSpPr>
@@ -2719,7 +3134,7 @@
       </p:sp>
       <p:sp>
         <p:nvSpPr>
-          <p:cNvPr id="53" name="Text 50"/>
+          <p:cNvPr id="69" name="Text 66"/>
           <p:cNvSpPr txBox="1"/>
           <p:nvPr/>
         </p:nvSpPr>
@@ -2758,7 +3173,7 @@
       </p:sp>
       <p:sp>
         <p:nvSpPr>
-          <p:cNvPr id="54" name="Text 51"/>
+          <p:cNvPr id="70" name="Text 67"/>
           <p:cNvSpPr txBox="1"/>
           <p:nvPr/>
         </p:nvSpPr>
@@ -2825,7 +3240,7 @@
       </p:sp>
       <p:sp>
         <p:nvSpPr>
-          <p:cNvPr id="55" name="Shape 52"/>
+          <p:cNvPr id="71" name="Shape 68"/>
           <p:cNvSpPr/>
           <p:nvPr/>
         </p:nvSpPr>
@@ -2845,7 +3260,7 @@
       </p:sp>
       <p:sp>
         <p:nvSpPr>
-          <p:cNvPr id="56" name="Text 53"/>
+          <p:cNvPr id="72" name="Text 69"/>
           <p:cNvSpPr txBox="1"/>
           <p:nvPr/>
         </p:nvSpPr>
@@ -2884,7 +3299,7 @@
       </p:sp>
       <p:sp>
         <p:nvSpPr>
-          <p:cNvPr id="57" name="Text 54"/>
+          <p:cNvPr id="73" name="Text 70"/>
           <p:cNvSpPr txBox="1"/>
           <p:nvPr/>
         </p:nvSpPr>
@@ -2923,7 +3338,7 @@
       </p:sp>
       <p:sp>
         <p:nvSpPr>
-          <p:cNvPr id="58" name="Shape 55"/>
+          <p:cNvPr id="74" name="Shape 71"/>
           <p:cNvSpPr/>
           <p:nvPr/>
         </p:nvSpPr>
@@ -2943,7 +3358,7 @@
       </p:sp>
       <p:sp>
         <p:nvSpPr>
-          <p:cNvPr id="59" name="Text 56"/>
+          <p:cNvPr id="75" name="Text 72"/>
           <p:cNvSpPr txBox="1"/>
           <p:nvPr/>
         </p:nvSpPr>
@@ -2982,7 +3397,7 @@
       </p:sp>
       <p:sp>
         <p:nvSpPr>
-          <p:cNvPr id="60" name="Text 57"/>
+          <p:cNvPr id="76" name="Text 73"/>
           <p:cNvSpPr txBox="1"/>
           <p:nvPr/>
         </p:nvSpPr>
@@ -3021,7 +3436,7 @@
       </p:sp>
       <p:sp>
         <p:nvSpPr>
-          <p:cNvPr id="61" name="Shape 58"/>
+          <p:cNvPr id="77" name="Shape 74"/>
           <p:cNvSpPr/>
           <p:nvPr/>
         </p:nvSpPr>
@@ -3041,7 +3456,7 @@
       </p:sp>
       <p:sp>
         <p:nvSpPr>
-          <p:cNvPr id="62" name="Text 59"/>
+          <p:cNvPr id="78" name="Text 75"/>
           <p:cNvSpPr txBox="1"/>
           <p:nvPr/>
         </p:nvSpPr>
@@ -3080,7 +3495,7 @@
       </p:sp>
       <p:sp>
         <p:nvSpPr>
-          <p:cNvPr id="63" name="Text 60"/>
+          <p:cNvPr id="79" name="Text 76"/>
           <p:cNvSpPr txBox="1"/>
           <p:nvPr/>
         </p:nvSpPr>
@@ -3119,7 +3534,7 @@
       </p:sp>
       <p:sp>
         <p:nvSpPr>
-          <p:cNvPr id="64" name="Shape 61"/>
+          <p:cNvPr id="80" name="Shape 77"/>
           <p:cNvSpPr/>
           <p:nvPr/>
         </p:nvSpPr>
@@ -3139,7 +3554,7 @@
       </p:sp>
       <p:sp>
         <p:nvSpPr>
-          <p:cNvPr id="65" name="Text 62"/>
+          <p:cNvPr id="81" name="Text 78"/>
           <p:cNvSpPr txBox="1"/>
           <p:nvPr/>
         </p:nvSpPr>
@@ -3178,7 +3593,7 @@
       </p:sp>
       <p:sp>
         <p:nvSpPr>
-          <p:cNvPr id="66" name="Text 63"/>
+          <p:cNvPr id="82" name="Text 79"/>
           <p:cNvSpPr txBox="1"/>
           <p:nvPr/>
         </p:nvSpPr>
@@ -3217,7 +3632,7 @@
       </p:sp>
       <p:sp>
         <p:nvSpPr>
-          <p:cNvPr id="67" name="Text 64"/>
+          <p:cNvPr id="83" name="Text 80"/>
           <p:cNvSpPr txBox="1"/>
           <p:nvPr/>
         </p:nvSpPr>
@@ -3256,7 +3671,7 @@
       </p:sp>
       <p:sp>
         <p:nvSpPr>
-          <p:cNvPr id="68" name="Text 65"/>
+          <p:cNvPr id="84" name="Text 81"/>
           <p:cNvSpPr txBox="1"/>
           <p:nvPr/>
         </p:nvSpPr>
@@ -3295,7 +3710,7 @@
       </p:sp>
       <p:sp>
         <p:nvSpPr>
-          <p:cNvPr id="69" name="Text 66"/>
+          <p:cNvPr id="85" name="Text 82"/>
           <p:cNvSpPr txBox="1"/>
           <p:nvPr/>
         </p:nvSpPr>
@@ -3334,7 +3749,7 @@
       </p:sp>
       <p:sp>
         <p:nvSpPr>
-          <p:cNvPr id="70" name="Text 67"/>
+          <p:cNvPr id="86" name="Text 83"/>
           <p:cNvSpPr txBox="1"/>
           <p:nvPr/>
         </p:nvSpPr>
@@ -3373,7 +3788,7 @@
       </p:sp>
       <p:sp>
         <p:nvSpPr>
-          <p:cNvPr id="71" name="Text 68"/>
+          <p:cNvPr id="87" name="Text 84"/>
           <p:cNvSpPr txBox="1"/>
           <p:nvPr/>
         </p:nvSpPr>
@@ -3412,7 +3827,7 @@
       </p:sp>
       <p:sp>
         <p:nvSpPr>
-          <p:cNvPr id="72" name="Text 69"/>
+          <p:cNvPr id="88" name="Text 85"/>
           <p:cNvSpPr txBox="1"/>
           <p:nvPr/>
         </p:nvSpPr>
@@ -3451,7 +3866,7 @@
       </p:sp>
       <p:sp>
         <p:nvSpPr>
-          <p:cNvPr id="73" name="Text 70"/>
+          <p:cNvPr id="89" name="Text 86"/>
           <p:cNvSpPr txBox="1"/>
           <p:nvPr/>
         </p:nvSpPr>
@@ -3490,7 +3905,7 @@
       </p:sp>
       <p:sp>
         <p:nvSpPr>
-          <p:cNvPr id="74" name="Shape 71"/>
+          <p:cNvPr id="90" name="Shape 87"/>
           <p:cNvSpPr/>
           <p:nvPr/>
         </p:nvSpPr>
@@ -3513,7 +3928,7 @@
       </p:sp>
       <p:sp>
         <p:nvSpPr>
-          <p:cNvPr id="75" name="Text 72"/>
+          <p:cNvPr id="91" name="Text 88"/>
           <p:cNvSpPr txBox="1"/>
           <p:nvPr/>
         </p:nvSpPr>
@@ -3580,7 +3995,7 @@
       </p:sp>
       <p:sp>
         <p:nvSpPr>
-          <p:cNvPr id="76" name="Text 73"/>
+          <p:cNvPr id="92" name="Text 89"/>
           <p:cNvSpPr txBox="1"/>
           <p:nvPr/>
         </p:nvSpPr>
@@ -3619,7 +4034,7 @@
       </p:sp>
       <p:sp>
         <p:nvSpPr>
-          <p:cNvPr id="77" name="Text 74"/>
+          <p:cNvPr id="93" name="Text 90"/>
           <p:cNvSpPr txBox="1"/>
           <p:nvPr/>
         </p:nvSpPr>
@@ -3658,7 +4073,7 @@
       </p:sp>
       <p:sp>
         <p:nvSpPr>
-          <p:cNvPr id="78" name="Text 75"/>
+          <p:cNvPr id="94" name="Text 91"/>
           <p:cNvSpPr txBox="1"/>
           <p:nvPr/>
         </p:nvSpPr>
@@ -3697,7 +4112,7 @@
       </p:sp>
       <p:sp>
         <p:nvSpPr>
-          <p:cNvPr id="79" name="Text 76"/>
+          <p:cNvPr id="95" name="Text 92"/>
           <p:cNvSpPr txBox="1"/>
           <p:nvPr/>
         </p:nvSpPr>
@@ -3736,7 +4151,7 @@
       </p:sp>
       <p:sp>
         <p:nvSpPr>
-          <p:cNvPr id="80" name="Text 77"/>
+          <p:cNvPr id="96" name="Text 93"/>
           <p:cNvSpPr txBox="1"/>
           <p:nvPr/>
         </p:nvSpPr>
@@ -3775,7 +4190,7 @@
       </p:sp>
       <p:sp>
         <p:nvSpPr>
-          <p:cNvPr id="81" name="Text 78"/>
+          <p:cNvPr id="97" name="Text 94"/>
           <p:cNvSpPr txBox="1"/>
           <p:nvPr/>
         </p:nvSpPr>
@@ -3814,7 +4229,7 @@
       </p:sp>
       <p:sp>
         <p:nvSpPr>
-          <p:cNvPr id="82" name="Text 79"/>
+          <p:cNvPr id="98" name="Text 95"/>
           <p:cNvSpPr txBox="1"/>
           <p:nvPr/>
         </p:nvSpPr>
@@ -3853,7 +4268,7 @@
       </p:sp>
       <p:sp>
         <p:nvSpPr>
-          <p:cNvPr id="83" name="Text 80"/>
+          <p:cNvPr id="99" name="Text 96"/>
           <p:cNvSpPr txBox="1"/>
           <p:nvPr/>
         </p:nvSpPr>
@@ -3884,7 +4299,7 @@
                 <a:ea typeface="Arial" pitchFamily="34" charset="-122"/>
                 <a:cs typeface="Arial" pitchFamily="34" charset="-120"/>
               </a:rPr>
-              <a:t>Illustrative — a walkthrough of the method, not a plan of record. Detailed assumptions: backup slide.</a:t>
+              <a:t>Illustrative — a walkthrough of the method, not a plan of record. Pools rounded to $0.1M. Detailed assumptions: backup slide.</a:t>
             </a:r>
             <a:endParaRPr lang="en-US" sz="800" dirty="0"/>
           </a:p>

</xml_diff>

<commit_message>
Keep three activities; make the funnel start from their own sum
The three example pools now use clean teaching numbers (3+2+1 = 6M)
and stack into the funnel's opening bar in the same colors, so steps
2-4 form one self-contained chain: map, add up, haircut, prioritize.

Co-Authored-By: Claude <noreply@anthropic.com>
Claude-Session: https://claude.ai/code/session_01NFmLfQt1gGoL7VkhSjRDgY
</commit_message>
<xml_diff>
--- a/docs/sizing-example/ds-sizing-example.pptx
+++ b/docs/sizing-example/ds-sizing-example.pptx
@@ -503,7 +503,7 @@
           <a:p>
             <a:r>
               <a:rPr lang="en-US" dirty="0"/>
-              <a:t>Worked example: how to size an AI business case bottom-up. Left: cost base -&gt; map the week -&gt; haircut to capturable -&gt; prioritize. Right: what the first build costs, one-time and recurring. All numbers illustrative.</a:t>
+              <a:t>Worked example: how to size an AI business case bottom-up, using three activities to keep it simple. Left: cost base -&gt; map the week -&gt; add the pools and haircut -&gt; prioritize. Right: what the first build costs, one-time and recurring. All numbers illustrative.</a:t>
             </a:r>
             <a:endParaRPr lang="en-US" dirty="0"/>
           </a:p>
@@ -1036,7 +1036,7 @@
                 <a:ea typeface="Arial" pitchFamily="34" charset="-122"/>
                 <a:cs typeface="Arial" pitchFamily="34" charset="-120"/>
               </a:rPr>
-              <a:t>Data scientists: a $38M cost base yields </a:t>
+              <a:t>Data scientists: three activities yield </a:t>
             </a:r>
             <a:pPr indent="0" marL="0">
               <a:buNone/>
@@ -1050,7 +1050,7 @@
                 <a:ea typeface="Arial" pitchFamily="34" charset="-122"/>
                 <a:cs typeface="Arial" pitchFamily="34" charset="-120"/>
               </a:rPr>
-              <a:t>~$8.3M capturable</a:t>
+              <a:t>~$3M capturable</a:t>
             </a:r>
             <a:pPr indent="0" marL="0">
               <a:buNone/>
@@ -1290,7 +1290,7 @@
         </p:nvSpPr>
         <p:spPr>
           <a:xfrm>
-            <a:off x="502920" y="2121408"/>
+            <a:off x="502920" y="2139696"/>
             <a:ext cx="219456" cy="219456"/>
           </a:xfrm>
           <a:prstGeom prst="ellipse">
@@ -1310,7 +1310,7 @@
         </p:nvSpPr>
         <p:spPr>
           <a:xfrm>
-            <a:off x="502920" y="2121408"/>
+            <a:off x="502920" y="2139696"/>
             <a:ext cx="219456" cy="219456"/>
           </a:xfrm>
           <a:prstGeom prst="rect">
@@ -1349,7 +1349,7 @@
         </p:nvSpPr>
         <p:spPr>
           <a:xfrm>
-            <a:off x="813816" y="2103120"/>
+            <a:off x="813816" y="2121408"/>
             <a:ext cx="5486400" cy="256032"/>
           </a:xfrm>
           <a:prstGeom prst="rect">
@@ -1388,7 +1388,7 @@
         </p:nvSpPr>
         <p:spPr>
           <a:xfrm>
-            <a:off x="813816" y="2340864"/>
+            <a:off x="813816" y="2377440"/>
             <a:ext cx="5486400" cy="182880"/>
           </a:xfrm>
           <a:prstGeom prst="rect">
@@ -1427,24 +1427,24 @@
         </p:nvSpPr>
         <p:spPr>
           <a:xfrm>
-            <a:off x="813816" y="2542032"/>
-            <a:ext cx="1847088" cy="237744"/>
-          </a:xfrm>
-          <a:prstGeom prst="rect">
-            <a:avLst/>
-          </a:prstGeom>
-          <a:noFill/>
-          <a:ln/>
-        </p:spPr>
-        <p:txBody>
-          <a:bodyPr wrap="square" lIns="0" tIns="0" rIns="0" bIns="0" rtlCol="0" anchor="ctr"/>
-          <a:lstStyle/>
-          <a:p>
-            <a:pPr indent="0" marL="0">
-              <a:buNone/>
-            </a:pPr>
-            <a:r>
-              <a:rPr lang="en-US" sz="1050" dirty="0">
+            <a:off x="813816" y="2633472"/>
+            <a:ext cx="1847088" cy="310896"/>
+          </a:xfrm>
+          <a:prstGeom prst="rect">
+            <a:avLst/>
+          </a:prstGeom>
+          <a:noFill/>
+          <a:ln/>
+        </p:spPr>
+        <p:txBody>
+          <a:bodyPr wrap="square" lIns="0" tIns="0" rIns="0" bIns="0" rtlCol="0" anchor="ctr"/>
+          <a:lstStyle/>
+          <a:p>
+            <a:pPr indent="0" marL="0">
+              <a:buNone/>
+            </a:pPr>
+            <a:r>
+              <a:rPr lang="en-US" sz="1250" dirty="0">
                 <a:solidFill>
                   <a:srgbClr val="1F2A33"/>
                 </a:solidFill>
@@ -1454,7 +1454,7 @@
               </a:rPr>
               <a:t>Data prep &amp; cleaning</a:t>
             </a:r>
-            <a:endParaRPr lang="en-US" sz="1050" dirty="0"/>
+            <a:endParaRPr lang="en-US" sz="1250" dirty="0"/>
           </a:p>
         </p:txBody>
       </p:sp>
@@ -1466,8 +1466,8 @@
         </p:nvSpPr>
         <p:spPr>
           <a:xfrm>
-            <a:off x="2715768" y="2592324"/>
-            <a:ext cx="2286000" cy="146304"/>
+            <a:off x="2715768" y="2688336"/>
+            <a:ext cx="2286000" cy="201168"/>
           </a:xfrm>
           <a:prstGeom prst="rect">
             <a:avLst/>
@@ -1486,8 +1486,8 @@
         </p:nvSpPr>
         <p:spPr>
           <a:xfrm>
-            <a:off x="2715768" y="2592324"/>
-            <a:ext cx="1371600" cy="146304"/>
+            <a:off x="2715768" y="2688336"/>
+            <a:ext cx="1371600" cy="201168"/>
           </a:xfrm>
           <a:prstGeom prst="rect">
             <a:avLst/>
@@ -1506,24 +1506,24 @@
         </p:nvSpPr>
         <p:spPr>
           <a:xfrm>
-            <a:off x="5093208" y="2542032"/>
-            <a:ext cx="868680" cy="237744"/>
-          </a:xfrm>
-          <a:prstGeom prst="rect">
-            <a:avLst/>
-          </a:prstGeom>
-          <a:noFill/>
-          <a:ln/>
-        </p:spPr>
-        <p:txBody>
-          <a:bodyPr wrap="square" lIns="0" tIns="0" rIns="0" bIns="0" rtlCol="0" anchor="ctr"/>
-          <a:lstStyle/>
-          <a:p>
-            <a:pPr indent="0" marL="0">
-              <a:buNone/>
-            </a:pPr>
-            <a:r>
-              <a:rPr lang="en-US" sz="1100" b="1" dirty="0">
+            <a:off x="5111496" y="2633472"/>
+            <a:ext cx="868680" cy="310896"/>
+          </a:xfrm>
+          <a:prstGeom prst="rect">
+            <a:avLst/>
+          </a:prstGeom>
+          <a:noFill/>
+          <a:ln/>
+        </p:spPr>
+        <p:txBody>
+          <a:bodyPr wrap="square" lIns="0" tIns="0" rIns="0" bIns="0" rtlCol="0" anchor="ctr"/>
+          <a:lstStyle/>
+          <a:p>
+            <a:pPr indent="0" marL="0">
+              <a:buNone/>
+            </a:pPr>
+            <a:r>
+              <a:rPr lang="en-US" sz="1300" b="1" dirty="0">
                 <a:solidFill>
                   <a:srgbClr val="0B6B5D"/>
                 </a:solidFill>
@@ -1531,9 +1531,9 @@
                 <a:ea typeface="Arial" pitchFamily="34" charset="-122"/>
                 <a:cs typeface="Arial" pitchFamily="34" charset="-120"/>
               </a:rPr>
-              <a:t>$6.8M</a:t>
-            </a:r>
-            <a:endParaRPr lang="en-US" sz="1100" dirty="0"/>
+              <a:t>$3M</a:t>
+            </a:r>
+            <a:endParaRPr lang="en-US" sz="1300" dirty="0"/>
           </a:p>
         </p:txBody>
       </p:sp>
@@ -1545,24 +1545,24 @@
         </p:nvSpPr>
         <p:spPr>
           <a:xfrm>
-            <a:off x="813816" y="2807208"/>
-            <a:ext cx="1847088" cy="237744"/>
-          </a:xfrm>
-          <a:prstGeom prst="rect">
-            <a:avLst/>
-          </a:prstGeom>
-          <a:noFill/>
-          <a:ln/>
-        </p:spPr>
-        <p:txBody>
-          <a:bodyPr wrap="square" lIns="0" tIns="0" rIns="0" bIns="0" rtlCol="0" anchor="ctr"/>
-          <a:lstStyle/>
-          <a:p>
-            <a:pPr indent="0" marL="0">
-              <a:buNone/>
-            </a:pPr>
-            <a:r>
-              <a:rPr lang="en-US" sz="1050" dirty="0">
+            <a:off x="813816" y="3054096"/>
+            <a:ext cx="1847088" cy="310896"/>
+          </a:xfrm>
+          <a:prstGeom prst="rect">
+            <a:avLst/>
+          </a:prstGeom>
+          <a:noFill/>
+          <a:ln/>
+        </p:spPr>
+        <p:txBody>
+          <a:bodyPr wrap="square" lIns="0" tIns="0" rIns="0" bIns="0" rtlCol="0" anchor="ctr"/>
+          <a:lstStyle/>
+          <a:p>
+            <a:pPr indent="0" marL="0">
+              <a:buNone/>
+            </a:pPr>
+            <a:r>
+              <a:rPr lang="en-US" sz="1250" dirty="0">
                 <a:solidFill>
                   <a:srgbClr val="1F2A33"/>
                 </a:solidFill>
@@ -1570,9 +1570,9 @@
                 <a:ea typeface="Arial" pitchFamily="34" charset="-122"/>
                 <a:cs typeface="Arial" pitchFamily="34" charset="-120"/>
               </a:rPr>
-              <a:t>Model build &amp; experiments</a:t>
-            </a:r>
-            <a:endParaRPr lang="en-US" sz="1050" dirty="0"/>
+              <a:t>Exploratory analysis</a:t>
+            </a:r>
+            <a:endParaRPr lang="en-US" sz="1250" dirty="0"/>
           </a:p>
         </p:txBody>
       </p:sp>
@@ -1584,8 +1584,8 @@
         </p:nvSpPr>
         <p:spPr>
           <a:xfrm>
-            <a:off x="2715768" y="2857500"/>
-            <a:ext cx="1524000" cy="146304"/>
+            <a:off x="2715768" y="3108960"/>
+            <a:ext cx="1143000" cy="201168"/>
           </a:xfrm>
           <a:prstGeom prst="rect">
             <a:avLst/>
@@ -1604,8 +1604,8 @@
         </p:nvSpPr>
         <p:spPr>
           <a:xfrm>
-            <a:off x="2715768" y="2857500"/>
-            <a:ext cx="533400" cy="146304"/>
+            <a:off x="2715768" y="3108960"/>
+            <a:ext cx="457200" cy="201168"/>
           </a:xfrm>
           <a:prstGeom prst="rect">
             <a:avLst/>
@@ -1624,24 +1624,24 @@
         </p:nvSpPr>
         <p:spPr>
           <a:xfrm>
-            <a:off x="4331208" y="2807208"/>
-            <a:ext cx="868680" cy="237744"/>
-          </a:xfrm>
-          <a:prstGeom prst="rect">
-            <a:avLst/>
-          </a:prstGeom>
-          <a:noFill/>
-          <a:ln/>
-        </p:spPr>
-        <p:txBody>
-          <a:bodyPr wrap="square" lIns="0" tIns="0" rIns="0" bIns="0" rtlCol="0" anchor="ctr"/>
-          <a:lstStyle/>
-          <a:p>
-            <a:pPr indent="0" marL="0">
-              <a:buNone/>
-            </a:pPr>
-            <a:r>
-              <a:rPr lang="en-US" sz="1100" b="1" dirty="0">
+            <a:off x="3968496" y="3054096"/>
+            <a:ext cx="868680" cy="310896"/>
+          </a:xfrm>
+          <a:prstGeom prst="rect">
+            <a:avLst/>
+          </a:prstGeom>
+          <a:noFill/>
+          <a:ln/>
+        </p:spPr>
+        <p:txBody>
+          <a:bodyPr wrap="square" lIns="0" tIns="0" rIns="0" bIns="0" rtlCol="0" anchor="ctr"/>
+          <a:lstStyle/>
+          <a:p>
+            <a:pPr indent="0" marL="0">
+              <a:buNone/>
+            </a:pPr>
+            <a:r>
+              <a:rPr lang="en-US" sz="1300" b="1" dirty="0">
                 <a:solidFill>
                   <a:srgbClr val="9A5A0B"/>
                 </a:solidFill>
@@ -1649,9 +1649,9 @@
                 <a:ea typeface="Arial" pitchFamily="34" charset="-122"/>
                 <a:cs typeface="Arial" pitchFamily="34" charset="-120"/>
               </a:rPr>
-              <a:t>$2.7M</a:t>
-            </a:r>
-            <a:endParaRPr lang="en-US" sz="1100" dirty="0"/>
+              <a:t>$2M</a:t>
+            </a:r>
+            <a:endParaRPr lang="en-US" sz="1300" dirty="0"/>
           </a:p>
         </p:txBody>
       </p:sp>
@@ -1663,24 +1663,24 @@
         </p:nvSpPr>
         <p:spPr>
           <a:xfrm>
-            <a:off x="813816" y="3072384"/>
-            <a:ext cx="1847088" cy="237744"/>
-          </a:xfrm>
-          <a:prstGeom prst="rect">
-            <a:avLst/>
-          </a:prstGeom>
-          <a:noFill/>
-          <a:ln/>
-        </p:spPr>
-        <p:txBody>
-          <a:bodyPr wrap="square" lIns="0" tIns="0" rIns="0" bIns="0" rtlCol="0" anchor="ctr"/>
-          <a:lstStyle/>
-          <a:p>
-            <a:pPr indent="0" marL="0">
-              <a:buNone/>
-            </a:pPr>
-            <a:r>
-              <a:rPr lang="en-US" sz="1050" dirty="0">
+            <a:off x="813816" y="3474720"/>
+            <a:ext cx="1847088" cy="310896"/>
+          </a:xfrm>
+          <a:prstGeom prst="rect">
+            <a:avLst/>
+          </a:prstGeom>
+          <a:noFill/>
+          <a:ln/>
+        </p:spPr>
+        <p:txBody>
+          <a:bodyPr wrap="square" lIns="0" tIns="0" rIns="0" bIns="0" rtlCol="0" anchor="ctr"/>
+          <a:lstStyle/>
+          <a:p>
+            <a:pPr indent="0" marL="0">
+              <a:buNone/>
+            </a:pPr>
+            <a:r>
+              <a:rPr lang="en-US" sz="1250" dirty="0">
                 <a:solidFill>
                   <a:srgbClr val="1F2A33"/>
                 </a:solidFill>
@@ -1688,9 +1688,9 @@
                 <a:ea typeface="Arial" pitchFamily="34" charset="-122"/>
                 <a:cs typeface="Arial" pitchFamily="34" charset="-120"/>
               </a:rPr>
-              <a:t>Exploratory analysis</a:t>
-            </a:r>
-            <a:endParaRPr lang="en-US" sz="1050" dirty="0"/>
+              <a:t>Stakeholder alignment</a:t>
+            </a:r>
+            <a:endParaRPr lang="en-US" sz="1250" dirty="0"/>
           </a:p>
         </p:txBody>
       </p:sp>
@@ -1702,14 +1702,14 @@
         </p:nvSpPr>
         <p:spPr>
           <a:xfrm>
-            <a:off x="2715768" y="3122676"/>
-            <a:ext cx="1143000" cy="146304"/>
+            <a:off x="2715768" y="3529584"/>
+            <a:ext cx="914400" cy="201168"/>
           </a:xfrm>
           <a:prstGeom prst="rect">
             <a:avLst/>
           </a:prstGeom>
           <a:solidFill>
-            <a:srgbClr val="EFD9B8"/>
+            <a:srgbClr val="EBD3D6"/>
           </a:solidFill>
           <a:ln/>
         </p:spPr>
@@ -1722,8 +1722,224 @@
         </p:nvSpPr>
         <p:spPr>
           <a:xfrm>
-            <a:off x="2715768" y="3122676"/>
-            <a:ext cx="457200" cy="146304"/>
+            <a:off x="2715768" y="3529584"/>
+            <a:ext cx="91440" cy="201168"/>
+          </a:xfrm>
+          <a:prstGeom prst="rect">
+            <a:avLst/>
+          </a:prstGeom>
+          <a:solidFill>
+            <a:srgbClr val="9A4E58"/>
+          </a:solidFill>
+          <a:ln/>
+        </p:spPr>
+      </p:sp>
+      <p:sp>
+        <p:nvSpPr>
+          <p:cNvPr id="26" name="Text 23"/>
+          <p:cNvSpPr txBox="1"/>
+          <p:nvPr/>
+        </p:nvSpPr>
+        <p:spPr>
+          <a:xfrm>
+            <a:off x="3739896" y="3474720"/>
+            <a:ext cx="868680" cy="310896"/>
+          </a:xfrm>
+          <a:prstGeom prst="rect">
+            <a:avLst/>
+          </a:prstGeom>
+          <a:noFill/>
+          <a:ln/>
+        </p:spPr>
+        <p:txBody>
+          <a:bodyPr wrap="square" lIns="0" tIns="0" rIns="0" bIns="0" rtlCol="0" anchor="ctr"/>
+          <a:lstStyle/>
+          <a:p>
+            <a:pPr indent="0" marL="0">
+              <a:buNone/>
+            </a:pPr>
+            <a:r>
+              <a:rPr lang="en-US" sz="1300" b="1" dirty="0">
+                <a:solidFill>
+                  <a:srgbClr val="9A4E58"/>
+                </a:solidFill>
+                <a:latin typeface="Arial" pitchFamily="34" charset="0"/>
+                <a:ea typeface="Arial" pitchFamily="34" charset="-122"/>
+                <a:cs typeface="Arial" pitchFamily="34" charset="-120"/>
+              </a:rPr>
+              <a:t>$1M</a:t>
+            </a:r>
+            <a:endParaRPr lang="en-US" sz="1300" dirty="0"/>
+          </a:p>
+        </p:txBody>
+      </p:sp>
+      <p:sp>
+        <p:nvSpPr>
+          <p:cNvPr id="27" name="Shape 24"/>
+          <p:cNvSpPr/>
+          <p:nvPr/>
+        </p:nvSpPr>
+        <p:spPr>
+          <a:xfrm>
+            <a:off x="502920" y="4133088"/>
+            <a:ext cx="219456" cy="219456"/>
+          </a:xfrm>
+          <a:prstGeom prst="ellipse">
+            <a:avLst/>
+          </a:prstGeom>
+          <a:solidFill>
+            <a:srgbClr val="0B6B5D"/>
+          </a:solidFill>
+          <a:ln/>
+        </p:spPr>
+      </p:sp>
+      <p:sp>
+        <p:nvSpPr>
+          <p:cNvPr id="28" name="Text 25"/>
+          <p:cNvSpPr txBox="1"/>
+          <p:nvPr/>
+        </p:nvSpPr>
+        <p:spPr>
+          <a:xfrm>
+            <a:off x="502920" y="4133088"/>
+            <a:ext cx="219456" cy="219456"/>
+          </a:xfrm>
+          <a:prstGeom prst="rect">
+            <a:avLst/>
+          </a:prstGeom>
+          <a:noFill/>
+          <a:ln/>
+        </p:spPr>
+        <p:txBody>
+          <a:bodyPr wrap="square" lIns="0" tIns="0" rIns="0" bIns="0" rtlCol="0" anchor="ctr"/>
+          <a:lstStyle/>
+          <a:p>
+            <a:pPr algn="ctr" indent="0" marL="0">
+              <a:buNone/>
+            </a:pPr>
+            <a:r>
+              <a:rPr lang="en-US" sz="1100" b="1" dirty="0">
+                <a:solidFill>
+                  <a:srgbClr val="FFFFFF"/>
+                </a:solidFill>
+                <a:latin typeface="Arial" pitchFamily="34" charset="0"/>
+                <a:ea typeface="Arial" pitchFamily="34" charset="-122"/>
+                <a:cs typeface="Arial" pitchFamily="34" charset="-120"/>
+              </a:rPr>
+              <a:t>3</a:t>
+            </a:r>
+            <a:endParaRPr lang="en-US" sz="1100" dirty="0"/>
+          </a:p>
+        </p:txBody>
+      </p:sp>
+      <p:sp>
+        <p:nvSpPr>
+          <p:cNvPr id="29" name="Text 26"/>
+          <p:cNvSpPr txBox="1"/>
+          <p:nvPr/>
+        </p:nvSpPr>
+        <p:spPr>
+          <a:xfrm>
+            <a:off x="813816" y="4114800"/>
+            <a:ext cx="5486400" cy="256032"/>
+          </a:xfrm>
+          <a:prstGeom prst="rect">
+            <a:avLst/>
+          </a:prstGeom>
+          <a:noFill/>
+          <a:ln/>
+        </p:spPr>
+        <p:txBody>
+          <a:bodyPr wrap="square" lIns="0" tIns="0" rIns="0" bIns="0" rtlCol="0" anchor="ctr"/>
+          <a:lstStyle/>
+          <a:p>
+            <a:pPr indent="0" marL="0">
+              <a:buNone/>
+            </a:pPr>
+            <a:r>
+              <a:rPr lang="en-US" sz="1350" b="1" dirty="0">
+                <a:solidFill>
+                  <a:srgbClr val="1F2A33"/>
+                </a:solidFill>
+                <a:latin typeface="Arial" pitchFamily="34" charset="0"/>
+                <a:ea typeface="Arial" pitchFamily="34" charset="-122"/>
+                <a:cs typeface="Arial" pitchFamily="34" charset="-120"/>
+              </a:rPr>
+              <a:t>Add the pools up — then haircut to what you can capture</a:t>
+            </a:r>
+            <a:endParaRPr lang="en-US" sz="1350" dirty="0"/>
+          </a:p>
+        </p:txBody>
+      </p:sp>
+      <p:sp>
+        <p:nvSpPr>
+          <p:cNvPr id="30" name="Text 27"/>
+          <p:cNvSpPr txBox="1"/>
+          <p:nvPr/>
+        </p:nvSpPr>
+        <p:spPr>
+          <a:xfrm>
+            <a:off x="813816" y="4407408"/>
+            <a:ext cx="1847088" cy="237744"/>
+          </a:xfrm>
+          <a:prstGeom prst="rect">
+            <a:avLst/>
+          </a:prstGeom>
+          <a:noFill/>
+          <a:ln/>
+        </p:spPr>
+        <p:txBody>
+          <a:bodyPr wrap="square" lIns="0" tIns="0" rIns="0" bIns="0" rtlCol="0" anchor="ctr"/>
+          <a:lstStyle/>
+          <a:p>
+            <a:pPr indent="0" marL="0">
+              <a:buNone/>
+            </a:pPr>
+            <a:r>
+              <a:rPr lang="en-US" sz="1100" dirty="0">
+                <a:solidFill>
+                  <a:srgbClr val="1F2A33"/>
+                </a:solidFill>
+                <a:latin typeface="Arial" pitchFamily="34" charset="0"/>
+                <a:ea typeface="Arial" pitchFamily="34" charset="-122"/>
+                <a:cs typeface="Arial" pitchFamily="34" charset="-120"/>
+              </a:rPr>
+              <a:t>The three pools together</a:t>
+            </a:r>
+            <a:endParaRPr lang="en-US" sz="1100" dirty="0"/>
+          </a:p>
+        </p:txBody>
+      </p:sp>
+      <p:sp>
+        <p:nvSpPr>
+          <p:cNvPr id="31" name="Shape 28"/>
+          <p:cNvSpPr/>
+          <p:nvPr/>
+        </p:nvSpPr>
+        <p:spPr>
+          <a:xfrm>
+            <a:off x="2715768" y="4448556"/>
+            <a:ext cx="1124712" cy="164592"/>
+          </a:xfrm>
+          <a:prstGeom prst="rect">
+            <a:avLst/>
+          </a:prstGeom>
+          <a:solidFill>
+            <a:srgbClr val="0B6B5D"/>
+          </a:solidFill>
+          <a:ln/>
+        </p:spPr>
+      </p:sp>
+      <p:sp>
+        <p:nvSpPr>
+          <p:cNvPr id="32" name="Shape 29"/>
+          <p:cNvSpPr/>
+          <p:nvPr/>
+        </p:nvSpPr>
+        <p:spPr>
+          <a:xfrm>
+            <a:off x="3858768" y="4448556"/>
+            <a:ext cx="743712" cy="164592"/>
           </a:xfrm>
           <a:prstGeom prst="rect">
             <a:avLst/>
@@ -1736,14 +1952,249 @@
       </p:sp>
       <p:sp>
         <p:nvSpPr>
-          <p:cNvPr id="26" name="Text 23"/>
-          <p:cNvSpPr txBox="1"/>
-          <p:nvPr/>
-        </p:nvSpPr>
-        <p:spPr>
-          <a:xfrm>
-            <a:off x="3950208" y="3072384"/>
-            <a:ext cx="868680" cy="237744"/>
+          <p:cNvPr id="33" name="Shape 30"/>
+          <p:cNvSpPr/>
+          <p:nvPr/>
+        </p:nvSpPr>
+        <p:spPr>
+          <a:xfrm>
+            <a:off x="4620768" y="4448556"/>
+            <a:ext cx="362712" cy="164592"/>
+          </a:xfrm>
+          <a:prstGeom prst="rect">
+            <a:avLst/>
+          </a:prstGeom>
+          <a:solidFill>
+            <a:srgbClr val="9A4E58"/>
+          </a:solidFill>
+          <a:ln/>
+        </p:spPr>
+      </p:sp>
+      <p:sp>
+        <p:nvSpPr>
+          <p:cNvPr id="34" name="Text 31"/>
+          <p:cNvSpPr txBox="1"/>
+          <p:nvPr/>
+        </p:nvSpPr>
+        <p:spPr>
+          <a:xfrm>
+            <a:off x="5074920" y="4407408"/>
+            <a:ext cx="2011680" cy="237744"/>
+          </a:xfrm>
+          <a:prstGeom prst="rect">
+            <a:avLst/>
+          </a:prstGeom>
+          <a:noFill/>
+          <a:ln/>
+        </p:spPr>
+        <p:txBody>
+          <a:bodyPr wrap="square" lIns="0" tIns="0" rIns="0" bIns="0" rtlCol="0" anchor="ctr"/>
+          <a:lstStyle/>
+          <a:p>
+            <a:pPr indent="0" marL="0">
+              <a:buNone/>
+            </a:pPr>
+            <a:r>
+              <a:rPr lang="en-US" sz="1150" b="1" dirty="0">
+                <a:solidFill>
+                  <a:srgbClr val="0B6B5D"/>
+                </a:solidFill>
+                <a:latin typeface="Arial" pitchFamily="34" charset="0"/>
+                <a:ea typeface="Arial" pitchFamily="34" charset="-122"/>
+                <a:cs typeface="Arial" pitchFamily="34" charset="-120"/>
+              </a:rPr>
+              <a:t>$6M</a:t>
+            </a:r>
+            <a:endParaRPr lang="en-US" sz="1150" dirty="0"/>
+          </a:p>
+        </p:txBody>
+      </p:sp>
+      <p:sp>
+        <p:nvSpPr>
+          <p:cNvPr id="35" name="Text 32"/>
+          <p:cNvSpPr txBox="1"/>
+          <p:nvPr/>
+        </p:nvSpPr>
+        <p:spPr>
+          <a:xfrm>
+            <a:off x="1527048" y="4663440"/>
+            <a:ext cx="4937760" cy="182880"/>
+          </a:xfrm>
+          <a:prstGeom prst="rect">
+            <a:avLst/>
+          </a:prstGeom>
+          <a:noFill/>
+          <a:ln/>
+        </p:spPr>
+        <p:txBody>
+          <a:bodyPr wrap="square" lIns="0" tIns="0" rIns="0" bIns="0" rtlCol="0" anchor="ctr"/>
+          <a:lstStyle/>
+          <a:p>
+            <a:pPr indent="0" marL="0">
+              <a:buNone/>
+            </a:pPr>
+            <a:r>
+              <a:rPr lang="en-US" sz="950" i="1" dirty="0">
+                <a:solidFill>
+                  <a:srgbClr val="5C6B77"/>
+                </a:solidFill>
+                <a:latin typeface="Arial" pitchFamily="34" charset="0"/>
+                <a:ea typeface="Arial" pitchFamily="34" charset="-122"/>
+                <a:cs typeface="Arial" pitchFamily="34" charset="-120"/>
+              </a:rPr>
+              <a:t>− you already cover some of this today — tools in place, learned via interviews  (−25%)</a:t>
+            </a:r>
+            <a:endParaRPr lang="en-US" sz="950" dirty="0"/>
+          </a:p>
+        </p:txBody>
+      </p:sp>
+      <p:sp>
+        <p:nvSpPr>
+          <p:cNvPr id="36" name="Text 33"/>
+          <p:cNvSpPr txBox="1"/>
+          <p:nvPr/>
+        </p:nvSpPr>
+        <p:spPr>
+          <a:xfrm>
+            <a:off x="813816" y="4846320"/>
+            <a:ext cx="1847088" cy="237744"/>
+          </a:xfrm>
+          <a:prstGeom prst="rect">
+            <a:avLst/>
+          </a:prstGeom>
+          <a:noFill/>
+          <a:ln/>
+        </p:spPr>
+        <p:txBody>
+          <a:bodyPr wrap="square" lIns="0" tIns="0" rIns="0" bIns="0" rtlCol="0" anchor="ctr"/>
+          <a:lstStyle/>
+          <a:p>
+            <a:pPr indent="0" marL="0">
+              <a:buNone/>
+            </a:pPr>
+            <a:r>
+              <a:rPr lang="en-US" sz="1100" dirty="0">
+                <a:solidFill>
+                  <a:srgbClr val="1F2A33"/>
+                </a:solidFill>
+                <a:latin typeface="Arial" pitchFamily="34" charset="0"/>
+                <a:ea typeface="Arial" pitchFamily="34" charset="-122"/>
+                <a:cs typeface="Arial" pitchFamily="34" charset="-120"/>
+              </a:rPr>
+              <a:t>Truly new opportunity</a:t>
+            </a:r>
+            <a:endParaRPr lang="en-US" sz="1100" dirty="0"/>
+          </a:p>
+        </p:txBody>
+      </p:sp>
+      <p:sp>
+        <p:nvSpPr>
+          <p:cNvPr id="37" name="Shape 34"/>
+          <p:cNvSpPr/>
+          <p:nvPr/>
+        </p:nvSpPr>
+        <p:spPr>
+          <a:xfrm>
+            <a:off x="2715768" y="4887468"/>
+            <a:ext cx="1714500" cy="164592"/>
+          </a:xfrm>
+          <a:prstGeom prst="rect">
+            <a:avLst/>
+          </a:prstGeom>
+          <a:solidFill>
+            <a:srgbClr val="129682"/>
+          </a:solidFill>
+          <a:ln/>
+        </p:spPr>
+      </p:sp>
+      <p:sp>
+        <p:nvSpPr>
+          <p:cNvPr id="38" name="Text 35"/>
+          <p:cNvSpPr txBox="1"/>
+          <p:nvPr/>
+        </p:nvSpPr>
+        <p:spPr>
+          <a:xfrm>
+            <a:off x="4521708" y="4846320"/>
+            <a:ext cx="2011680" cy="237744"/>
+          </a:xfrm>
+          <a:prstGeom prst="rect">
+            <a:avLst/>
+          </a:prstGeom>
+          <a:noFill/>
+          <a:ln/>
+        </p:spPr>
+        <p:txBody>
+          <a:bodyPr wrap="square" lIns="0" tIns="0" rIns="0" bIns="0" rtlCol="0" anchor="ctr"/>
+          <a:lstStyle/>
+          <a:p>
+            <a:pPr indent="0" marL="0">
+              <a:buNone/>
+            </a:pPr>
+            <a:r>
+              <a:rPr lang="en-US" sz="1150" b="1" dirty="0">
+                <a:solidFill>
+                  <a:srgbClr val="0B6B5D"/>
+                </a:solidFill>
+                <a:latin typeface="Arial" pitchFamily="34" charset="0"/>
+                <a:ea typeface="Arial" pitchFamily="34" charset="-122"/>
+                <a:cs typeface="Arial" pitchFamily="34" charset="-120"/>
+              </a:rPr>
+              <a:t>$4.5M</a:t>
+            </a:r>
+            <a:endParaRPr lang="en-US" sz="1150" dirty="0"/>
+          </a:p>
+        </p:txBody>
+      </p:sp>
+      <p:sp>
+        <p:nvSpPr>
+          <p:cNvPr id="39" name="Text 36"/>
+          <p:cNvSpPr txBox="1"/>
+          <p:nvPr/>
+        </p:nvSpPr>
+        <p:spPr>
+          <a:xfrm>
+            <a:off x="1527048" y="5102352"/>
+            <a:ext cx="4937760" cy="182880"/>
+          </a:xfrm>
+          <a:prstGeom prst="rect">
+            <a:avLst/>
+          </a:prstGeom>
+          <a:noFill/>
+          <a:ln/>
+        </p:spPr>
+        <p:txBody>
+          <a:bodyPr wrap="square" lIns="0" tIns="0" rIns="0" bIns="0" rtlCol="0" anchor="ctr"/>
+          <a:lstStyle/>
+          <a:p>
+            <a:pPr indent="0" marL="0">
+              <a:buNone/>
+            </a:pPr>
+            <a:r>
+              <a:rPr lang="en-US" sz="950" i="1" dirty="0">
+                <a:solidFill>
+                  <a:srgbClr val="5C6B77"/>
+                </a:solidFill>
+                <a:latin typeface="Arial" pitchFamily="34" charset="0"/>
+                <a:ea typeface="Arial" pitchFamily="34" charset="-122"/>
+                <a:cs typeface="Arial" pitchFamily="34" charset="-120"/>
+              </a:rPr>
+              <a:t>− not everything gets captured — people adopt gradually, freed time is reinvested  (−35%)</a:t>
+            </a:r>
+            <a:endParaRPr lang="en-US" sz="950" dirty="0"/>
+          </a:p>
+        </p:txBody>
+      </p:sp>
+      <p:sp>
+        <p:nvSpPr>
+          <p:cNvPr id="40" name="Text 37"/>
+          <p:cNvSpPr txBox="1"/>
+          <p:nvPr/>
+        </p:nvSpPr>
+        <p:spPr>
+          <a:xfrm>
+            <a:off x="813816" y="5285232"/>
+            <a:ext cx="1847088" cy="237744"/>
           </a:xfrm>
           <a:prstGeom prst="rect">
             <a:avLst/>
@@ -1767,7 +2218,7 @@
                 <a:ea typeface="Arial" pitchFamily="34" charset="-122"/>
                 <a:cs typeface="Arial" pitchFamily="34" charset="-120"/>
               </a:rPr>
-              <a:t>$2.3M</a:t>
+              <a:t>Capturable</a:t>
             </a:r>
             <a:endParaRPr lang="en-US" sz="1100" dirty="0"/>
           </a:p>
@@ -1775,75 +2226,75 @@
       </p:sp>
       <p:sp>
         <p:nvSpPr>
-          <p:cNvPr id="27" name="Text 24"/>
-          <p:cNvSpPr txBox="1"/>
-          <p:nvPr/>
-        </p:nvSpPr>
-        <p:spPr>
-          <a:xfrm>
-            <a:off x="813816" y="3337560"/>
-            <a:ext cx="1847088" cy="237744"/>
-          </a:xfrm>
-          <a:prstGeom prst="rect">
-            <a:avLst/>
-          </a:prstGeom>
-          <a:noFill/>
-          <a:ln/>
-        </p:spPr>
-        <p:txBody>
-          <a:bodyPr wrap="square" lIns="0" tIns="0" rIns="0" bIns="0" rtlCol="0" anchor="ctr"/>
-          <a:lstStyle/>
-          <a:p>
-            <a:pPr indent="0" marL="0">
-              <a:buNone/>
-            </a:pPr>
-            <a:r>
-              <a:rPr lang="en-US" sz="1050" dirty="0">
-                <a:solidFill>
-                  <a:srgbClr val="1F2A33"/>
-                </a:solidFill>
-                <a:latin typeface="Arial" pitchFamily="34" charset="0"/>
-                <a:ea typeface="Arial" pitchFamily="34" charset="-122"/>
-                <a:cs typeface="Arial" pitchFamily="34" charset="-120"/>
-              </a:rPr>
-              <a:t>Reporting &amp; documentation</a:t>
-            </a:r>
-            <a:endParaRPr lang="en-US" sz="1050" dirty="0"/>
-          </a:p>
-        </p:txBody>
-      </p:sp>
-      <p:sp>
-        <p:nvSpPr>
-          <p:cNvPr id="28" name="Shape 25"/>
+          <p:cNvPr id="41" name="Shape 38"/>
           <p:cNvSpPr/>
           <p:nvPr/>
         </p:nvSpPr>
         <p:spPr>
           <a:xfrm>
-            <a:off x="2715768" y="3387852"/>
-            <a:ext cx="1143000" cy="146304"/>
+            <a:off x="2715768" y="5326380"/>
+            <a:ext cx="1143000" cy="164592"/>
           </a:xfrm>
           <a:prstGeom prst="rect">
             <a:avLst/>
           </a:prstGeom>
           <a:solidFill>
-            <a:srgbClr val="BFE0D8"/>
+            <a:srgbClr val="C77414"/>
           </a:solidFill>
           <a:ln/>
         </p:spPr>
       </p:sp>
       <p:sp>
         <p:nvSpPr>
-          <p:cNvPr id="29" name="Shape 26"/>
+          <p:cNvPr id="42" name="Text 39"/>
+          <p:cNvSpPr txBox="1"/>
+          <p:nvPr/>
+        </p:nvSpPr>
+        <p:spPr>
+          <a:xfrm>
+            <a:off x="3950208" y="5285232"/>
+            <a:ext cx="2011680" cy="237744"/>
+          </a:xfrm>
+          <a:prstGeom prst="rect">
+            <a:avLst/>
+          </a:prstGeom>
+          <a:noFill/>
+          <a:ln/>
+        </p:spPr>
+        <p:txBody>
+          <a:bodyPr wrap="square" lIns="0" tIns="0" rIns="0" bIns="0" rtlCol="0" anchor="ctr"/>
+          <a:lstStyle/>
+          <a:p>
+            <a:pPr indent="0" marL="0">
+              <a:buNone/>
+            </a:pPr>
+            <a:r>
+              <a:rPr lang="en-US" sz="1150" b="1" dirty="0">
+                <a:solidFill>
+                  <a:srgbClr val="9A5A0B"/>
+                </a:solidFill>
+                <a:latin typeface="Arial" pitchFamily="34" charset="0"/>
+                <a:ea typeface="Arial" pitchFamily="34" charset="-122"/>
+                <a:cs typeface="Arial" pitchFamily="34" charset="-120"/>
+              </a:rPr>
+              <a:t>~$3M / yr</a:t>
+            </a:r>
+            <a:endParaRPr lang="en-US" sz="1150" dirty="0"/>
+          </a:p>
+        </p:txBody>
+      </p:sp>
+      <p:sp>
+        <p:nvSpPr>
+          <p:cNvPr id="43" name="Shape 40"/>
           <p:cNvSpPr/>
           <p:nvPr/>
         </p:nvSpPr>
         <p:spPr>
           <a:xfrm>
-            <a:off x="2715768" y="3387852"/>
-            <a:ext cx="685800" cy="146304"/>
-          </a:xfrm>
-          <a:prstGeom prst="rect">
+            <a:off x="502920" y="5705856"/>
+            <a:ext cx="219456" cy="219456"/>
+          </a:xfrm>
+          <a:prstGeom prst="ellipse">
             <a:avLst/>
           </a:prstGeom>
           <a:solidFill>
@@ -1854,77 +2305,261 @@
       </p:sp>
       <p:sp>
         <p:nvSpPr>
-          <p:cNvPr id="30" name="Text 27"/>
-          <p:cNvSpPr txBox="1"/>
-          <p:nvPr/>
-        </p:nvSpPr>
-        <p:spPr>
-          <a:xfrm>
-            <a:off x="3950208" y="3337560"/>
-            <a:ext cx="868680" cy="237744"/>
-          </a:xfrm>
-          <a:prstGeom prst="rect">
-            <a:avLst/>
-          </a:prstGeom>
-          <a:noFill/>
-          <a:ln/>
-        </p:spPr>
-        <p:txBody>
-          <a:bodyPr wrap="square" lIns="0" tIns="0" rIns="0" bIns="0" rtlCol="0" anchor="ctr"/>
-          <a:lstStyle/>
-          <a:p>
-            <a:pPr indent="0" marL="0">
+          <p:cNvPr id="44" name="Text 41"/>
+          <p:cNvSpPr txBox="1"/>
+          <p:nvPr/>
+        </p:nvSpPr>
+        <p:spPr>
+          <a:xfrm>
+            <a:off x="502920" y="5705856"/>
+            <a:ext cx="219456" cy="219456"/>
+          </a:xfrm>
+          <a:prstGeom prst="rect">
+            <a:avLst/>
+          </a:prstGeom>
+          <a:noFill/>
+          <a:ln/>
+        </p:spPr>
+        <p:txBody>
+          <a:bodyPr wrap="square" lIns="0" tIns="0" rIns="0" bIns="0" rtlCol="0" anchor="ctr"/>
+          <a:lstStyle/>
+          <a:p>
+            <a:pPr algn="ctr" indent="0" marL="0">
               <a:buNone/>
             </a:pPr>
             <a:r>
               <a:rPr lang="en-US" sz="1100" b="1" dirty="0">
                 <a:solidFill>
+                  <a:srgbClr val="FFFFFF"/>
+                </a:solidFill>
+                <a:latin typeface="Arial" pitchFamily="34" charset="0"/>
+                <a:ea typeface="Arial" pitchFamily="34" charset="-122"/>
+                <a:cs typeface="Arial" pitchFamily="34" charset="-120"/>
+              </a:rPr>
+              <a:t>4</a:t>
+            </a:r>
+            <a:endParaRPr lang="en-US" sz="1100" dirty="0"/>
+          </a:p>
+        </p:txBody>
+      </p:sp>
+      <p:sp>
+        <p:nvSpPr>
+          <p:cNvPr id="45" name="Text 42"/>
+          <p:cNvSpPr txBox="1"/>
+          <p:nvPr/>
+        </p:nvSpPr>
+        <p:spPr>
+          <a:xfrm>
+            <a:off x="813816" y="5687568"/>
+            <a:ext cx="5486400" cy="256032"/>
+          </a:xfrm>
+          <a:prstGeom prst="rect">
+            <a:avLst/>
+          </a:prstGeom>
+          <a:noFill/>
+          <a:ln/>
+        </p:spPr>
+        <p:txBody>
+          <a:bodyPr wrap="square" lIns="0" tIns="0" rIns="0" bIns="0" rtlCol="0" anchor="ctr"/>
+          <a:lstStyle/>
+          <a:p>
+            <a:pPr indent="0" marL="0">
+              <a:buNone/>
+            </a:pPr>
+            <a:r>
+              <a:rPr lang="en-US" sz="1350" b="1" dirty="0">
+                <a:solidFill>
+                  <a:srgbClr val="1F2A33"/>
+                </a:solidFill>
+                <a:latin typeface="Arial" pitchFamily="34" charset="0"/>
+                <a:ea typeface="Arial" pitchFamily="34" charset="-122"/>
+                <a:cs typeface="Arial" pitchFamily="34" charset="-120"/>
+              </a:rPr>
+              <a:t>Prioritize by size × ease — go easy-first</a:t>
+            </a:r>
+            <a:endParaRPr lang="en-US" sz="1350" dirty="0"/>
+          </a:p>
+        </p:txBody>
+      </p:sp>
+      <p:sp>
+        <p:nvSpPr>
+          <p:cNvPr id="46" name="Text 43"/>
+          <p:cNvSpPr txBox="1"/>
+          <p:nvPr/>
+        </p:nvSpPr>
+        <p:spPr>
+          <a:xfrm>
+            <a:off x="832104" y="5943600"/>
+            <a:ext cx="219456" cy="201168"/>
+          </a:xfrm>
+          <a:prstGeom prst="rect">
+            <a:avLst/>
+          </a:prstGeom>
+          <a:noFill/>
+          <a:ln/>
+        </p:spPr>
+        <p:txBody>
+          <a:bodyPr wrap="square" lIns="0" tIns="0" rIns="0" bIns="0" rtlCol="0" anchor="ctr"/>
+          <a:lstStyle/>
+          <a:p>
+            <a:pPr indent="0" marL="0">
+              <a:buNone/>
+            </a:pPr>
+            <a:r>
+              <a:rPr lang="en-US" sz="1050" b="1" dirty="0">
+                <a:solidFill>
                   <a:srgbClr val="0B6B5D"/>
                 </a:solidFill>
                 <a:latin typeface="Arial" pitchFamily="34" charset="0"/>
                 <a:ea typeface="Arial" pitchFamily="34" charset="-122"/>
                 <a:cs typeface="Arial" pitchFamily="34" charset="-120"/>
               </a:rPr>
-              <a:t>$3.4M</a:t>
-            </a:r>
-            <a:endParaRPr lang="en-US" sz="1100" dirty="0"/>
-          </a:p>
-        </p:txBody>
-      </p:sp>
-      <p:sp>
-        <p:nvSpPr>
-          <p:cNvPr id="31" name="Text 28"/>
-          <p:cNvSpPr txBox="1"/>
-          <p:nvPr/>
-        </p:nvSpPr>
-        <p:spPr>
-          <a:xfrm>
-            <a:off x="813816" y="3602736"/>
-            <a:ext cx="1847088" cy="237744"/>
-          </a:xfrm>
-          <a:prstGeom prst="rect">
-            <a:avLst/>
-          </a:prstGeom>
-          <a:noFill/>
-          <a:ln/>
-        </p:spPr>
-        <p:txBody>
-          <a:bodyPr wrap="square" lIns="0" tIns="0" rIns="0" bIns="0" rtlCol="0" anchor="ctr"/>
-          <a:lstStyle/>
-          <a:p>
+              <a:t>1.</a:t>
+            </a:r>
+            <a:endParaRPr lang="en-US" sz="1050" dirty="0"/>
+          </a:p>
+        </p:txBody>
+      </p:sp>
+      <p:sp>
+        <p:nvSpPr>
+          <p:cNvPr id="47" name="Text 44"/>
+          <p:cNvSpPr txBox="1"/>
+          <p:nvPr/>
+        </p:nvSpPr>
+        <p:spPr>
+          <a:xfrm>
+            <a:off x="1069848" y="5943600"/>
+            <a:ext cx="5486400" cy="201168"/>
+          </a:xfrm>
+          <a:prstGeom prst="rect">
+            <a:avLst/>
+          </a:prstGeom>
+          <a:noFill/>
+          <a:ln/>
+        </p:spPr>
+        <p:txBody>
+          <a:bodyPr wrap="square" lIns="0" tIns="0" rIns="0" bIns="0" rtlCol="0" anchor="ctr"/>
+          <a:lstStyle/>
+          <a:p>
+            <a:pPr indent="0" marL="0">
+              <a:buNone/>
+            </a:pPr>
+            <a:r>
+              <a:rPr lang="en-US" sz="1050" b="1" dirty="0">
+                <a:solidFill>
+                  <a:srgbClr val="1F2A33"/>
+                </a:solidFill>
+                <a:latin typeface="Arial" pitchFamily="34" charset="0"/>
+                <a:ea typeface="Arial" pitchFamily="34" charset="-122"/>
+                <a:cs typeface="Arial" pitchFamily="34" charset="-120"/>
+              </a:rPr>
+              <a:t>Data prep &amp; cleaning   </a:t>
+            </a:r>
             <a:pPr indent="0" marL="0">
               <a:buNone/>
             </a:pPr>
             <a:r>
               <a:rPr lang="en-US" sz="1050" dirty="0">
                 <a:solidFill>
+                  <a:srgbClr val="5C6B77"/>
+                </a:solidFill>
+                <a:latin typeface="Arial" pitchFamily="34" charset="0"/>
+                <a:ea typeface="Arial" pitchFamily="34" charset="-122"/>
+                <a:cs typeface="Arial" pitchFamily="34" charset="-120"/>
+              </a:rPr>
+              <a:t>$3M pool, easy — the agent build starts here</a:t>
+            </a:r>
+            <a:endParaRPr lang="en-US" sz="1050" dirty="0"/>
+          </a:p>
+        </p:txBody>
+      </p:sp>
+      <p:sp>
+        <p:nvSpPr>
+          <p:cNvPr id="48" name="Text 45"/>
+          <p:cNvSpPr txBox="1"/>
+          <p:nvPr/>
+        </p:nvSpPr>
+        <p:spPr>
+          <a:xfrm>
+            <a:off x="832104" y="6172200"/>
+            <a:ext cx="219456" cy="201168"/>
+          </a:xfrm>
+          <a:prstGeom prst="rect">
+            <a:avLst/>
+          </a:prstGeom>
+          <a:noFill/>
+          <a:ln/>
+        </p:spPr>
+        <p:txBody>
+          <a:bodyPr wrap="square" lIns="0" tIns="0" rIns="0" bIns="0" rtlCol="0" anchor="ctr"/>
+          <a:lstStyle/>
+          <a:p>
+            <a:pPr indent="0" marL="0">
+              <a:buNone/>
+            </a:pPr>
+            <a:r>
+              <a:rPr lang="en-US" sz="1050" b="1" dirty="0">
+                <a:solidFill>
+                  <a:srgbClr val="9A5A0B"/>
+                </a:solidFill>
+                <a:latin typeface="Arial" pitchFamily="34" charset="0"/>
+                <a:ea typeface="Arial" pitchFamily="34" charset="-122"/>
+                <a:cs typeface="Arial" pitchFamily="34" charset="-120"/>
+              </a:rPr>
+              <a:t>2.</a:t>
+            </a:r>
+            <a:endParaRPr lang="en-US" sz="1050" dirty="0"/>
+          </a:p>
+        </p:txBody>
+      </p:sp>
+      <p:sp>
+        <p:nvSpPr>
+          <p:cNvPr id="49" name="Text 46"/>
+          <p:cNvSpPr txBox="1"/>
+          <p:nvPr/>
+        </p:nvSpPr>
+        <p:spPr>
+          <a:xfrm>
+            <a:off x="1069848" y="6172200"/>
+            <a:ext cx="5486400" cy="201168"/>
+          </a:xfrm>
+          <a:prstGeom prst="rect">
+            <a:avLst/>
+          </a:prstGeom>
+          <a:noFill/>
+          <a:ln/>
+        </p:spPr>
+        <p:txBody>
+          <a:bodyPr wrap="square" lIns="0" tIns="0" rIns="0" bIns="0" rtlCol="0" anchor="ctr"/>
+          <a:lstStyle/>
+          <a:p>
+            <a:pPr indent="0" marL="0">
+              <a:buNone/>
+            </a:pPr>
+            <a:r>
+              <a:rPr lang="en-US" sz="1050" b="1" dirty="0">
+                <a:solidFill>
                   <a:srgbClr val="1F2A33"/>
                 </a:solidFill>
                 <a:latin typeface="Arial" pitchFamily="34" charset="0"/>
                 <a:ea typeface="Arial" pitchFamily="34" charset="-122"/>
                 <a:cs typeface="Arial" pitchFamily="34" charset="-120"/>
               </a:rPr>
-              <a:t>Stakeholder alignment</a:t>
+              <a:t>Exploratory analysis   </a:t>
+            </a:r>
+            <a:pPr indent="0" marL="0">
+              <a:buNone/>
+            </a:pPr>
+            <a:r>
+              <a:rPr lang="en-US" sz="1050" dirty="0">
+                <a:solidFill>
+                  <a:srgbClr val="5C6B77"/>
+                </a:solidFill>
+                <a:latin typeface="Arial" pitchFamily="34" charset="0"/>
+                <a:ea typeface="Arial" pitchFamily="34" charset="-122"/>
+                <a:cs typeface="Arial" pitchFamily="34" charset="-120"/>
+              </a:rPr>
+              <a:t>$2M pool, medium — fast follow on the same backbone</a:t>
             </a:r>
             <a:endParaRPr lang="en-US" sz="1050" dirty="0"/>
           </a:p>
@@ -1932,70 +2567,30 @@
       </p:sp>
       <p:sp>
         <p:nvSpPr>
-          <p:cNvPr id="32" name="Shape 29"/>
-          <p:cNvSpPr/>
-          <p:nvPr/>
-        </p:nvSpPr>
-        <p:spPr>
-          <a:xfrm>
-            <a:off x="2715768" y="3653028"/>
-            <a:ext cx="914400" cy="146304"/>
-          </a:xfrm>
-          <a:prstGeom prst="rect">
-            <a:avLst/>
-          </a:prstGeom>
-          <a:solidFill>
-            <a:srgbClr val="EBD3D6"/>
-          </a:solidFill>
-          <a:ln/>
-        </p:spPr>
-      </p:sp>
-      <p:sp>
-        <p:nvSpPr>
-          <p:cNvPr id="33" name="Shape 30"/>
-          <p:cNvSpPr/>
-          <p:nvPr/>
-        </p:nvSpPr>
-        <p:spPr>
-          <a:xfrm>
-            <a:off x="2715768" y="3653028"/>
-            <a:ext cx="91440" cy="146304"/>
-          </a:xfrm>
-          <a:prstGeom prst="rect">
-            <a:avLst/>
-          </a:prstGeom>
-          <a:solidFill>
-            <a:srgbClr val="9A4E58"/>
-          </a:solidFill>
-          <a:ln/>
-        </p:spPr>
-      </p:sp>
-      <p:sp>
-        <p:nvSpPr>
-          <p:cNvPr id="34" name="Text 31"/>
-          <p:cNvSpPr txBox="1"/>
-          <p:nvPr/>
-        </p:nvSpPr>
-        <p:spPr>
-          <a:xfrm>
-            <a:off x="3721608" y="3602736"/>
-            <a:ext cx="868680" cy="237744"/>
-          </a:xfrm>
-          <a:prstGeom prst="rect">
-            <a:avLst/>
-          </a:prstGeom>
-          <a:noFill/>
-          <a:ln/>
-        </p:spPr>
-        <p:txBody>
-          <a:bodyPr wrap="square" lIns="0" tIns="0" rIns="0" bIns="0" rtlCol="0" anchor="ctr"/>
-          <a:lstStyle/>
-          <a:p>
-            <a:pPr indent="0" marL="0">
-              <a:buNone/>
-            </a:pPr>
-            <a:r>
-              <a:rPr lang="en-US" sz="1100" b="1" dirty="0">
+          <p:cNvPr id="50" name="Text 47"/>
+          <p:cNvSpPr txBox="1"/>
+          <p:nvPr/>
+        </p:nvSpPr>
+        <p:spPr>
+          <a:xfrm>
+            <a:off x="832104" y="6400800"/>
+            <a:ext cx="219456" cy="201168"/>
+          </a:xfrm>
+          <a:prstGeom prst="rect">
+            <a:avLst/>
+          </a:prstGeom>
+          <a:noFill/>
+          <a:ln/>
+        </p:spPr>
+        <p:txBody>
+          <a:bodyPr wrap="square" lIns="0" tIns="0" rIns="0" bIns="0" rtlCol="0" anchor="ctr"/>
+          <a:lstStyle/>
+          <a:p>
+            <a:pPr indent="0" marL="0">
+              <a:buNone/>
+            </a:pPr>
+            <a:r>
+              <a:rPr lang="en-US" sz="1050" b="1" dirty="0">
                 <a:solidFill>
                   <a:srgbClr val="9A4E58"/>
                 </a:solidFill>
@@ -2003,46 +2598,60 @@
                 <a:ea typeface="Arial" pitchFamily="34" charset="-122"/>
                 <a:cs typeface="Arial" pitchFamily="34" charset="-120"/>
               </a:rPr>
-              <a:t>$0.5M</a:t>
-            </a:r>
-            <a:endParaRPr lang="en-US" sz="1100" dirty="0"/>
-          </a:p>
-        </p:txBody>
-      </p:sp>
-      <p:sp>
-        <p:nvSpPr>
-          <p:cNvPr id="35" name="Text 32"/>
-          <p:cNvSpPr txBox="1"/>
-          <p:nvPr/>
-        </p:nvSpPr>
-        <p:spPr>
-          <a:xfrm>
-            <a:off x="813816" y="3867912"/>
-            <a:ext cx="1847088" cy="237744"/>
-          </a:xfrm>
-          <a:prstGeom prst="rect">
-            <a:avLst/>
-          </a:prstGeom>
-          <a:noFill/>
-          <a:ln/>
-        </p:spPr>
-        <p:txBody>
-          <a:bodyPr wrap="square" lIns="0" tIns="0" rIns="0" bIns="0" rtlCol="0" anchor="ctr"/>
-          <a:lstStyle/>
-          <a:p>
+              <a:t>3.</a:t>
+            </a:r>
+            <a:endParaRPr lang="en-US" sz="1050" dirty="0"/>
+          </a:p>
+        </p:txBody>
+      </p:sp>
+      <p:sp>
+        <p:nvSpPr>
+          <p:cNvPr id="51" name="Text 48"/>
+          <p:cNvSpPr txBox="1"/>
+          <p:nvPr/>
+        </p:nvSpPr>
+        <p:spPr>
+          <a:xfrm>
+            <a:off x="1069848" y="6400800"/>
+            <a:ext cx="5486400" cy="201168"/>
+          </a:xfrm>
+          <a:prstGeom prst="rect">
+            <a:avLst/>
+          </a:prstGeom>
+          <a:noFill/>
+          <a:ln/>
+        </p:spPr>
+        <p:txBody>
+          <a:bodyPr wrap="square" lIns="0" tIns="0" rIns="0" bIns="0" rtlCol="0" anchor="ctr"/>
+          <a:lstStyle/>
+          <a:p>
+            <a:pPr indent="0" marL="0">
+              <a:buNone/>
+            </a:pPr>
+            <a:r>
+              <a:rPr lang="en-US" sz="1050" b="1" dirty="0">
+                <a:solidFill>
+                  <a:srgbClr val="1F2A33"/>
+                </a:solidFill>
+                <a:latin typeface="Arial" pitchFamily="34" charset="0"/>
+                <a:ea typeface="Arial" pitchFamily="34" charset="-122"/>
+                <a:cs typeface="Arial" pitchFamily="34" charset="-120"/>
+              </a:rPr>
+              <a:t>Stakeholder alignment   </a:t>
+            </a:r>
             <a:pPr indent="0" marL="0">
               <a:buNone/>
             </a:pPr>
             <a:r>
               <a:rPr lang="en-US" sz="1050" dirty="0">
                 <a:solidFill>
-                  <a:srgbClr val="1F2A33"/>
-                </a:solidFill>
-                <a:latin typeface="Arial" pitchFamily="34" charset="0"/>
-                <a:ea typeface="Arial" pitchFamily="34" charset="-122"/>
-                <a:cs typeface="Arial" pitchFamily="34" charset="-120"/>
-              </a:rPr>
-              <a:t>Ad-hoc requests</a:t>
+                  <a:srgbClr val="5C6B77"/>
+                </a:solidFill>
+                <a:latin typeface="Arial" pitchFamily="34" charset="0"/>
+                <a:ea typeface="Arial" pitchFamily="34" charset="-122"/>
+                <a:cs typeface="Arial" pitchFamily="34" charset="-120"/>
+              </a:rPr>
+              <a:t>$1M pool, hard and human-led — don’t build here yet</a:t>
             </a:r>
             <a:endParaRPr lang="en-US" sz="1050" dirty="0"/>
           </a:p>
@@ -2050,1030 +2659,7 @@
       </p:sp>
       <p:sp>
         <p:nvSpPr>
-          <p:cNvPr id="36" name="Shape 33"/>
-          <p:cNvSpPr/>
-          <p:nvPr/>
-        </p:nvSpPr>
-        <p:spPr>
-          <a:xfrm>
-            <a:off x="2715768" y="3918204"/>
-            <a:ext cx="609600" cy="146304"/>
-          </a:xfrm>
-          <a:prstGeom prst="rect">
-            <a:avLst/>
-          </a:prstGeom>
-          <a:solidFill>
-            <a:srgbClr val="EFD9B8"/>
-          </a:solidFill>
-          <a:ln/>
-        </p:spPr>
-      </p:sp>
-      <p:sp>
-        <p:nvSpPr>
-          <p:cNvPr id="37" name="Shape 34"/>
-          <p:cNvSpPr/>
-          <p:nvPr/>
-        </p:nvSpPr>
-        <p:spPr>
-          <a:xfrm>
-            <a:off x="2715768" y="3918204"/>
-            <a:ext cx="274320" cy="146304"/>
-          </a:xfrm>
-          <a:prstGeom prst="rect">
-            <a:avLst/>
-          </a:prstGeom>
-          <a:solidFill>
-            <a:srgbClr val="9A5A0B"/>
-          </a:solidFill>
-          <a:ln/>
-        </p:spPr>
-      </p:sp>
-      <p:sp>
-        <p:nvSpPr>
-          <p:cNvPr id="38" name="Text 35"/>
-          <p:cNvSpPr txBox="1"/>
-          <p:nvPr/>
-        </p:nvSpPr>
-        <p:spPr>
-          <a:xfrm>
-            <a:off x="3416808" y="3867912"/>
-            <a:ext cx="868680" cy="237744"/>
-          </a:xfrm>
-          <a:prstGeom prst="rect">
-            <a:avLst/>
-          </a:prstGeom>
-          <a:noFill/>
-          <a:ln/>
-        </p:spPr>
-        <p:txBody>
-          <a:bodyPr wrap="square" lIns="0" tIns="0" rIns="0" bIns="0" rtlCol="0" anchor="ctr"/>
-          <a:lstStyle/>
-          <a:p>
-            <a:pPr indent="0" marL="0">
-              <a:buNone/>
-            </a:pPr>
-            <a:r>
-              <a:rPr lang="en-US" sz="1100" b="1" dirty="0">
-                <a:solidFill>
-                  <a:srgbClr val="9A5A0B"/>
-                </a:solidFill>
-                <a:latin typeface="Arial" pitchFamily="34" charset="0"/>
-                <a:ea typeface="Arial" pitchFamily="34" charset="-122"/>
-                <a:cs typeface="Arial" pitchFamily="34" charset="-120"/>
-              </a:rPr>
-              <a:t>$1.4M</a:t>
-            </a:r>
-            <a:endParaRPr lang="en-US" sz="1100" dirty="0"/>
-          </a:p>
-        </p:txBody>
-      </p:sp>
-      <p:sp>
-        <p:nvSpPr>
-          <p:cNvPr id="39" name="Shape 36"/>
-          <p:cNvSpPr/>
-          <p:nvPr/>
-        </p:nvSpPr>
-        <p:spPr>
-          <a:xfrm>
-            <a:off x="502920" y="4224528"/>
-            <a:ext cx="219456" cy="219456"/>
-          </a:xfrm>
-          <a:prstGeom prst="ellipse">
-            <a:avLst/>
-          </a:prstGeom>
-          <a:solidFill>
-            <a:srgbClr val="0B6B5D"/>
-          </a:solidFill>
-          <a:ln/>
-        </p:spPr>
-      </p:sp>
-      <p:sp>
-        <p:nvSpPr>
-          <p:cNvPr id="40" name="Text 37"/>
-          <p:cNvSpPr txBox="1"/>
-          <p:nvPr/>
-        </p:nvSpPr>
-        <p:spPr>
-          <a:xfrm>
-            <a:off x="502920" y="4224528"/>
-            <a:ext cx="219456" cy="219456"/>
-          </a:xfrm>
-          <a:prstGeom prst="rect">
-            <a:avLst/>
-          </a:prstGeom>
-          <a:noFill/>
-          <a:ln/>
-        </p:spPr>
-        <p:txBody>
-          <a:bodyPr wrap="square" lIns="0" tIns="0" rIns="0" bIns="0" rtlCol="0" anchor="ctr"/>
-          <a:lstStyle/>
-          <a:p>
-            <a:pPr algn="ctr" indent="0" marL="0">
-              <a:buNone/>
-            </a:pPr>
-            <a:r>
-              <a:rPr lang="en-US" sz="1100" b="1" dirty="0">
-                <a:solidFill>
-                  <a:srgbClr val="FFFFFF"/>
-                </a:solidFill>
-                <a:latin typeface="Arial" pitchFamily="34" charset="0"/>
-                <a:ea typeface="Arial" pitchFamily="34" charset="-122"/>
-                <a:cs typeface="Arial" pitchFamily="34" charset="-120"/>
-              </a:rPr>
-              <a:t>3</a:t>
-            </a:r>
-            <a:endParaRPr lang="en-US" sz="1100" dirty="0"/>
-          </a:p>
-        </p:txBody>
-      </p:sp>
-      <p:sp>
-        <p:nvSpPr>
-          <p:cNvPr id="41" name="Text 38"/>
-          <p:cNvSpPr txBox="1"/>
-          <p:nvPr/>
-        </p:nvSpPr>
-        <p:spPr>
-          <a:xfrm>
-            <a:off x="813816" y="4206240"/>
-            <a:ext cx="5486400" cy="256032"/>
-          </a:xfrm>
-          <a:prstGeom prst="rect">
-            <a:avLst/>
-          </a:prstGeom>
-          <a:noFill/>
-          <a:ln/>
-        </p:spPr>
-        <p:txBody>
-          <a:bodyPr wrap="square" lIns="0" tIns="0" rIns="0" bIns="0" rtlCol="0" anchor="ctr"/>
-          <a:lstStyle/>
-          <a:p>
-            <a:pPr indent="0" marL="0">
-              <a:buNone/>
-            </a:pPr>
-            <a:r>
-              <a:rPr lang="en-US" sz="1350" b="1" dirty="0">
-                <a:solidFill>
-                  <a:srgbClr val="1F2A33"/>
-                </a:solidFill>
-                <a:latin typeface="Arial" pitchFamily="34" charset="0"/>
-                <a:ea typeface="Arial" pitchFamily="34" charset="-122"/>
-                <a:cs typeface="Arial" pitchFamily="34" charset="-120"/>
-              </a:rPr>
-              <a:t>Add the pools up — then haircut to what you can capture</a:t>
-            </a:r>
-            <a:endParaRPr lang="en-US" sz="1350" dirty="0"/>
-          </a:p>
-        </p:txBody>
-      </p:sp>
-      <p:sp>
-        <p:nvSpPr>
-          <p:cNvPr id="42" name="Text 39"/>
-          <p:cNvSpPr txBox="1"/>
-          <p:nvPr/>
-        </p:nvSpPr>
-        <p:spPr>
-          <a:xfrm>
-            <a:off x="813816" y="4480560"/>
-            <a:ext cx="1847088" cy="237744"/>
-          </a:xfrm>
-          <a:prstGeom prst="rect">
-            <a:avLst/>
-          </a:prstGeom>
-          <a:noFill/>
-          <a:ln/>
-        </p:spPr>
-        <p:txBody>
-          <a:bodyPr wrap="square" lIns="0" tIns="0" rIns="0" bIns="0" rtlCol="0" anchor="ctr"/>
-          <a:lstStyle/>
-          <a:p>
-            <a:pPr indent="0" marL="0">
-              <a:buNone/>
-            </a:pPr>
-            <a:r>
-              <a:rPr lang="en-US" sz="1100" dirty="0">
-                <a:solidFill>
-                  <a:srgbClr val="1F2A33"/>
-                </a:solidFill>
-                <a:latin typeface="Arial" pitchFamily="34" charset="0"/>
-                <a:ea typeface="Arial" pitchFamily="34" charset="-122"/>
-                <a:cs typeface="Arial" pitchFamily="34" charset="-120"/>
-              </a:rPr>
-              <a:t>All six pools added up</a:t>
-            </a:r>
-            <a:endParaRPr lang="en-US" sz="1100" dirty="0"/>
-          </a:p>
-        </p:txBody>
-      </p:sp>
-      <p:sp>
-        <p:nvSpPr>
-          <p:cNvPr id="43" name="Shape 40"/>
-          <p:cNvSpPr/>
-          <p:nvPr/>
-        </p:nvSpPr>
-        <p:spPr>
-          <a:xfrm>
-            <a:off x="2715768" y="4521708"/>
-            <a:ext cx="890765" cy="164592"/>
-          </a:xfrm>
-          <a:prstGeom prst="rect">
-            <a:avLst/>
-          </a:prstGeom>
-          <a:solidFill>
-            <a:srgbClr val="0B6B5D"/>
-          </a:solidFill>
-          <a:ln/>
-        </p:spPr>
-      </p:sp>
-      <p:sp>
-        <p:nvSpPr>
-          <p:cNvPr id="44" name="Shape 41"/>
-          <p:cNvSpPr/>
-          <p:nvPr/>
-        </p:nvSpPr>
-        <p:spPr>
-          <a:xfrm>
-            <a:off x="3624821" y="4521708"/>
-            <a:ext cx="342659" cy="164592"/>
-          </a:xfrm>
-          <a:prstGeom prst="rect">
-            <a:avLst/>
-          </a:prstGeom>
-          <a:solidFill>
-            <a:srgbClr val="9A5A0B"/>
-          </a:solidFill>
-          <a:ln/>
-        </p:spPr>
-      </p:sp>
-      <p:sp>
-        <p:nvSpPr>
-          <p:cNvPr id="45" name="Shape 42"/>
-          <p:cNvSpPr/>
-          <p:nvPr/>
-        </p:nvSpPr>
-        <p:spPr>
-          <a:xfrm>
-            <a:off x="3985768" y="4521708"/>
-            <a:ext cx="289186" cy="164592"/>
-          </a:xfrm>
-          <a:prstGeom prst="rect">
-            <a:avLst/>
-          </a:prstGeom>
-          <a:solidFill>
-            <a:srgbClr val="9A5A0B"/>
-          </a:solidFill>
-          <a:ln/>
-        </p:spPr>
-      </p:sp>
-      <p:sp>
-        <p:nvSpPr>
-          <p:cNvPr id="46" name="Shape 43"/>
-          <p:cNvSpPr/>
-          <p:nvPr/>
-        </p:nvSpPr>
-        <p:spPr>
-          <a:xfrm>
-            <a:off x="4293242" y="4521708"/>
-            <a:ext cx="436238" cy="164592"/>
-          </a:xfrm>
-          <a:prstGeom prst="rect">
-            <a:avLst/>
-          </a:prstGeom>
-          <a:solidFill>
-            <a:srgbClr val="0B6B5D"/>
-          </a:solidFill>
-          <a:ln/>
-        </p:spPr>
-      </p:sp>
-      <p:sp>
-        <p:nvSpPr>
-          <p:cNvPr id="47" name="Shape 44"/>
-          <p:cNvSpPr/>
-          <p:nvPr/>
-        </p:nvSpPr>
-        <p:spPr>
-          <a:xfrm>
-            <a:off x="4747768" y="4521708"/>
-            <a:ext cx="48554" cy="164592"/>
-          </a:xfrm>
-          <a:prstGeom prst="rect">
-            <a:avLst/>
-          </a:prstGeom>
-          <a:solidFill>
-            <a:srgbClr val="9A4E58"/>
-          </a:solidFill>
-          <a:ln/>
-        </p:spPr>
-      </p:sp>
-      <p:sp>
-        <p:nvSpPr>
-          <p:cNvPr id="48" name="Shape 45"/>
-          <p:cNvSpPr/>
-          <p:nvPr/>
-        </p:nvSpPr>
-        <p:spPr>
-          <a:xfrm>
-            <a:off x="4814610" y="4521708"/>
-            <a:ext cx="168870" cy="164592"/>
-          </a:xfrm>
-          <a:prstGeom prst="rect">
-            <a:avLst/>
-          </a:prstGeom>
-          <a:solidFill>
-            <a:srgbClr val="9A5A0B"/>
-          </a:solidFill>
-          <a:ln/>
-        </p:spPr>
-      </p:sp>
-      <p:sp>
-        <p:nvSpPr>
-          <p:cNvPr id="49" name="Text 46"/>
-          <p:cNvSpPr txBox="1"/>
-          <p:nvPr/>
-        </p:nvSpPr>
-        <p:spPr>
-          <a:xfrm>
-            <a:off x="5074920" y="4480560"/>
-            <a:ext cx="2011680" cy="237744"/>
-          </a:xfrm>
-          <a:prstGeom prst="rect">
-            <a:avLst/>
-          </a:prstGeom>
-          <a:noFill/>
-          <a:ln/>
-        </p:spPr>
-        <p:txBody>
-          <a:bodyPr wrap="square" lIns="0" tIns="0" rIns="0" bIns="0" rtlCol="0" anchor="ctr"/>
-          <a:lstStyle/>
-          <a:p>
-            <a:pPr indent="0" marL="0">
-              <a:buNone/>
-            </a:pPr>
-            <a:r>
-              <a:rPr lang="en-US" sz="1150" b="1" dirty="0">
-                <a:solidFill>
-                  <a:srgbClr val="0B6B5D"/>
-                </a:solidFill>
-                <a:latin typeface="Arial" pitchFamily="34" charset="0"/>
-                <a:ea typeface="Arial" pitchFamily="34" charset="-122"/>
-                <a:cs typeface="Arial" pitchFamily="34" charset="-120"/>
-              </a:rPr>
-              <a:t>≈$17M</a:t>
-            </a:r>
-            <a:endParaRPr lang="en-US" sz="1150" dirty="0"/>
-          </a:p>
-        </p:txBody>
-      </p:sp>
-      <p:sp>
-        <p:nvSpPr>
-          <p:cNvPr id="50" name="Text 47"/>
-          <p:cNvSpPr txBox="1"/>
-          <p:nvPr/>
-        </p:nvSpPr>
-        <p:spPr>
-          <a:xfrm>
-            <a:off x="1527048" y="4736592"/>
-            <a:ext cx="4937760" cy="182880"/>
-          </a:xfrm>
-          <a:prstGeom prst="rect">
-            <a:avLst/>
-          </a:prstGeom>
-          <a:noFill/>
-          <a:ln/>
-        </p:spPr>
-        <p:txBody>
-          <a:bodyPr wrap="square" lIns="0" tIns="0" rIns="0" bIns="0" rtlCol="0" anchor="ctr"/>
-          <a:lstStyle/>
-          <a:p>
-            <a:pPr indent="0" marL="0">
-              <a:buNone/>
-            </a:pPr>
-            <a:r>
-              <a:rPr lang="en-US" sz="950" i="1" dirty="0">
-                <a:solidFill>
-                  <a:srgbClr val="5C6B77"/>
-                </a:solidFill>
-                <a:latin typeface="Arial" pitchFamily="34" charset="0"/>
-                <a:ea typeface="Arial" pitchFamily="34" charset="-122"/>
-                <a:cs typeface="Arial" pitchFamily="34" charset="-120"/>
-              </a:rPr>
-              <a:t>− you already cover some of this today — tools in place, learned via interviews  (−25%)</a:t>
-            </a:r>
-            <a:endParaRPr lang="en-US" sz="950" dirty="0"/>
-          </a:p>
-        </p:txBody>
-      </p:sp>
-      <p:sp>
-        <p:nvSpPr>
-          <p:cNvPr id="51" name="Text 48"/>
-          <p:cNvSpPr txBox="1"/>
-          <p:nvPr/>
-        </p:nvSpPr>
-        <p:spPr>
-          <a:xfrm>
-            <a:off x="813816" y="4919472"/>
-            <a:ext cx="1847088" cy="237744"/>
-          </a:xfrm>
-          <a:prstGeom prst="rect">
-            <a:avLst/>
-          </a:prstGeom>
-          <a:noFill/>
-          <a:ln/>
-        </p:spPr>
-        <p:txBody>
-          <a:bodyPr wrap="square" lIns="0" tIns="0" rIns="0" bIns="0" rtlCol="0" anchor="ctr"/>
-          <a:lstStyle/>
-          <a:p>
-            <a:pPr indent="0" marL="0">
-              <a:buNone/>
-            </a:pPr>
-            <a:r>
-              <a:rPr lang="en-US" sz="1100" dirty="0">
-                <a:solidFill>
-                  <a:srgbClr val="1F2A33"/>
-                </a:solidFill>
-                <a:latin typeface="Arial" pitchFamily="34" charset="0"/>
-                <a:ea typeface="Arial" pitchFamily="34" charset="-122"/>
-                <a:cs typeface="Arial" pitchFamily="34" charset="-120"/>
-              </a:rPr>
-              <a:t>Truly new opportunity</a:t>
-            </a:r>
-            <a:endParaRPr lang="en-US" sz="1100" dirty="0"/>
-          </a:p>
-        </p:txBody>
-      </p:sp>
-      <p:sp>
-        <p:nvSpPr>
           <p:cNvPr id="52" name="Shape 49"/>
-          <p:cNvSpPr/>
-          <p:nvPr/>
-        </p:nvSpPr>
-        <p:spPr>
-          <a:xfrm>
-            <a:off x="2715768" y="4960620"/>
-            <a:ext cx="1711158" cy="164592"/>
-          </a:xfrm>
-          <a:prstGeom prst="rect">
-            <a:avLst/>
-          </a:prstGeom>
-          <a:solidFill>
-            <a:srgbClr val="129682"/>
-          </a:solidFill>
-          <a:ln/>
-        </p:spPr>
-      </p:sp>
-      <p:sp>
-        <p:nvSpPr>
-          <p:cNvPr id="53" name="Text 50"/>
-          <p:cNvSpPr txBox="1"/>
-          <p:nvPr/>
-        </p:nvSpPr>
-        <p:spPr>
-          <a:xfrm>
-            <a:off x="4518366" y="4919472"/>
-            <a:ext cx="2011680" cy="237744"/>
-          </a:xfrm>
-          <a:prstGeom prst="rect">
-            <a:avLst/>
-          </a:prstGeom>
-          <a:noFill/>
-          <a:ln/>
-        </p:spPr>
-        <p:txBody>
-          <a:bodyPr wrap="square" lIns="0" tIns="0" rIns="0" bIns="0" rtlCol="0" anchor="ctr"/>
-          <a:lstStyle/>
-          <a:p>
-            <a:pPr indent="0" marL="0">
-              <a:buNone/>
-            </a:pPr>
-            <a:r>
-              <a:rPr lang="en-US" sz="1150" b="1" dirty="0">
-                <a:solidFill>
-                  <a:srgbClr val="0B6B5D"/>
-                </a:solidFill>
-                <a:latin typeface="Arial" pitchFamily="34" charset="0"/>
-                <a:ea typeface="Arial" pitchFamily="34" charset="-122"/>
-                <a:cs typeface="Arial" pitchFamily="34" charset="-120"/>
-              </a:rPr>
-              <a:t>$12.8M</a:t>
-            </a:r>
-            <a:endParaRPr lang="en-US" sz="1150" dirty="0"/>
-          </a:p>
-        </p:txBody>
-      </p:sp>
-      <p:sp>
-        <p:nvSpPr>
-          <p:cNvPr id="54" name="Text 51"/>
-          <p:cNvSpPr txBox="1"/>
-          <p:nvPr/>
-        </p:nvSpPr>
-        <p:spPr>
-          <a:xfrm>
-            <a:off x="1527048" y="5175504"/>
-            <a:ext cx="4937760" cy="182880"/>
-          </a:xfrm>
-          <a:prstGeom prst="rect">
-            <a:avLst/>
-          </a:prstGeom>
-          <a:noFill/>
-          <a:ln/>
-        </p:spPr>
-        <p:txBody>
-          <a:bodyPr wrap="square" lIns="0" tIns="0" rIns="0" bIns="0" rtlCol="0" anchor="ctr"/>
-          <a:lstStyle/>
-          <a:p>
-            <a:pPr indent="0" marL="0">
-              <a:buNone/>
-            </a:pPr>
-            <a:r>
-              <a:rPr lang="en-US" sz="950" i="1" dirty="0">
-                <a:solidFill>
-                  <a:srgbClr val="5C6B77"/>
-                </a:solidFill>
-                <a:latin typeface="Arial" pitchFamily="34" charset="0"/>
-                <a:ea typeface="Arial" pitchFamily="34" charset="-122"/>
-                <a:cs typeface="Arial" pitchFamily="34" charset="-120"/>
-              </a:rPr>
-              <a:t>− not everything gets captured — people adopt gradually, freed time is reinvested  (−35%)</a:t>
-            </a:r>
-            <a:endParaRPr lang="en-US" sz="950" dirty="0"/>
-          </a:p>
-        </p:txBody>
-      </p:sp>
-      <p:sp>
-        <p:nvSpPr>
-          <p:cNvPr id="55" name="Text 52"/>
-          <p:cNvSpPr txBox="1"/>
-          <p:nvPr/>
-        </p:nvSpPr>
-        <p:spPr>
-          <a:xfrm>
-            <a:off x="813816" y="5358384"/>
-            <a:ext cx="1847088" cy="237744"/>
-          </a:xfrm>
-          <a:prstGeom prst="rect">
-            <a:avLst/>
-          </a:prstGeom>
-          <a:noFill/>
-          <a:ln/>
-        </p:spPr>
-        <p:txBody>
-          <a:bodyPr wrap="square" lIns="0" tIns="0" rIns="0" bIns="0" rtlCol="0" anchor="ctr"/>
-          <a:lstStyle/>
-          <a:p>
-            <a:pPr indent="0" marL="0">
-              <a:buNone/>
-            </a:pPr>
-            <a:r>
-              <a:rPr lang="en-US" sz="1100" b="1" dirty="0">
-                <a:solidFill>
-                  <a:srgbClr val="9A5A0B"/>
-                </a:solidFill>
-                <a:latin typeface="Arial" pitchFamily="34" charset="0"/>
-                <a:ea typeface="Arial" pitchFamily="34" charset="-122"/>
-                <a:cs typeface="Arial" pitchFamily="34" charset="-120"/>
-              </a:rPr>
-              <a:t>Capturable</a:t>
-            </a:r>
-            <a:endParaRPr lang="en-US" sz="1100" dirty="0"/>
-          </a:p>
-        </p:txBody>
-      </p:sp>
-      <p:sp>
-        <p:nvSpPr>
-          <p:cNvPr id="56" name="Shape 53"/>
-          <p:cNvSpPr/>
-          <p:nvPr/>
-        </p:nvSpPr>
-        <p:spPr>
-          <a:xfrm>
-            <a:off x="2715768" y="5399532"/>
-            <a:ext cx="1109579" cy="164592"/>
-          </a:xfrm>
-          <a:prstGeom prst="rect">
-            <a:avLst/>
-          </a:prstGeom>
-          <a:solidFill>
-            <a:srgbClr val="C77414"/>
-          </a:solidFill>
-          <a:ln/>
-        </p:spPr>
-      </p:sp>
-      <p:sp>
-        <p:nvSpPr>
-          <p:cNvPr id="57" name="Text 54"/>
-          <p:cNvSpPr txBox="1"/>
-          <p:nvPr/>
-        </p:nvSpPr>
-        <p:spPr>
-          <a:xfrm>
-            <a:off x="3916787" y="5358384"/>
-            <a:ext cx="2011680" cy="237744"/>
-          </a:xfrm>
-          <a:prstGeom prst="rect">
-            <a:avLst/>
-          </a:prstGeom>
-          <a:noFill/>
-          <a:ln/>
-        </p:spPr>
-        <p:txBody>
-          <a:bodyPr wrap="square" lIns="0" tIns="0" rIns="0" bIns="0" rtlCol="0" anchor="ctr"/>
-          <a:lstStyle/>
-          <a:p>
-            <a:pPr indent="0" marL="0">
-              <a:buNone/>
-            </a:pPr>
-            <a:r>
-              <a:rPr lang="en-US" sz="1150" b="1" dirty="0">
-                <a:solidFill>
-                  <a:srgbClr val="9A5A0B"/>
-                </a:solidFill>
-                <a:latin typeface="Arial" pitchFamily="34" charset="0"/>
-                <a:ea typeface="Arial" pitchFamily="34" charset="-122"/>
-                <a:cs typeface="Arial" pitchFamily="34" charset="-120"/>
-              </a:rPr>
-              <a:t>$8.3M  (≈22% of cost base)</a:t>
-            </a:r>
-            <a:endParaRPr lang="en-US" sz="1150" dirty="0"/>
-          </a:p>
-        </p:txBody>
-      </p:sp>
-      <p:sp>
-        <p:nvSpPr>
-          <p:cNvPr id="58" name="Shape 55"/>
-          <p:cNvSpPr/>
-          <p:nvPr/>
-        </p:nvSpPr>
-        <p:spPr>
-          <a:xfrm>
-            <a:off x="502920" y="5724144"/>
-            <a:ext cx="219456" cy="219456"/>
-          </a:xfrm>
-          <a:prstGeom prst="ellipse">
-            <a:avLst/>
-          </a:prstGeom>
-          <a:solidFill>
-            <a:srgbClr val="0B6B5D"/>
-          </a:solidFill>
-          <a:ln/>
-        </p:spPr>
-      </p:sp>
-      <p:sp>
-        <p:nvSpPr>
-          <p:cNvPr id="59" name="Text 56"/>
-          <p:cNvSpPr txBox="1"/>
-          <p:nvPr/>
-        </p:nvSpPr>
-        <p:spPr>
-          <a:xfrm>
-            <a:off x="502920" y="5724144"/>
-            <a:ext cx="219456" cy="219456"/>
-          </a:xfrm>
-          <a:prstGeom prst="rect">
-            <a:avLst/>
-          </a:prstGeom>
-          <a:noFill/>
-          <a:ln/>
-        </p:spPr>
-        <p:txBody>
-          <a:bodyPr wrap="square" lIns="0" tIns="0" rIns="0" bIns="0" rtlCol="0" anchor="ctr"/>
-          <a:lstStyle/>
-          <a:p>
-            <a:pPr algn="ctr" indent="0" marL="0">
-              <a:buNone/>
-            </a:pPr>
-            <a:r>
-              <a:rPr lang="en-US" sz="1100" b="1" dirty="0">
-                <a:solidFill>
-                  <a:srgbClr val="FFFFFF"/>
-                </a:solidFill>
-                <a:latin typeface="Arial" pitchFamily="34" charset="0"/>
-                <a:ea typeface="Arial" pitchFamily="34" charset="-122"/>
-                <a:cs typeface="Arial" pitchFamily="34" charset="-120"/>
-              </a:rPr>
-              <a:t>4</a:t>
-            </a:r>
-            <a:endParaRPr lang="en-US" sz="1100" dirty="0"/>
-          </a:p>
-        </p:txBody>
-      </p:sp>
-      <p:sp>
-        <p:nvSpPr>
-          <p:cNvPr id="60" name="Text 57"/>
-          <p:cNvSpPr txBox="1"/>
-          <p:nvPr/>
-        </p:nvSpPr>
-        <p:spPr>
-          <a:xfrm>
-            <a:off x="813816" y="5705856"/>
-            <a:ext cx="5486400" cy="256032"/>
-          </a:xfrm>
-          <a:prstGeom prst="rect">
-            <a:avLst/>
-          </a:prstGeom>
-          <a:noFill/>
-          <a:ln/>
-        </p:spPr>
-        <p:txBody>
-          <a:bodyPr wrap="square" lIns="0" tIns="0" rIns="0" bIns="0" rtlCol="0" anchor="ctr"/>
-          <a:lstStyle/>
-          <a:p>
-            <a:pPr indent="0" marL="0">
-              <a:buNone/>
-            </a:pPr>
-            <a:r>
-              <a:rPr lang="en-US" sz="1350" b="1" dirty="0">
-                <a:solidFill>
-                  <a:srgbClr val="1F2A33"/>
-                </a:solidFill>
-                <a:latin typeface="Arial" pitchFamily="34" charset="0"/>
-                <a:ea typeface="Arial" pitchFamily="34" charset="-122"/>
-                <a:cs typeface="Arial" pitchFamily="34" charset="-120"/>
-              </a:rPr>
-              <a:t>Prioritize by size × ease — go easy-first</a:t>
-            </a:r>
-            <a:endParaRPr lang="en-US" sz="1350" dirty="0"/>
-          </a:p>
-        </p:txBody>
-      </p:sp>
-      <p:sp>
-        <p:nvSpPr>
-          <p:cNvPr id="61" name="Text 58"/>
-          <p:cNvSpPr txBox="1"/>
-          <p:nvPr/>
-        </p:nvSpPr>
-        <p:spPr>
-          <a:xfrm>
-            <a:off x="832104" y="5961888"/>
-            <a:ext cx="219456" cy="201168"/>
-          </a:xfrm>
-          <a:prstGeom prst="rect">
-            <a:avLst/>
-          </a:prstGeom>
-          <a:noFill/>
-          <a:ln/>
-        </p:spPr>
-        <p:txBody>
-          <a:bodyPr wrap="square" lIns="0" tIns="0" rIns="0" bIns="0" rtlCol="0" anchor="ctr"/>
-          <a:lstStyle/>
-          <a:p>
-            <a:pPr indent="0" marL="0">
-              <a:buNone/>
-            </a:pPr>
-            <a:r>
-              <a:rPr lang="en-US" sz="1050" b="1" dirty="0">
-                <a:solidFill>
-                  <a:srgbClr val="0B6B5D"/>
-                </a:solidFill>
-                <a:latin typeface="Arial" pitchFamily="34" charset="0"/>
-                <a:ea typeface="Arial" pitchFamily="34" charset="-122"/>
-                <a:cs typeface="Arial" pitchFamily="34" charset="-120"/>
-              </a:rPr>
-              <a:t>1.</a:t>
-            </a:r>
-            <a:endParaRPr lang="en-US" sz="1050" dirty="0"/>
-          </a:p>
-        </p:txBody>
-      </p:sp>
-      <p:sp>
-        <p:nvSpPr>
-          <p:cNvPr id="62" name="Text 59"/>
-          <p:cNvSpPr txBox="1"/>
-          <p:nvPr/>
-        </p:nvSpPr>
-        <p:spPr>
-          <a:xfrm>
-            <a:off x="1069848" y="5961888"/>
-            <a:ext cx="5486400" cy="201168"/>
-          </a:xfrm>
-          <a:prstGeom prst="rect">
-            <a:avLst/>
-          </a:prstGeom>
-          <a:noFill/>
-          <a:ln/>
-        </p:spPr>
-        <p:txBody>
-          <a:bodyPr wrap="square" lIns="0" tIns="0" rIns="0" bIns="0" rtlCol="0" anchor="ctr"/>
-          <a:lstStyle/>
-          <a:p>
-            <a:pPr indent="0" marL="0">
-              <a:buNone/>
-            </a:pPr>
-            <a:r>
-              <a:rPr lang="en-US" sz="1050" b="1" dirty="0">
-                <a:solidFill>
-                  <a:srgbClr val="1F2A33"/>
-                </a:solidFill>
-                <a:latin typeface="Arial" pitchFamily="34" charset="0"/>
-                <a:ea typeface="Arial" pitchFamily="34" charset="-122"/>
-                <a:cs typeface="Arial" pitchFamily="34" charset="-120"/>
-              </a:rPr>
-              <a:t>Data prep &amp; cleaning   </a:t>
-            </a:r>
-            <a:pPr indent="0" marL="0">
-              <a:buNone/>
-            </a:pPr>
-            <a:r>
-              <a:rPr lang="en-US" sz="1050" dirty="0">
-                <a:solidFill>
-                  <a:srgbClr val="5C6B77"/>
-                </a:solidFill>
-                <a:latin typeface="Arial" pitchFamily="34" charset="0"/>
-                <a:ea typeface="Arial" pitchFamily="34" charset="-122"/>
-                <a:cs typeface="Arial" pitchFamily="34" charset="-120"/>
-              </a:rPr>
-              <a:t>$6.8M pool — the agentic backbone starts here</a:t>
-            </a:r>
-            <a:endParaRPr lang="en-US" sz="1050" dirty="0"/>
-          </a:p>
-        </p:txBody>
-      </p:sp>
-      <p:sp>
-        <p:nvSpPr>
-          <p:cNvPr id="63" name="Text 60"/>
-          <p:cNvSpPr txBox="1"/>
-          <p:nvPr/>
-        </p:nvSpPr>
-        <p:spPr>
-          <a:xfrm>
-            <a:off x="832104" y="6190488"/>
-            <a:ext cx="219456" cy="201168"/>
-          </a:xfrm>
-          <a:prstGeom prst="rect">
-            <a:avLst/>
-          </a:prstGeom>
-          <a:noFill/>
-          <a:ln/>
-        </p:spPr>
-        <p:txBody>
-          <a:bodyPr wrap="square" lIns="0" tIns="0" rIns="0" bIns="0" rtlCol="0" anchor="ctr"/>
-          <a:lstStyle/>
-          <a:p>
-            <a:pPr indent="0" marL="0">
-              <a:buNone/>
-            </a:pPr>
-            <a:r>
-              <a:rPr lang="en-US" sz="1050" b="1" dirty="0">
-                <a:solidFill>
-                  <a:srgbClr val="0B6B5D"/>
-                </a:solidFill>
-                <a:latin typeface="Arial" pitchFamily="34" charset="0"/>
-                <a:ea typeface="Arial" pitchFamily="34" charset="-122"/>
-                <a:cs typeface="Arial" pitchFamily="34" charset="-120"/>
-              </a:rPr>
-              <a:t>2.</a:t>
-            </a:r>
-            <a:endParaRPr lang="en-US" sz="1050" dirty="0"/>
-          </a:p>
-        </p:txBody>
-      </p:sp>
-      <p:sp>
-        <p:nvSpPr>
-          <p:cNvPr id="64" name="Text 61"/>
-          <p:cNvSpPr txBox="1"/>
-          <p:nvPr/>
-        </p:nvSpPr>
-        <p:spPr>
-          <a:xfrm>
-            <a:off x="1069848" y="6190488"/>
-            <a:ext cx="5486400" cy="201168"/>
-          </a:xfrm>
-          <a:prstGeom prst="rect">
-            <a:avLst/>
-          </a:prstGeom>
-          <a:noFill/>
-          <a:ln/>
-        </p:spPr>
-        <p:txBody>
-          <a:bodyPr wrap="square" lIns="0" tIns="0" rIns="0" bIns="0" rtlCol="0" anchor="ctr"/>
-          <a:lstStyle/>
-          <a:p>
-            <a:pPr indent="0" marL="0">
-              <a:buNone/>
-            </a:pPr>
-            <a:r>
-              <a:rPr lang="en-US" sz="1050" b="1" dirty="0">
-                <a:solidFill>
-                  <a:srgbClr val="1F2A33"/>
-                </a:solidFill>
-                <a:latin typeface="Arial" pitchFamily="34" charset="0"/>
-                <a:ea typeface="Arial" pitchFamily="34" charset="-122"/>
-                <a:cs typeface="Arial" pitchFamily="34" charset="-120"/>
-              </a:rPr>
-              <a:t>Reporting &amp; documentation   </a:t>
-            </a:r>
-            <a:pPr indent="0" marL="0">
-              <a:buNone/>
-            </a:pPr>
-            <a:r>
-              <a:rPr lang="en-US" sz="1050" dirty="0">
-                <a:solidFill>
-                  <a:srgbClr val="5C6B77"/>
-                </a:solidFill>
-                <a:latin typeface="Arial" pitchFamily="34" charset="0"/>
-                <a:ea typeface="Arial" pitchFamily="34" charset="-122"/>
-                <a:cs typeface="Arial" pitchFamily="34" charset="-120"/>
-              </a:rPr>
-              <a:t>$3.4M pool — fast follow on the backbone</a:t>
-            </a:r>
-            <a:endParaRPr lang="en-US" sz="1050" dirty="0"/>
-          </a:p>
-        </p:txBody>
-      </p:sp>
-      <p:sp>
-        <p:nvSpPr>
-          <p:cNvPr id="65" name="Text 62"/>
-          <p:cNvSpPr txBox="1"/>
-          <p:nvPr/>
-        </p:nvSpPr>
-        <p:spPr>
-          <a:xfrm>
-            <a:off x="832104" y="6419088"/>
-            <a:ext cx="219456" cy="201168"/>
-          </a:xfrm>
-          <a:prstGeom prst="rect">
-            <a:avLst/>
-          </a:prstGeom>
-          <a:noFill/>
-          <a:ln/>
-        </p:spPr>
-        <p:txBody>
-          <a:bodyPr wrap="square" lIns="0" tIns="0" rIns="0" bIns="0" rtlCol="0" anchor="ctr"/>
-          <a:lstStyle/>
-          <a:p>
-            <a:pPr indent="0" marL="0">
-              <a:buNone/>
-            </a:pPr>
-            <a:r>
-              <a:rPr lang="en-US" sz="1050" b="1" dirty="0">
-                <a:solidFill>
-                  <a:srgbClr val="0B6B5D"/>
-                </a:solidFill>
-                <a:latin typeface="Arial" pitchFamily="34" charset="0"/>
-                <a:ea typeface="Arial" pitchFamily="34" charset="-122"/>
-                <a:cs typeface="Arial" pitchFamily="34" charset="-120"/>
-              </a:rPr>
-              <a:t>3.</a:t>
-            </a:r>
-            <a:endParaRPr lang="en-US" sz="1050" dirty="0"/>
-          </a:p>
-        </p:txBody>
-      </p:sp>
-      <p:sp>
-        <p:nvSpPr>
-          <p:cNvPr id="66" name="Text 63"/>
-          <p:cNvSpPr txBox="1"/>
-          <p:nvPr/>
-        </p:nvSpPr>
-        <p:spPr>
-          <a:xfrm>
-            <a:off x="1069848" y="6419088"/>
-            <a:ext cx="5486400" cy="201168"/>
-          </a:xfrm>
-          <a:prstGeom prst="rect">
-            <a:avLst/>
-          </a:prstGeom>
-          <a:noFill/>
-          <a:ln/>
-        </p:spPr>
-        <p:txBody>
-          <a:bodyPr wrap="square" lIns="0" tIns="0" rIns="0" bIns="0" rtlCol="0" anchor="ctr"/>
-          <a:lstStyle/>
-          <a:p>
-            <a:pPr indent="0" marL="0">
-              <a:buNone/>
-            </a:pPr>
-            <a:r>
-              <a:rPr lang="en-US" sz="1050" b="1" dirty="0">
-                <a:solidFill>
-                  <a:srgbClr val="1F2A33"/>
-                </a:solidFill>
-                <a:latin typeface="Arial" pitchFamily="34" charset="0"/>
-                <a:ea typeface="Arial" pitchFamily="34" charset="-122"/>
-                <a:cs typeface="Arial" pitchFamily="34" charset="-120"/>
-              </a:rPr>
-              <a:t>Model build &amp; experiments   </a:t>
-            </a:r>
-            <a:pPr indent="0" marL="0">
-              <a:buNone/>
-            </a:pPr>
-            <a:r>
-              <a:rPr lang="en-US" sz="1050" dirty="0">
-                <a:solidFill>
-                  <a:srgbClr val="5C6B77"/>
-                </a:solidFill>
-                <a:latin typeface="Arial" pitchFamily="34" charset="0"/>
-                <a:ea typeface="Arial" pitchFamily="34" charset="-122"/>
-                <a:cs typeface="Arial" pitchFamily="34" charset="-120"/>
-              </a:rPr>
-              <a:t>$2.7M pool — wave 2</a:t>
-            </a:r>
-            <a:endParaRPr lang="en-US" sz="1050" dirty="0"/>
-          </a:p>
-        </p:txBody>
-      </p:sp>
-      <p:sp>
-        <p:nvSpPr>
-          <p:cNvPr id="67" name="Shape 64"/>
           <p:cNvSpPr/>
           <p:nvPr/>
         </p:nvSpPr>
@@ -3095,7 +2681,7 @@
       </p:sp>
       <p:sp>
         <p:nvSpPr>
-          <p:cNvPr id="68" name="Text 65"/>
+          <p:cNvPr id="53" name="Text 50"/>
           <p:cNvSpPr txBox="1"/>
           <p:nvPr/>
         </p:nvSpPr>
@@ -3134,7 +2720,7 @@
       </p:sp>
       <p:sp>
         <p:nvSpPr>
-          <p:cNvPr id="69" name="Text 66"/>
+          <p:cNvPr id="54" name="Text 51"/>
           <p:cNvSpPr txBox="1"/>
           <p:nvPr/>
         </p:nvSpPr>
@@ -3173,7 +2759,7 @@
       </p:sp>
       <p:sp>
         <p:nvSpPr>
-          <p:cNvPr id="70" name="Text 67"/>
+          <p:cNvPr id="55" name="Text 52"/>
           <p:cNvSpPr txBox="1"/>
           <p:nvPr/>
         </p:nvSpPr>
@@ -3240,7 +2826,7 @@
       </p:sp>
       <p:sp>
         <p:nvSpPr>
-          <p:cNvPr id="71" name="Shape 68"/>
+          <p:cNvPr id="56" name="Shape 53"/>
           <p:cNvSpPr/>
           <p:nvPr/>
         </p:nvSpPr>
@@ -3260,7 +2846,7 @@
       </p:sp>
       <p:sp>
         <p:nvSpPr>
-          <p:cNvPr id="72" name="Text 69"/>
+          <p:cNvPr id="57" name="Text 54"/>
           <p:cNvSpPr txBox="1"/>
           <p:nvPr/>
         </p:nvSpPr>
@@ -3299,7 +2885,7 @@
       </p:sp>
       <p:sp>
         <p:nvSpPr>
-          <p:cNvPr id="73" name="Text 70"/>
+          <p:cNvPr id="58" name="Text 55"/>
           <p:cNvSpPr txBox="1"/>
           <p:nvPr/>
         </p:nvSpPr>
@@ -3338,7 +2924,7 @@
       </p:sp>
       <p:sp>
         <p:nvSpPr>
-          <p:cNvPr id="74" name="Shape 71"/>
+          <p:cNvPr id="59" name="Shape 56"/>
           <p:cNvSpPr/>
           <p:nvPr/>
         </p:nvSpPr>
@@ -3358,7 +2944,7 @@
       </p:sp>
       <p:sp>
         <p:nvSpPr>
-          <p:cNvPr id="75" name="Text 72"/>
+          <p:cNvPr id="60" name="Text 57"/>
           <p:cNvSpPr txBox="1"/>
           <p:nvPr/>
         </p:nvSpPr>
@@ -3397,7 +2983,7 @@
       </p:sp>
       <p:sp>
         <p:nvSpPr>
-          <p:cNvPr id="76" name="Text 73"/>
+          <p:cNvPr id="61" name="Text 58"/>
           <p:cNvSpPr txBox="1"/>
           <p:nvPr/>
         </p:nvSpPr>
@@ -3436,7 +3022,7 @@
       </p:sp>
       <p:sp>
         <p:nvSpPr>
-          <p:cNvPr id="77" name="Shape 74"/>
+          <p:cNvPr id="62" name="Shape 59"/>
           <p:cNvSpPr/>
           <p:nvPr/>
         </p:nvSpPr>
@@ -3456,7 +3042,7 @@
       </p:sp>
       <p:sp>
         <p:nvSpPr>
-          <p:cNvPr id="78" name="Text 75"/>
+          <p:cNvPr id="63" name="Text 60"/>
           <p:cNvSpPr txBox="1"/>
           <p:nvPr/>
         </p:nvSpPr>
@@ -3495,7 +3081,7 @@
       </p:sp>
       <p:sp>
         <p:nvSpPr>
-          <p:cNvPr id="79" name="Text 76"/>
+          <p:cNvPr id="64" name="Text 61"/>
           <p:cNvSpPr txBox="1"/>
           <p:nvPr/>
         </p:nvSpPr>
@@ -3534,7 +3120,7 @@
       </p:sp>
       <p:sp>
         <p:nvSpPr>
-          <p:cNvPr id="80" name="Shape 77"/>
+          <p:cNvPr id="65" name="Shape 62"/>
           <p:cNvSpPr/>
           <p:nvPr/>
         </p:nvSpPr>
@@ -3554,7 +3140,7 @@
       </p:sp>
       <p:sp>
         <p:nvSpPr>
-          <p:cNvPr id="81" name="Text 78"/>
+          <p:cNvPr id="66" name="Text 63"/>
           <p:cNvSpPr txBox="1"/>
           <p:nvPr/>
         </p:nvSpPr>
@@ -3593,7 +3179,7 @@
       </p:sp>
       <p:sp>
         <p:nvSpPr>
-          <p:cNvPr id="82" name="Text 79"/>
+          <p:cNvPr id="67" name="Text 64"/>
           <p:cNvSpPr txBox="1"/>
           <p:nvPr/>
         </p:nvSpPr>
@@ -3632,7 +3218,7 @@
       </p:sp>
       <p:sp>
         <p:nvSpPr>
-          <p:cNvPr id="83" name="Text 80"/>
+          <p:cNvPr id="68" name="Text 65"/>
           <p:cNvSpPr txBox="1"/>
           <p:nvPr/>
         </p:nvSpPr>
@@ -3671,7 +3257,7 @@
       </p:sp>
       <p:sp>
         <p:nvSpPr>
-          <p:cNvPr id="84" name="Text 81"/>
+          <p:cNvPr id="69" name="Text 66"/>
           <p:cNvSpPr txBox="1"/>
           <p:nvPr/>
         </p:nvSpPr>
@@ -3710,7 +3296,7 @@
       </p:sp>
       <p:sp>
         <p:nvSpPr>
-          <p:cNvPr id="85" name="Text 82"/>
+          <p:cNvPr id="70" name="Text 67"/>
           <p:cNvSpPr txBox="1"/>
           <p:nvPr/>
         </p:nvSpPr>
@@ -3749,7 +3335,7 @@
       </p:sp>
       <p:sp>
         <p:nvSpPr>
-          <p:cNvPr id="86" name="Text 83"/>
+          <p:cNvPr id="71" name="Text 68"/>
           <p:cNvSpPr txBox="1"/>
           <p:nvPr/>
         </p:nvSpPr>
@@ -3788,7 +3374,7 @@
       </p:sp>
       <p:sp>
         <p:nvSpPr>
-          <p:cNvPr id="87" name="Text 84"/>
+          <p:cNvPr id="72" name="Text 69"/>
           <p:cNvSpPr txBox="1"/>
           <p:nvPr/>
         </p:nvSpPr>
@@ -3827,7 +3413,7 @@
       </p:sp>
       <p:sp>
         <p:nvSpPr>
-          <p:cNvPr id="88" name="Text 85"/>
+          <p:cNvPr id="73" name="Text 70"/>
           <p:cNvSpPr txBox="1"/>
           <p:nvPr/>
         </p:nvSpPr>
@@ -3866,7 +3452,7 @@
       </p:sp>
       <p:sp>
         <p:nvSpPr>
-          <p:cNvPr id="89" name="Text 86"/>
+          <p:cNvPr id="74" name="Text 71"/>
           <p:cNvSpPr txBox="1"/>
           <p:nvPr/>
         </p:nvSpPr>
@@ -3905,7 +3491,7 @@
       </p:sp>
       <p:sp>
         <p:nvSpPr>
-          <p:cNvPr id="90" name="Shape 87"/>
+          <p:cNvPr id="75" name="Shape 72"/>
           <p:cNvSpPr/>
           <p:nvPr/>
         </p:nvSpPr>
@@ -3928,7 +3514,7 @@
       </p:sp>
       <p:sp>
         <p:nvSpPr>
-          <p:cNvPr id="91" name="Text 88"/>
+          <p:cNvPr id="76" name="Text 73"/>
           <p:cNvSpPr txBox="1"/>
           <p:nvPr/>
         </p:nvSpPr>
@@ -3995,7 +3581,7 @@
       </p:sp>
       <p:sp>
         <p:nvSpPr>
-          <p:cNvPr id="92" name="Text 89"/>
+          <p:cNvPr id="77" name="Text 74"/>
           <p:cNvSpPr txBox="1"/>
           <p:nvPr/>
         </p:nvSpPr>
@@ -4034,7 +3620,7 @@
       </p:sp>
       <p:sp>
         <p:nvSpPr>
-          <p:cNvPr id="93" name="Text 90"/>
+          <p:cNvPr id="78" name="Text 75"/>
           <p:cNvSpPr txBox="1"/>
           <p:nvPr/>
         </p:nvSpPr>
@@ -4073,7 +3659,7 @@
       </p:sp>
       <p:sp>
         <p:nvSpPr>
-          <p:cNvPr id="94" name="Text 91"/>
+          <p:cNvPr id="79" name="Text 76"/>
           <p:cNvSpPr txBox="1"/>
           <p:nvPr/>
         </p:nvSpPr>
@@ -4112,7 +3698,7 @@
       </p:sp>
       <p:sp>
         <p:nvSpPr>
-          <p:cNvPr id="95" name="Text 92"/>
+          <p:cNvPr id="80" name="Text 77"/>
           <p:cNvSpPr txBox="1"/>
           <p:nvPr/>
         </p:nvSpPr>
@@ -4151,7 +3737,7 @@
       </p:sp>
       <p:sp>
         <p:nvSpPr>
-          <p:cNvPr id="96" name="Text 93"/>
+          <p:cNvPr id="81" name="Text 78"/>
           <p:cNvSpPr txBox="1"/>
           <p:nvPr/>
         </p:nvSpPr>
@@ -4190,7 +3776,7 @@
       </p:sp>
       <p:sp>
         <p:nvSpPr>
-          <p:cNvPr id="97" name="Text 94"/>
+          <p:cNvPr id="82" name="Text 79"/>
           <p:cNvSpPr txBox="1"/>
           <p:nvPr/>
         </p:nvSpPr>
@@ -4229,7 +3815,7 @@
       </p:sp>
       <p:sp>
         <p:nvSpPr>
-          <p:cNvPr id="98" name="Text 95"/>
+          <p:cNvPr id="83" name="Text 80"/>
           <p:cNvSpPr txBox="1"/>
           <p:nvPr/>
         </p:nvSpPr>
@@ -4268,7 +3854,7 @@
       </p:sp>
       <p:sp>
         <p:nvSpPr>
-          <p:cNvPr id="99" name="Text 96"/>
+          <p:cNvPr id="84" name="Text 81"/>
           <p:cNvSpPr txBox="1"/>
           <p:nvPr/>
         </p:nvSpPr>
@@ -4299,7 +3885,7 @@
                 <a:ea typeface="Arial" pitchFamily="34" charset="-122"/>
                 <a:cs typeface="Arial" pitchFamily="34" charset="-120"/>
               </a:rPr>
-              <a:t>Illustrative — a walkthrough of the method, not a plan of record. Pools rounded to $0.1M. Detailed assumptions: backup slide.</a:t>
+              <a:t>Illustrative — a walkthrough of the method, not a plan of record. Detailed assumptions: backup slide.</a:t>
             </a:r>
             <a:endParaRPr lang="en-US" sz="800" dirty="0"/>
           </a:p>
@@ -4999,7 +4585,7 @@
                 <a:ea typeface="Arial" pitchFamily="34" charset="-122"/>
                 <a:cs typeface="Arial" pitchFamily="34" charset="-120"/>
               </a:rPr>
-              <a:t>$8.3M (~22% of cost base) is capacity — realized as hiring avoidance, throughput, or redeployment. Releasing vs reinvesting it is a leadership decision.</a:t>
+              <a:t>Capturable value is capacity — realized as hiring avoidance, throughput, or redeployment. Releasing vs reinvesting it is a leadership decision. Three activities are shown for clarity; a full sizing maps the whole week.</a:t>
             </a:r>
             <a:endParaRPr lang="en-US" sz="900" dirty="0"/>
           </a:p>

</xml_diff>

<commit_message>
Add AI reviewer checklist page: five gates before sign-off
New slide 2: gate / what-must-be-true / sent-back-when table covering
value mechanism, bottom-up math without double counting, full AI cost
including tokens, the CTO-style technical bar, and vendor
standardization, with an approve/return outcome strip.

Co-Authored-By: Claude <noreply@anthropic.com>
Claude-Session: https://claude.ai/code/session_01NFmLfQt1gGoL7VkhSjRDgY
</commit_message>
<xml_diff>
--- a/docs/sizing-example/ds-sizing-example.pptx
+++ b/docs/sizing-example/ds-sizing-example.pptx
@@ -7,9 +7,10 @@
   <p:sldIdLst>
     <p:sldId id="256" r:id="rId2"/>
     <p:sldId id="257" r:id="rId3"/>
+    <p:sldId id="258" r:id="rId4"/>
   </p:sldIdLst>
   <p:notesMasterIdLst>
-    <p:notesMasterId r:id="rId4"/>
+    <p:notesMasterId r:id="rId5"/>
   </p:notesMasterIdLst>
   <p:sldSz cx="12192000" cy="6858000"/>
   <p:notesSz cx="6858000" cy="12192000"/>
@@ -591,7 +592,7 @@
           <a:p>
             <a:r>
               <a:rPr lang="en-US" dirty="0"/>
-              <a:t>Backup: the assumptions behind every number on the worked example. Reuse the structure, not the numbers - replace each assumption with your own role's data.</a:t>
+              <a:t>The AI reviewer's checklist: the five gates the AI &amp; automation approver checks before sign-off. Finance approves the dollars separately; this review checks the AI substance so approval is not a rubber stamp. Teams use the same list as a pre-flight check before submitting.</a:t>
             </a:r>
             <a:endParaRPr lang="en-US" dirty="0"/>
           </a:p>
@@ -615,6 +616,94 @@
             <a:fld id="{F7021451-1387-4CA6-816F-3879F97B5CBC}" type="slidenum">
               <a:rPr lang="en-US"/>
               <a:t>2</a:t>
+            </a:fld>
+            <a:endParaRPr lang="en-US"/>
+          </a:p>
+        </p:txBody>
+      </p:sp>
+    </p:spTree>
+    <p:extLst>
+      <p:ext uri="{BB962C8B-B14F-4D97-AF65-F5344CB8AC3E}">
+        <p14:creationId xmlns:p14="http://schemas.microsoft.com/office/powerpoint/2010/main" val="1024086991"/>
+      </p:ext>
+    </p:extLst>
+  </p:cSld>
+  <p:clrMapOvr>
+    <a:masterClrMapping/>
+  </p:clrMapOvr>
+</p:notes>
+</file>
+
+<file path=ppt/notesSlides/notesSlide3.xml><?xml version="1.0" encoding="utf-8"?>
+<p:notes xmlns:a="http://schemas.openxmlformats.org/drawingml/2006/main" xmlns:r="http://schemas.openxmlformats.org/officeDocument/2006/relationships" xmlns:p="http://schemas.openxmlformats.org/presentationml/2006/main">
+  <p:cSld>
+    <p:spTree>
+      <p:nvGrpSpPr>
+        <p:cNvPr id="1" name=""/>
+        <p:cNvGrpSpPr/>
+        <p:nvPr/>
+      </p:nvGrpSpPr>
+      <p:grpSpPr>
+        <a:xfrm>
+          <a:off x="0" y="0"/>
+          <a:ext cx="0" cy="0"/>
+          <a:chOff x="0" y="0"/>
+          <a:chExt cx="0" cy="0"/>
+        </a:xfrm>
+      </p:grpSpPr>
+      <p:sp>
+        <p:nvSpPr>
+          <p:cNvPr id="2" name="Slide Image Placeholder 1"/>
+          <p:cNvSpPr>
+            <a:spLocks noGrp="1" noRot="1" noChangeAspect="1"/>
+          </p:cNvSpPr>
+          <p:nvPr>
+            <p:ph type="sldImg"/>
+          </p:nvPr>
+        </p:nvSpPr>
+        <p:spPr/>
+      </p:sp>
+      <p:sp>
+        <p:nvSpPr>
+          <p:cNvPr id="3" name="Notes Placeholder 2"/>
+          <p:cNvSpPr>
+            <a:spLocks noGrp="1"/>
+          </p:cNvSpPr>
+          <p:nvPr>
+            <p:ph type="body" idx="1"/>
+          </p:nvPr>
+        </p:nvSpPr>
+        <p:spPr/>
+        <p:txBody>
+          <a:bodyPr/>
+          <a:lstStyle/>
+          <a:p>
+            <a:r>
+              <a:rPr lang="en-US" dirty="0"/>
+              <a:t>Backup: the assumptions behind every number on the worked example. Reuse the structure, not the numbers - replace each assumption with your own role's data.</a:t>
+            </a:r>
+            <a:endParaRPr lang="en-US" dirty="0"/>
+          </a:p>
+        </p:txBody>
+      </p:sp>
+      <p:sp>
+        <p:nvSpPr>
+          <p:cNvPr id="4" name="Slide Number Placeholder 3"/>
+          <p:cNvSpPr>
+            <a:spLocks noGrp="1"/>
+          </p:cNvSpPr>
+          <p:nvPr>
+            <p:ph type="sldNum" sz="quarter" idx="10"/>
+          </p:nvPr>
+        </p:nvSpPr>
+        <p:spPr/>
+        <p:txBody>
+          <a:bodyPr/>
+          <a:lstStyle/>
+          <a:p>
+            <a:fld id="{F7021451-1387-4CA6-816F-3879F97B5CBC}" type="slidenum">
+              <a:rPr lang="en-US"/>
+              <a:t>3</a:t>
             </a:fld>
             <a:endParaRPr lang="en-US"/>
           </a:p>
@@ -3956,6 +4045,1456 @@
                 <a:ea typeface="Arial" pitchFamily="34" charset="-122"/>
                 <a:cs typeface="Arial" pitchFamily="34" charset="-120"/>
               </a:rPr>
+              <a:t>AI TRANSFORMATION  ·  INVESTMENT-CASE REVIEW</a:t>
+            </a:r>
+            <a:endParaRPr lang="en-US" sz="900" dirty="0"/>
+          </a:p>
+        </p:txBody>
+      </p:sp>
+      <p:sp>
+        <p:nvSpPr>
+          <p:cNvPr id="4" name="Text 1"/>
+          <p:cNvSpPr txBox="1"/>
+          <p:nvPr/>
+        </p:nvSpPr>
+        <p:spPr>
+          <a:xfrm>
+            <a:off x="502920" y="438912"/>
+            <a:ext cx="9326880" cy="384048"/>
+          </a:xfrm>
+          <a:prstGeom prst="rect">
+            <a:avLst/>
+          </a:prstGeom>
+          <a:noFill/>
+          <a:ln/>
+        </p:spPr>
+        <p:txBody>
+          <a:bodyPr wrap="square" lIns="0" tIns="0" rIns="0" bIns="0" rtlCol="0" anchor="ctr"/>
+          <a:lstStyle/>
+          <a:p>
+            <a:pPr indent="0" marL="0">
+              <a:buNone/>
+            </a:pPr>
+            <a:r>
+              <a:rPr lang="en-US" sz="2000" b="1" dirty="0">
+                <a:solidFill>
+                  <a:srgbClr val="1F2A33"/>
+                </a:solidFill>
+                <a:latin typeface="Arial" pitchFamily="34" charset="0"/>
+                <a:ea typeface="Arial" pitchFamily="34" charset="-122"/>
+                <a:cs typeface="Arial" pitchFamily="34" charset="-120"/>
+              </a:rPr>
+              <a:t>The AI reviewer’s checklist — five gates before sign-off</a:t>
+            </a:r>
+            <a:endParaRPr lang="en-US" sz="2000" dirty="0"/>
+          </a:p>
+        </p:txBody>
+      </p:sp>
+      <p:sp>
+        <p:nvSpPr>
+          <p:cNvPr id="5" name="Shape 2"/>
+          <p:cNvSpPr/>
+          <p:nvPr/>
+        </p:nvSpPr>
+        <p:spPr>
+          <a:xfrm>
+            <a:off x="10058400" y="365760"/>
+            <a:ext cx="1673352" cy="310896"/>
+          </a:xfrm>
+          <a:prstGeom prst="roundRect">
+            <a:avLst>
+              <a:gd name="adj" fmla="val 50000"/>
+            </a:avLst>
+          </a:prstGeom>
+          <a:solidFill>
+            <a:srgbClr val="0B6B5D"/>
+          </a:solidFill>
+          <a:ln/>
+        </p:spPr>
+      </p:sp>
+      <p:sp>
+        <p:nvSpPr>
+          <p:cNvPr id="6" name="Text 3"/>
+          <p:cNvSpPr txBox="1"/>
+          <p:nvPr/>
+        </p:nvSpPr>
+        <p:spPr>
+          <a:xfrm>
+            <a:off x="10058400" y="365760"/>
+            <a:ext cx="1673352" cy="310896"/>
+          </a:xfrm>
+          <a:prstGeom prst="rect">
+            <a:avLst/>
+          </a:prstGeom>
+          <a:noFill/>
+          <a:ln/>
+        </p:spPr>
+        <p:txBody>
+          <a:bodyPr wrap="square" lIns="0" tIns="0" rIns="0" bIns="0" rtlCol="0" anchor="ctr"/>
+          <a:lstStyle/>
+          <a:p>
+            <a:pPr algn="ctr" indent="0" marL="0">
+              <a:buNone/>
+            </a:pPr>
+            <a:r>
+              <a:rPr lang="en-US" sz="850" b="1" spc="150" kern="0" dirty="0">
+                <a:solidFill>
+                  <a:srgbClr val="FFFFFF"/>
+                </a:solidFill>
+                <a:latin typeface="Arial" pitchFamily="34" charset="0"/>
+                <a:ea typeface="Arial" pitchFamily="34" charset="-122"/>
+                <a:cs typeface="Arial" pitchFamily="34" charset="-120"/>
+              </a:rPr>
+              <a:t>FOR APPROVERS</a:t>
+            </a:r>
+            <a:endParaRPr lang="en-US" sz="850" dirty="0"/>
+          </a:p>
+        </p:txBody>
+      </p:sp>
+      <p:sp>
+        <p:nvSpPr>
+          <p:cNvPr id="7" name="Text 4"/>
+          <p:cNvSpPr txBox="1"/>
+          <p:nvPr/>
+        </p:nvSpPr>
+        <p:spPr>
+          <a:xfrm>
+            <a:off x="502920" y="896112"/>
+            <a:ext cx="10607040" cy="219456"/>
+          </a:xfrm>
+          <a:prstGeom prst="rect">
+            <a:avLst/>
+          </a:prstGeom>
+          <a:noFill/>
+          <a:ln/>
+        </p:spPr>
+        <p:txBody>
+          <a:bodyPr wrap="square" lIns="0" tIns="0" rIns="0" bIns="0" rtlCol="0" anchor="ctr"/>
+          <a:lstStyle/>
+          <a:p>
+            <a:pPr indent="0" marL="0">
+              <a:buNone/>
+            </a:pPr>
+            <a:r>
+              <a:rPr lang="en-US" sz="1100" dirty="0">
+                <a:solidFill>
+                  <a:srgbClr val="5C6B77"/>
+                </a:solidFill>
+                <a:latin typeface="Arial" pitchFamily="34" charset="0"/>
+                <a:ea typeface="Arial" pitchFamily="34" charset="-122"/>
+                <a:cs typeface="Arial" pitchFamily="34" charset="-120"/>
+              </a:rPr>
+              <a:t>Finance approves the dollars. This review checks the AI substance — so sign-off is never a rubber stamp. Teams: run the same five gates before you submit.</a:t>
+            </a:r>
+            <a:endParaRPr lang="en-US" sz="1100" dirty="0"/>
+          </a:p>
+        </p:txBody>
+      </p:sp>
+      <p:sp>
+        <p:nvSpPr>
+          <p:cNvPr id="8" name="Text 5"/>
+          <p:cNvSpPr txBox="1"/>
+          <p:nvPr/>
+        </p:nvSpPr>
+        <p:spPr>
+          <a:xfrm>
+            <a:off x="868680" y="1353312"/>
+            <a:ext cx="2423160" cy="182880"/>
+          </a:xfrm>
+          <a:prstGeom prst="rect">
+            <a:avLst/>
+          </a:prstGeom>
+          <a:noFill/>
+          <a:ln/>
+        </p:spPr>
+        <p:txBody>
+          <a:bodyPr wrap="square" lIns="0" tIns="0" rIns="0" bIns="0" rtlCol="0" anchor="ctr"/>
+          <a:lstStyle/>
+          <a:p>
+            <a:pPr indent="0" marL="0">
+              <a:buNone/>
+            </a:pPr>
+            <a:r>
+              <a:rPr lang="en-US" sz="900" b="1" spc="200" kern="0" dirty="0">
+                <a:solidFill>
+                  <a:srgbClr val="8B98A2"/>
+                </a:solidFill>
+                <a:latin typeface="Arial" pitchFamily="34" charset="0"/>
+                <a:ea typeface="Arial" pitchFamily="34" charset="-122"/>
+                <a:cs typeface="Arial" pitchFamily="34" charset="-120"/>
+              </a:rPr>
+              <a:t>GATE</a:t>
+            </a:r>
+            <a:endParaRPr lang="en-US" sz="900" dirty="0"/>
+          </a:p>
+        </p:txBody>
+      </p:sp>
+      <p:sp>
+        <p:nvSpPr>
+          <p:cNvPr id="9" name="Text 6"/>
+          <p:cNvSpPr txBox="1"/>
+          <p:nvPr/>
+        </p:nvSpPr>
+        <p:spPr>
+          <a:xfrm>
+            <a:off x="3520440" y="1353312"/>
+            <a:ext cx="4160520" cy="182880"/>
+          </a:xfrm>
+          <a:prstGeom prst="rect">
+            <a:avLst/>
+          </a:prstGeom>
+          <a:noFill/>
+          <a:ln/>
+        </p:spPr>
+        <p:txBody>
+          <a:bodyPr wrap="square" lIns="0" tIns="0" rIns="0" bIns="0" rtlCol="0" anchor="ctr"/>
+          <a:lstStyle/>
+          <a:p>
+            <a:pPr indent="0" marL="0">
+              <a:buNone/>
+            </a:pPr>
+            <a:r>
+              <a:rPr lang="en-US" sz="900" b="1" spc="200" kern="0" dirty="0">
+                <a:solidFill>
+                  <a:srgbClr val="8B98A2"/>
+                </a:solidFill>
+                <a:latin typeface="Arial" pitchFamily="34" charset="0"/>
+                <a:ea typeface="Arial" pitchFamily="34" charset="-122"/>
+                <a:cs typeface="Arial" pitchFamily="34" charset="-120"/>
+              </a:rPr>
+              <a:t>WHAT MUST BE TRUE</a:t>
+            </a:r>
+            <a:endParaRPr lang="en-US" sz="900" dirty="0"/>
+          </a:p>
+        </p:txBody>
+      </p:sp>
+      <p:sp>
+        <p:nvSpPr>
+          <p:cNvPr id="10" name="Text 7"/>
+          <p:cNvSpPr txBox="1"/>
+          <p:nvPr/>
+        </p:nvSpPr>
+        <p:spPr>
+          <a:xfrm>
+            <a:off x="7955280" y="1353312"/>
+            <a:ext cx="3749040" cy="182880"/>
+          </a:xfrm>
+          <a:prstGeom prst="rect">
+            <a:avLst/>
+          </a:prstGeom>
+          <a:noFill/>
+          <a:ln/>
+        </p:spPr>
+        <p:txBody>
+          <a:bodyPr wrap="square" lIns="0" tIns="0" rIns="0" bIns="0" rtlCol="0" anchor="ctr"/>
+          <a:lstStyle/>
+          <a:p>
+            <a:pPr indent="0" marL="0">
+              <a:buNone/>
+            </a:pPr>
+            <a:r>
+              <a:rPr lang="en-US" sz="900" b="1" spc="200" kern="0" dirty="0">
+                <a:solidFill>
+                  <a:srgbClr val="8B98A2"/>
+                </a:solidFill>
+                <a:latin typeface="Arial" pitchFamily="34" charset="0"/>
+                <a:ea typeface="Arial" pitchFamily="34" charset="-122"/>
+                <a:cs typeface="Arial" pitchFamily="34" charset="-120"/>
+              </a:rPr>
+              <a:t>SENT BACK WHEN…</a:t>
+            </a:r>
+            <a:endParaRPr lang="en-US" sz="900" dirty="0"/>
+          </a:p>
+        </p:txBody>
+      </p:sp>
+      <p:sp>
+        <p:nvSpPr>
+          <p:cNvPr id="11" name="Shape 8"/>
+          <p:cNvSpPr/>
+          <p:nvPr/>
+        </p:nvSpPr>
+        <p:spPr>
+          <a:xfrm>
+            <a:off x="502920" y="1591056"/>
+            <a:ext cx="11201400" cy="0"/>
+          </a:xfrm>
+          <a:prstGeom prst="line">
+            <a:avLst/>
+          </a:prstGeom>
+          <a:noFill/>
+          <a:ln w="9525">
+            <a:solidFill>
+              <a:srgbClr val="DCE3E8"/>
+            </a:solidFill>
+            <a:prstDash val="solid"/>
+          </a:ln>
+        </p:spPr>
+      </p:sp>
+      <p:sp>
+        <p:nvSpPr>
+          <p:cNvPr id="12" name="Shape 9"/>
+          <p:cNvSpPr/>
+          <p:nvPr/>
+        </p:nvSpPr>
+        <p:spPr>
+          <a:xfrm>
+            <a:off x="502920" y="1719072"/>
+            <a:ext cx="237744" cy="237744"/>
+          </a:xfrm>
+          <a:prstGeom prst="ellipse">
+            <a:avLst/>
+          </a:prstGeom>
+          <a:solidFill>
+            <a:srgbClr val="0B6B5D"/>
+          </a:solidFill>
+          <a:ln/>
+        </p:spPr>
+      </p:sp>
+      <p:sp>
+        <p:nvSpPr>
+          <p:cNvPr id="13" name="Text 10"/>
+          <p:cNvSpPr txBox="1"/>
+          <p:nvPr/>
+        </p:nvSpPr>
+        <p:spPr>
+          <a:xfrm>
+            <a:off x="502920" y="1719072"/>
+            <a:ext cx="237744" cy="237744"/>
+          </a:xfrm>
+          <a:prstGeom prst="rect">
+            <a:avLst/>
+          </a:prstGeom>
+          <a:noFill/>
+          <a:ln/>
+        </p:spPr>
+        <p:txBody>
+          <a:bodyPr wrap="square" lIns="0" tIns="0" rIns="0" bIns="0" rtlCol="0" anchor="ctr"/>
+          <a:lstStyle/>
+          <a:p>
+            <a:pPr algn="ctr" indent="0" marL="0">
+              <a:buNone/>
+            </a:pPr>
+            <a:r>
+              <a:rPr lang="en-US" sz="1100" b="1" dirty="0">
+                <a:solidFill>
+                  <a:srgbClr val="FFFFFF"/>
+                </a:solidFill>
+                <a:latin typeface="Arial" pitchFamily="34" charset="0"/>
+                <a:ea typeface="Arial" pitchFamily="34" charset="-122"/>
+                <a:cs typeface="Arial" pitchFamily="34" charset="-120"/>
+              </a:rPr>
+              <a:t>1</a:t>
+            </a:r>
+            <a:endParaRPr lang="en-US" sz="1100" dirty="0"/>
+          </a:p>
+        </p:txBody>
+      </p:sp>
+      <p:sp>
+        <p:nvSpPr>
+          <p:cNvPr id="14" name="Text 11"/>
+          <p:cNvSpPr txBox="1"/>
+          <p:nvPr/>
+        </p:nvSpPr>
+        <p:spPr>
+          <a:xfrm>
+            <a:off x="868680" y="1700784"/>
+            <a:ext cx="2423160" cy="512064"/>
+          </a:xfrm>
+          <a:prstGeom prst="rect">
+            <a:avLst/>
+          </a:prstGeom>
+          <a:noFill/>
+          <a:ln/>
+        </p:spPr>
+        <p:txBody>
+          <a:bodyPr wrap="square" lIns="0" tIns="0" rIns="0" bIns="0" rtlCol="0" anchor="t"/>
+          <a:lstStyle/>
+          <a:p>
+            <a:pPr indent="0" marL="0">
+              <a:buNone/>
+            </a:pPr>
+            <a:r>
+              <a:rPr lang="en-US" sz="1250" b="1" dirty="0">
+                <a:solidFill>
+                  <a:srgbClr val="1F2A33"/>
+                </a:solidFill>
+                <a:latin typeface="Arial" pitchFamily="34" charset="0"/>
+                <a:ea typeface="Arial" pitchFamily="34" charset="-122"/>
+                <a:cs typeface="Arial" pitchFamily="34" charset="-120"/>
+              </a:rPr>
+              <a:t>AI creates the value</a:t>
+            </a:r>
+            <a:endParaRPr lang="en-US" sz="1250" dirty="0"/>
+          </a:p>
+        </p:txBody>
+      </p:sp>
+      <p:sp>
+        <p:nvSpPr>
+          <p:cNvPr id="15" name="Text 12"/>
+          <p:cNvSpPr txBox="1"/>
+          <p:nvPr/>
+        </p:nvSpPr>
+        <p:spPr>
+          <a:xfrm>
+            <a:off x="3520440" y="1700784"/>
+            <a:ext cx="4160520" cy="731520"/>
+          </a:xfrm>
+          <a:prstGeom prst="rect">
+            <a:avLst/>
+          </a:prstGeom>
+          <a:noFill/>
+          <a:ln/>
+        </p:spPr>
+        <p:txBody>
+          <a:bodyPr wrap="square" lIns="0" tIns="0" rIns="0" bIns="0" rtlCol="0" anchor="t"/>
+          <a:lstStyle/>
+          <a:p>
+            <a:pPr indent="0" marL="0">
+              <a:buNone/>
+            </a:pPr>
+            <a:r>
+              <a:rPr lang="en-US" sz="1000" dirty="0">
+                <a:solidFill>
+                  <a:srgbClr val="1F2A33"/>
+                </a:solidFill>
+                <a:latin typeface="Arial" pitchFamily="34" charset="0"/>
+                <a:ea typeface="Arial" pitchFamily="34" charset="-122"/>
+                <a:cs typeface="Arial" pitchFamily="34" charset="-120"/>
+              </a:rPr>
+              <a:t>The problem is clear and the mechanism is explicit: which workflow, what the AI or agent actually does, and why that produces the number.</a:t>
+            </a:r>
+            <a:endParaRPr lang="en-US" sz="1000" dirty="0"/>
+          </a:p>
+        </p:txBody>
+      </p:sp>
+      <p:sp>
+        <p:nvSpPr>
+          <p:cNvPr id="16" name="Text 13"/>
+          <p:cNvSpPr txBox="1"/>
+          <p:nvPr/>
+        </p:nvSpPr>
+        <p:spPr>
+          <a:xfrm>
+            <a:off x="7955280" y="1700784"/>
+            <a:ext cx="3749040" cy="731520"/>
+          </a:xfrm>
+          <a:prstGeom prst="rect">
+            <a:avLst/>
+          </a:prstGeom>
+          <a:noFill/>
+          <a:ln/>
+        </p:spPr>
+        <p:txBody>
+          <a:bodyPr wrap="square" lIns="0" tIns="0" rIns="0" bIns="0" rtlCol="0" anchor="t"/>
+          <a:lstStyle/>
+          <a:p>
+            <a:pPr indent="0" marL="0">
+              <a:buNone/>
+            </a:pPr>
+            <a:r>
+              <a:rPr lang="en-US" sz="1000" i="1" dirty="0">
+                <a:solidFill>
+                  <a:srgbClr val="9A5A0B"/>
+                </a:solidFill>
+                <a:latin typeface="Arial" pitchFamily="34" charset="0"/>
+                <a:ea typeface="Arial" pitchFamily="34" charset="-122"/>
+                <a:cs typeface="Arial" pitchFamily="34" charset="-120"/>
+              </a:rPr>
+              <a:t>“AI” only appears in the title — the value really comes from ordinary process change.</a:t>
+            </a:r>
+            <a:endParaRPr lang="en-US" sz="1000" dirty="0"/>
+          </a:p>
+        </p:txBody>
+      </p:sp>
+      <p:sp>
+        <p:nvSpPr>
+          <p:cNvPr id="17" name="Shape 14"/>
+          <p:cNvSpPr/>
+          <p:nvPr/>
+        </p:nvSpPr>
+        <p:spPr>
+          <a:xfrm>
+            <a:off x="502920" y="2450592"/>
+            <a:ext cx="11201400" cy="0"/>
+          </a:xfrm>
+          <a:prstGeom prst="line">
+            <a:avLst/>
+          </a:prstGeom>
+          <a:noFill/>
+          <a:ln w="9525">
+            <a:solidFill>
+              <a:srgbClr val="DCE3E8"/>
+            </a:solidFill>
+            <a:prstDash val="solid"/>
+          </a:ln>
+        </p:spPr>
+      </p:sp>
+      <p:sp>
+        <p:nvSpPr>
+          <p:cNvPr id="18" name="Shape 15"/>
+          <p:cNvSpPr/>
+          <p:nvPr/>
+        </p:nvSpPr>
+        <p:spPr>
+          <a:xfrm>
+            <a:off x="502920" y="2578608"/>
+            <a:ext cx="237744" cy="237744"/>
+          </a:xfrm>
+          <a:prstGeom prst="ellipse">
+            <a:avLst/>
+          </a:prstGeom>
+          <a:solidFill>
+            <a:srgbClr val="0B6B5D"/>
+          </a:solidFill>
+          <a:ln/>
+        </p:spPr>
+      </p:sp>
+      <p:sp>
+        <p:nvSpPr>
+          <p:cNvPr id="19" name="Text 16"/>
+          <p:cNvSpPr txBox="1"/>
+          <p:nvPr/>
+        </p:nvSpPr>
+        <p:spPr>
+          <a:xfrm>
+            <a:off x="502920" y="2578608"/>
+            <a:ext cx="237744" cy="237744"/>
+          </a:xfrm>
+          <a:prstGeom prst="rect">
+            <a:avLst/>
+          </a:prstGeom>
+          <a:noFill/>
+          <a:ln/>
+        </p:spPr>
+        <p:txBody>
+          <a:bodyPr wrap="square" lIns="0" tIns="0" rIns="0" bIns="0" rtlCol="0" anchor="ctr"/>
+          <a:lstStyle/>
+          <a:p>
+            <a:pPr algn="ctr" indent="0" marL="0">
+              <a:buNone/>
+            </a:pPr>
+            <a:r>
+              <a:rPr lang="en-US" sz="1100" b="1" dirty="0">
+                <a:solidFill>
+                  <a:srgbClr val="FFFFFF"/>
+                </a:solidFill>
+                <a:latin typeface="Arial" pitchFamily="34" charset="0"/>
+                <a:ea typeface="Arial" pitchFamily="34" charset="-122"/>
+                <a:cs typeface="Arial" pitchFamily="34" charset="-120"/>
+              </a:rPr>
+              <a:t>2</a:t>
+            </a:r>
+            <a:endParaRPr lang="en-US" sz="1100" dirty="0"/>
+          </a:p>
+        </p:txBody>
+      </p:sp>
+      <p:sp>
+        <p:nvSpPr>
+          <p:cNvPr id="20" name="Text 17"/>
+          <p:cNvSpPr txBox="1"/>
+          <p:nvPr/>
+        </p:nvSpPr>
+        <p:spPr>
+          <a:xfrm>
+            <a:off x="868680" y="2560320"/>
+            <a:ext cx="2423160" cy="512064"/>
+          </a:xfrm>
+          <a:prstGeom prst="rect">
+            <a:avLst/>
+          </a:prstGeom>
+          <a:noFill/>
+          <a:ln/>
+        </p:spPr>
+        <p:txBody>
+          <a:bodyPr wrap="square" lIns="0" tIns="0" rIns="0" bIns="0" rtlCol="0" anchor="t"/>
+          <a:lstStyle/>
+          <a:p>
+            <a:pPr indent="0" marL="0">
+              <a:buNone/>
+            </a:pPr>
+            <a:r>
+              <a:rPr lang="en-US" sz="1250" b="1" dirty="0">
+                <a:solidFill>
+                  <a:srgbClr val="1F2A33"/>
+                </a:solidFill>
+                <a:latin typeface="Arial" pitchFamily="34" charset="0"/>
+                <a:ea typeface="Arial" pitchFamily="34" charset="-122"/>
+                <a:cs typeface="Arial" pitchFamily="34" charset="-120"/>
+              </a:rPr>
+              <a:t>The value math holds</a:t>
+            </a:r>
+            <a:endParaRPr lang="en-US" sz="1250" dirty="0"/>
+          </a:p>
+        </p:txBody>
+      </p:sp>
+      <p:sp>
+        <p:nvSpPr>
+          <p:cNvPr id="21" name="Text 18"/>
+          <p:cNvSpPr txBox="1"/>
+          <p:nvPr/>
+        </p:nvSpPr>
+        <p:spPr>
+          <a:xfrm>
+            <a:off x="3520440" y="2560320"/>
+            <a:ext cx="4160520" cy="731520"/>
+          </a:xfrm>
+          <a:prstGeom prst="rect">
+            <a:avLst/>
+          </a:prstGeom>
+          <a:noFill/>
+          <a:ln/>
+        </p:spPr>
+        <p:txBody>
+          <a:bodyPr wrap="square" lIns="0" tIns="0" rIns="0" bIns="0" rtlCol="0" anchor="t"/>
+          <a:lstStyle/>
+          <a:p>
+            <a:pPr indent="0" marL="0">
+              <a:buNone/>
+            </a:pPr>
+            <a:r>
+              <a:rPr lang="en-US" sz="1000" dirty="0">
+                <a:solidFill>
+                  <a:srgbClr val="1F2A33"/>
+                </a:solidFill>
+                <a:latin typeface="Arial" pitchFamily="34" charset="0"/>
+                <a:ea typeface="Arial" pitchFamily="34" charset="-122"/>
+                <a:cs typeface="Arial" pitchFamily="34" charset="-120"/>
+              </a:rPr>
+              <a:t>Sized bottom-up from a validated baseline with haircuts applied — and the value is claimed once, with overlaps adjusted in sequencing.</a:t>
+            </a:r>
+            <a:endParaRPr lang="en-US" sz="1000" dirty="0"/>
+          </a:p>
+        </p:txBody>
+      </p:sp>
+      <p:sp>
+        <p:nvSpPr>
+          <p:cNvPr id="22" name="Text 19"/>
+          <p:cNvSpPr txBox="1"/>
+          <p:nvPr/>
+        </p:nvSpPr>
+        <p:spPr>
+          <a:xfrm>
+            <a:off x="7955280" y="2560320"/>
+            <a:ext cx="3749040" cy="731520"/>
+          </a:xfrm>
+          <a:prstGeom prst="rect">
+            <a:avLst/>
+          </a:prstGeom>
+          <a:noFill/>
+          <a:ln/>
+        </p:spPr>
+        <p:txBody>
+          <a:bodyPr wrap="square" lIns="0" tIns="0" rIns="0" bIns="0" rtlCol="0" anchor="t"/>
+          <a:lstStyle/>
+          <a:p>
+            <a:pPr indent="0" marL="0">
+              <a:buNone/>
+            </a:pPr>
+            <a:r>
+              <a:rPr lang="en-US" sz="1000" i="1" dirty="0">
+                <a:solidFill>
+                  <a:srgbClr val="9A5A0B"/>
+                </a:solidFill>
+                <a:latin typeface="Arial" pitchFamily="34" charset="0"/>
+                <a:ea typeface="Arial" pitchFamily="34" charset="-122"/>
+                <a:cs typeface="Arial" pitchFamily="34" charset="-120"/>
+              </a:rPr>
+              <a:t>A top-down percentage on an unvalidated baseline, or the same savings counted by two initiatives.</a:t>
+            </a:r>
+            <a:endParaRPr lang="en-US" sz="1000" dirty="0"/>
+          </a:p>
+        </p:txBody>
+      </p:sp>
+      <p:sp>
+        <p:nvSpPr>
+          <p:cNvPr id="23" name="Shape 20"/>
+          <p:cNvSpPr/>
+          <p:nvPr/>
+        </p:nvSpPr>
+        <p:spPr>
+          <a:xfrm>
+            <a:off x="502920" y="3310128"/>
+            <a:ext cx="11201400" cy="0"/>
+          </a:xfrm>
+          <a:prstGeom prst="line">
+            <a:avLst/>
+          </a:prstGeom>
+          <a:noFill/>
+          <a:ln w="9525">
+            <a:solidFill>
+              <a:srgbClr val="DCE3E8"/>
+            </a:solidFill>
+            <a:prstDash val="solid"/>
+          </a:ln>
+        </p:spPr>
+      </p:sp>
+      <p:sp>
+        <p:nvSpPr>
+          <p:cNvPr id="24" name="Shape 21"/>
+          <p:cNvSpPr/>
+          <p:nvPr/>
+        </p:nvSpPr>
+        <p:spPr>
+          <a:xfrm>
+            <a:off x="502920" y="3438144"/>
+            <a:ext cx="237744" cy="237744"/>
+          </a:xfrm>
+          <a:prstGeom prst="ellipse">
+            <a:avLst/>
+          </a:prstGeom>
+          <a:solidFill>
+            <a:srgbClr val="0B6B5D"/>
+          </a:solidFill>
+          <a:ln/>
+        </p:spPr>
+      </p:sp>
+      <p:sp>
+        <p:nvSpPr>
+          <p:cNvPr id="25" name="Text 22"/>
+          <p:cNvSpPr txBox="1"/>
+          <p:nvPr/>
+        </p:nvSpPr>
+        <p:spPr>
+          <a:xfrm>
+            <a:off x="502920" y="3438144"/>
+            <a:ext cx="237744" cy="237744"/>
+          </a:xfrm>
+          <a:prstGeom prst="rect">
+            <a:avLst/>
+          </a:prstGeom>
+          <a:noFill/>
+          <a:ln/>
+        </p:spPr>
+        <p:txBody>
+          <a:bodyPr wrap="square" lIns="0" tIns="0" rIns="0" bIns="0" rtlCol="0" anchor="ctr"/>
+          <a:lstStyle/>
+          <a:p>
+            <a:pPr algn="ctr" indent="0" marL="0">
+              <a:buNone/>
+            </a:pPr>
+            <a:r>
+              <a:rPr lang="en-US" sz="1100" b="1" dirty="0">
+                <a:solidFill>
+                  <a:srgbClr val="FFFFFF"/>
+                </a:solidFill>
+                <a:latin typeface="Arial" pitchFamily="34" charset="0"/>
+                <a:ea typeface="Arial" pitchFamily="34" charset="-122"/>
+                <a:cs typeface="Arial" pitchFamily="34" charset="-120"/>
+              </a:rPr>
+              <a:t>3</a:t>
+            </a:r>
+            <a:endParaRPr lang="en-US" sz="1100" dirty="0"/>
+          </a:p>
+        </p:txBody>
+      </p:sp>
+      <p:sp>
+        <p:nvSpPr>
+          <p:cNvPr id="26" name="Text 23"/>
+          <p:cNvSpPr txBox="1"/>
+          <p:nvPr/>
+        </p:nvSpPr>
+        <p:spPr>
+          <a:xfrm>
+            <a:off x="868680" y="3419856"/>
+            <a:ext cx="2423160" cy="512064"/>
+          </a:xfrm>
+          <a:prstGeom prst="rect">
+            <a:avLst/>
+          </a:prstGeom>
+          <a:noFill/>
+          <a:ln/>
+        </p:spPr>
+        <p:txBody>
+          <a:bodyPr wrap="square" lIns="0" tIns="0" rIns="0" bIns="0" rtlCol="0" anchor="t"/>
+          <a:lstStyle/>
+          <a:p>
+            <a:pPr indent="0" marL="0">
+              <a:buNone/>
+            </a:pPr>
+            <a:r>
+              <a:rPr lang="en-US" sz="1250" b="1" dirty="0">
+                <a:solidFill>
+                  <a:srgbClr val="1F2A33"/>
+                </a:solidFill>
+                <a:latin typeface="Arial" pitchFamily="34" charset="0"/>
+                <a:ea typeface="Arial" pitchFamily="34" charset="-122"/>
+                <a:cs typeface="Arial" pitchFamily="34" charset="-120"/>
+              </a:rPr>
+              <a:t>The full AI cost is in</a:t>
+            </a:r>
+            <a:endParaRPr lang="en-US" sz="1250" dirty="0"/>
+          </a:p>
+        </p:txBody>
+      </p:sp>
+      <p:sp>
+        <p:nvSpPr>
+          <p:cNvPr id="27" name="Text 24"/>
+          <p:cNvSpPr txBox="1"/>
+          <p:nvPr/>
+        </p:nvSpPr>
+        <p:spPr>
+          <a:xfrm>
+            <a:off x="3520440" y="3419856"/>
+            <a:ext cx="4160520" cy="731520"/>
+          </a:xfrm>
+          <a:prstGeom prst="rect">
+            <a:avLst/>
+          </a:prstGeom>
+          <a:noFill/>
+          <a:ln/>
+        </p:spPr>
+        <p:txBody>
+          <a:bodyPr wrap="square" lIns="0" tIns="0" rIns="0" bIns="0" rtlCol="0" anchor="t"/>
+          <a:lstStyle/>
+          <a:p>
+            <a:pPr indent="0" marL="0">
+              <a:buNone/>
+            </a:pPr>
+            <a:r>
+              <a:rPr lang="en-US" sz="1000" dirty="0">
+                <a:solidFill>
+                  <a:srgbClr val="1F2A33"/>
+                </a:solidFill>
+                <a:latin typeface="Arial" pitchFamily="34" charset="0"/>
+                <a:ea typeface="Arial" pitchFamily="34" charset="-122"/>
+                <a:cs typeface="Arial" pitchFamily="34" charset="-120"/>
+              </a:rPr>
+              <a:t>One-time and recurring: build, platform and change management — plus tokens, licensing and a run team on the recurring side.</a:t>
+            </a:r>
+            <a:endParaRPr lang="en-US" sz="1000" dirty="0"/>
+          </a:p>
+        </p:txBody>
+      </p:sp>
+      <p:sp>
+        <p:nvSpPr>
+          <p:cNvPr id="28" name="Text 25"/>
+          <p:cNvSpPr txBox="1"/>
+          <p:nvPr/>
+        </p:nvSpPr>
+        <p:spPr>
+          <a:xfrm>
+            <a:off x="7955280" y="3419856"/>
+            <a:ext cx="3749040" cy="731520"/>
+          </a:xfrm>
+          <a:prstGeom prst="rect">
+            <a:avLst/>
+          </a:prstGeom>
+          <a:noFill/>
+          <a:ln/>
+        </p:spPr>
+        <p:txBody>
+          <a:bodyPr wrap="square" lIns="0" tIns="0" rIns="0" bIns="0" rtlCol="0" anchor="t"/>
+          <a:lstStyle/>
+          <a:p>
+            <a:pPr indent="0" marL="0">
+              <a:buNone/>
+            </a:pPr>
+            <a:r>
+              <a:rPr lang="en-US" sz="1000" i="1" dirty="0">
+                <a:solidFill>
+                  <a:srgbClr val="9A5A0B"/>
+                </a:solidFill>
+                <a:latin typeface="Arial" pitchFamily="34" charset="0"/>
+                <a:ea typeface="Arial" pitchFamily="34" charset="-122"/>
+                <a:cs typeface="Arial" pitchFamily="34" charset="-120"/>
+              </a:rPr>
+              <a:t>No token or run-cost line — the case only prices the build.</a:t>
+            </a:r>
+            <a:endParaRPr lang="en-US" sz="1000" dirty="0"/>
+          </a:p>
+        </p:txBody>
+      </p:sp>
+      <p:sp>
+        <p:nvSpPr>
+          <p:cNvPr id="29" name="Shape 26"/>
+          <p:cNvSpPr/>
+          <p:nvPr/>
+        </p:nvSpPr>
+        <p:spPr>
+          <a:xfrm>
+            <a:off x="502920" y="4169664"/>
+            <a:ext cx="11201400" cy="0"/>
+          </a:xfrm>
+          <a:prstGeom prst="line">
+            <a:avLst/>
+          </a:prstGeom>
+          <a:noFill/>
+          <a:ln w="9525">
+            <a:solidFill>
+              <a:srgbClr val="DCE3E8"/>
+            </a:solidFill>
+            <a:prstDash val="solid"/>
+          </a:ln>
+        </p:spPr>
+      </p:sp>
+      <p:sp>
+        <p:nvSpPr>
+          <p:cNvPr id="30" name="Shape 27"/>
+          <p:cNvSpPr/>
+          <p:nvPr/>
+        </p:nvSpPr>
+        <p:spPr>
+          <a:xfrm>
+            <a:off x="502920" y="4297680"/>
+            <a:ext cx="237744" cy="237744"/>
+          </a:xfrm>
+          <a:prstGeom prst="ellipse">
+            <a:avLst/>
+          </a:prstGeom>
+          <a:solidFill>
+            <a:srgbClr val="0B6B5D"/>
+          </a:solidFill>
+          <a:ln/>
+        </p:spPr>
+      </p:sp>
+      <p:sp>
+        <p:nvSpPr>
+          <p:cNvPr id="31" name="Text 28"/>
+          <p:cNvSpPr txBox="1"/>
+          <p:nvPr/>
+        </p:nvSpPr>
+        <p:spPr>
+          <a:xfrm>
+            <a:off x="502920" y="4297680"/>
+            <a:ext cx="237744" cy="237744"/>
+          </a:xfrm>
+          <a:prstGeom prst="rect">
+            <a:avLst/>
+          </a:prstGeom>
+          <a:noFill/>
+          <a:ln/>
+        </p:spPr>
+        <p:txBody>
+          <a:bodyPr wrap="square" lIns="0" tIns="0" rIns="0" bIns="0" rtlCol="0" anchor="ctr"/>
+          <a:lstStyle/>
+          <a:p>
+            <a:pPr algn="ctr" indent="0" marL="0">
+              <a:buNone/>
+            </a:pPr>
+            <a:r>
+              <a:rPr lang="en-US" sz="1100" b="1" dirty="0">
+                <a:solidFill>
+                  <a:srgbClr val="FFFFFF"/>
+                </a:solidFill>
+                <a:latin typeface="Arial" pitchFamily="34" charset="0"/>
+                <a:ea typeface="Arial" pitchFamily="34" charset="-122"/>
+                <a:cs typeface="Arial" pitchFamily="34" charset="-120"/>
+              </a:rPr>
+              <a:t>4</a:t>
+            </a:r>
+            <a:endParaRPr lang="en-US" sz="1100" dirty="0"/>
+          </a:p>
+        </p:txBody>
+      </p:sp>
+      <p:sp>
+        <p:nvSpPr>
+          <p:cNvPr id="32" name="Text 29"/>
+          <p:cNvSpPr txBox="1"/>
+          <p:nvPr/>
+        </p:nvSpPr>
+        <p:spPr>
+          <a:xfrm>
+            <a:off x="868680" y="4279392"/>
+            <a:ext cx="2423160" cy="512064"/>
+          </a:xfrm>
+          <a:prstGeom prst="rect">
+            <a:avLst/>
+          </a:prstGeom>
+          <a:noFill/>
+          <a:ln/>
+        </p:spPr>
+        <p:txBody>
+          <a:bodyPr wrap="square" lIns="0" tIns="0" rIns="0" bIns="0" rtlCol="0" anchor="t"/>
+          <a:lstStyle/>
+          <a:p>
+            <a:pPr indent="0" marL="0">
+              <a:buNone/>
+            </a:pPr>
+            <a:r>
+              <a:rPr lang="en-US" sz="1250" b="1" dirty="0">
+                <a:solidFill>
+                  <a:srgbClr val="1F2A33"/>
+                </a:solidFill>
+                <a:latin typeface="Arial" pitchFamily="34" charset="0"/>
+                <a:ea typeface="Arial" pitchFamily="34" charset="-122"/>
+                <a:cs typeface="Arial" pitchFamily="34" charset="-120"/>
+              </a:rPr>
+              <a:t>Tech is pressure-tested</a:t>
+            </a:r>
+            <a:endParaRPr lang="en-US" sz="1250" dirty="0"/>
+          </a:p>
+        </p:txBody>
+      </p:sp>
+      <p:sp>
+        <p:nvSpPr>
+          <p:cNvPr id="33" name="Text 30"/>
+          <p:cNvSpPr txBox="1"/>
+          <p:nvPr/>
+        </p:nvSpPr>
+        <p:spPr>
+          <a:xfrm>
+            <a:off x="3520440" y="4279392"/>
+            <a:ext cx="4160520" cy="731520"/>
+          </a:xfrm>
+          <a:prstGeom prst="rect">
+            <a:avLst/>
+          </a:prstGeom>
+          <a:noFill/>
+          <a:ln/>
+        </p:spPr>
+        <p:txBody>
+          <a:bodyPr wrap="square" lIns="0" tIns="0" rIns="0" bIns="0" rtlCol="0" anchor="t"/>
+          <a:lstStyle/>
+          <a:p>
+            <a:pPr indent="0" marL="0">
+              <a:buNone/>
+            </a:pPr>
+            <a:r>
+              <a:rPr lang="en-US" sz="1000" dirty="0">
+                <a:solidFill>
+                  <a:srgbClr val="1F2A33"/>
+                </a:solidFill>
+                <a:latin typeface="Arial" pitchFamily="34" charset="0"/>
+                <a:ea typeface="Arial" pitchFamily="34" charset="-122"/>
+                <a:cs typeface="Arial" pitchFamily="34" charset="-120"/>
+              </a:rPr>
+              <a:t>Dependencies are named, platform and engineering are engaged, and the implementation plan has been reviewed for feasibility — the CTO bar, carried here.</a:t>
+            </a:r>
+            <a:endParaRPr lang="en-US" sz="1000" dirty="0"/>
+          </a:p>
+        </p:txBody>
+      </p:sp>
+      <p:sp>
+        <p:nvSpPr>
+          <p:cNvPr id="34" name="Text 31"/>
+          <p:cNvSpPr txBox="1"/>
+          <p:nvPr/>
+        </p:nvSpPr>
+        <p:spPr>
+          <a:xfrm>
+            <a:off x="7955280" y="4279392"/>
+            <a:ext cx="3749040" cy="731520"/>
+          </a:xfrm>
+          <a:prstGeom prst="rect">
+            <a:avLst/>
+          </a:prstGeom>
+          <a:noFill/>
+          <a:ln/>
+        </p:spPr>
+        <p:txBody>
+          <a:bodyPr wrap="square" lIns="0" tIns="0" rIns="0" bIns="0" rtlCol="0" anchor="t"/>
+          <a:lstStyle/>
+          <a:p>
+            <a:pPr indent="0" marL="0">
+              <a:buNone/>
+            </a:pPr>
+            <a:r>
+              <a:rPr lang="en-US" sz="1000" i="1" dirty="0">
+                <a:solidFill>
+                  <a:srgbClr val="9A5A0B"/>
+                </a:solidFill>
+                <a:latin typeface="Arial" pitchFamily="34" charset="0"/>
+                <a:ea typeface="Arial" pitchFamily="34" charset="-122"/>
+                <a:cs typeface="Arial" pitchFamily="34" charset="-120"/>
+              </a:rPr>
+              <a:t>No named tech owner, or a plan engineering has never seen.</a:t>
+            </a:r>
+            <a:endParaRPr lang="en-US" sz="1000" dirty="0"/>
+          </a:p>
+        </p:txBody>
+      </p:sp>
+      <p:sp>
+        <p:nvSpPr>
+          <p:cNvPr id="35" name="Shape 32"/>
+          <p:cNvSpPr/>
+          <p:nvPr/>
+        </p:nvSpPr>
+        <p:spPr>
+          <a:xfrm>
+            <a:off x="502920" y="5029200"/>
+            <a:ext cx="11201400" cy="0"/>
+          </a:xfrm>
+          <a:prstGeom prst="line">
+            <a:avLst/>
+          </a:prstGeom>
+          <a:noFill/>
+          <a:ln w="9525">
+            <a:solidFill>
+              <a:srgbClr val="DCE3E8"/>
+            </a:solidFill>
+            <a:prstDash val="solid"/>
+          </a:ln>
+        </p:spPr>
+      </p:sp>
+      <p:sp>
+        <p:nvSpPr>
+          <p:cNvPr id="36" name="Shape 33"/>
+          <p:cNvSpPr/>
+          <p:nvPr/>
+        </p:nvSpPr>
+        <p:spPr>
+          <a:xfrm>
+            <a:off x="502920" y="5157216"/>
+            <a:ext cx="237744" cy="237744"/>
+          </a:xfrm>
+          <a:prstGeom prst="ellipse">
+            <a:avLst/>
+          </a:prstGeom>
+          <a:solidFill>
+            <a:srgbClr val="0B6B5D"/>
+          </a:solidFill>
+          <a:ln/>
+        </p:spPr>
+      </p:sp>
+      <p:sp>
+        <p:nvSpPr>
+          <p:cNvPr id="37" name="Text 34"/>
+          <p:cNvSpPr txBox="1"/>
+          <p:nvPr/>
+        </p:nvSpPr>
+        <p:spPr>
+          <a:xfrm>
+            <a:off x="502920" y="5157216"/>
+            <a:ext cx="237744" cy="237744"/>
+          </a:xfrm>
+          <a:prstGeom prst="rect">
+            <a:avLst/>
+          </a:prstGeom>
+          <a:noFill/>
+          <a:ln/>
+        </p:spPr>
+        <p:txBody>
+          <a:bodyPr wrap="square" lIns="0" tIns="0" rIns="0" bIns="0" rtlCol="0" anchor="ctr"/>
+          <a:lstStyle/>
+          <a:p>
+            <a:pPr algn="ctr" indent="0" marL="0">
+              <a:buNone/>
+            </a:pPr>
+            <a:r>
+              <a:rPr lang="en-US" sz="1100" b="1" dirty="0">
+                <a:solidFill>
+                  <a:srgbClr val="FFFFFF"/>
+                </a:solidFill>
+                <a:latin typeface="Arial" pitchFamily="34" charset="0"/>
+                <a:ea typeface="Arial" pitchFamily="34" charset="-122"/>
+                <a:cs typeface="Arial" pitchFamily="34" charset="-120"/>
+              </a:rPr>
+              <a:t>5</a:t>
+            </a:r>
+            <a:endParaRPr lang="en-US" sz="1100" dirty="0"/>
+          </a:p>
+        </p:txBody>
+      </p:sp>
+      <p:sp>
+        <p:nvSpPr>
+          <p:cNvPr id="38" name="Text 35"/>
+          <p:cNvSpPr txBox="1"/>
+          <p:nvPr/>
+        </p:nvSpPr>
+        <p:spPr>
+          <a:xfrm>
+            <a:off x="868680" y="5138928"/>
+            <a:ext cx="2423160" cy="512064"/>
+          </a:xfrm>
+          <a:prstGeom prst="rect">
+            <a:avLst/>
+          </a:prstGeom>
+          <a:noFill/>
+          <a:ln/>
+        </p:spPr>
+        <p:txBody>
+          <a:bodyPr wrap="square" lIns="0" tIns="0" rIns="0" bIns="0" rtlCol="0" anchor="t"/>
+          <a:lstStyle/>
+          <a:p>
+            <a:pPr indent="0" marL="0">
+              <a:buNone/>
+            </a:pPr>
+            <a:r>
+              <a:rPr lang="en-US" sz="1250" b="1" dirty="0">
+                <a:solidFill>
+                  <a:srgbClr val="1F2A33"/>
+                </a:solidFill>
+                <a:latin typeface="Arial" pitchFamily="34" charset="0"/>
+                <a:ea typeface="Arial" pitchFamily="34" charset="-122"/>
+                <a:cs typeface="Arial" pitchFamily="34" charset="-120"/>
+              </a:rPr>
+              <a:t>It uses the standard stack</a:t>
+            </a:r>
+            <a:endParaRPr lang="en-US" sz="1250" dirty="0"/>
+          </a:p>
+        </p:txBody>
+      </p:sp>
+      <p:sp>
+        <p:nvSpPr>
+          <p:cNvPr id="39" name="Text 36"/>
+          <p:cNvSpPr txBox="1"/>
+          <p:nvPr/>
+        </p:nvSpPr>
+        <p:spPr>
+          <a:xfrm>
+            <a:off x="3520440" y="5138928"/>
+            <a:ext cx="4160520" cy="731520"/>
+          </a:xfrm>
+          <a:prstGeom prst="rect">
+            <a:avLst/>
+          </a:prstGeom>
+          <a:noFill/>
+          <a:ln/>
+        </p:spPr>
+        <p:txBody>
+          <a:bodyPr wrap="square" lIns="0" tIns="0" rIns="0" bIns="0" rtlCol="0" anchor="t"/>
+          <a:lstStyle/>
+          <a:p>
+            <a:pPr indent="0" marL="0">
+              <a:buNone/>
+            </a:pPr>
+            <a:r>
+              <a:rPr lang="en-US" sz="1000" dirty="0">
+                <a:solidFill>
+                  <a:srgbClr val="1F2A33"/>
+                </a:solidFill>
+                <a:latin typeface="Arial" pitchFamily="34" charset="0"/>
+                <a:ea typeface="Arial" pitchFamily="34" charset="-122"/>
+                <a:cs typeface="Arial" pitchFamily="34" charset="-120"/>
+              </a:rPr>
+              <a:t>Built on approved platforms and existing vendor partnerships; a new tool only where no standard exists.</a:t>
+            </a:r>
+            <a:endParaRPr lang="en-US" sz="1000" dirty="0"/>
+          </a:p>
+        </p:txBody>
+      </p:sp>
+      <p:sp>
+        <p:nvSpPr>
+          <p:cNvPr id="40" name="Text 37"/>
+          <p:cNvSpPr txBox="1"/>
+          <p:nvPr/>
+        </p:nvSpPr>
+        <p:spPr>
+          <a:xfrm>
+            <a:off x="7955280" y="5138928"/>
+            <a:ext cx="3749040" cy="731520"/>
+          </a:xfrm>
+          <a:prstGeom prst="rect">
+            <a:avLst/>
+          </a:prstGeom>
+          <a:noFill/>
+          <a:ln/>
+        </p:spPr>
+        <p:txBody>
+          <a:bodyPr wrap="square" lIns="0" tIns="0" rIns="0" bIns="0" rtlCol="0" anchor="t"/>
+          <a:lstStyle/>
+          <a:p>
+            <a:pPr indent="0" marL="0">
+              <a:buNone/>
+            </a:pPr>
+            <a:r>
+              <a:rPr lang="en-US" sz="1000" i="1" dirty="0">
+                <a:solidFill>
+                  <a:srgbClr val="9A5A0B"/>
+                </a:solidFill>
+                <a:latin typeface="Arial" pitchFamily="34" charset="0"/>
+                <a:ea typeface="Arial" pitchFamily="34" charset="-122"/>
+                <a:cs typeface="Arial" pitchFamily="34" charset="-120"/>
+              </a:rPr>
+              <a:t>A new vendor duplicating a partnership we already have — one more random tool.</a:t>
+            </a:r>
+            <a:endParaRPr lang="en-US" sz="1000" dirty="0"/>
+          </a:p>
+        </p:txBody>
+      </p:sp>
+      <p:sp>
+        <p:nvSpPr>
+          <p:cNvPr id="41" name="Shape 38"/>
+          <p:cNvSpPr/>
+          <p:nvPr/>
+        </p:nvSpPr>
+        <p:spPr>
+          <a:xfrm>
+            <a:off x="502920" y="6035040"/>
+            <a:ext cx="11201400" cy="475488"/>
+          </a:xfrm>
+          <a:prstGeom prst="roundRect">
+            <a:avLst>
+              <a:gd name="adj" fmla="val 11538"/>
+            </a:avLst>
+          </a:prstGeom>
+          <a:solidFill>
+            <a:srgbClr val="EFF6F3"/>
+          </a:solidFill>
+          <a:ln/>
+        </p:spPr>
+      </p:sp>
+      <p:sp>
+        <p:nvSpPr>
+          <p:cNvPr id="42" name="Text 39"/>
+          <p:cNvSpPr txBox="1"/>
+          <p:nvPr/>
+        </p:nvSpPr>
+        <p:spPr>
+          <a:xfrm>
+            <a:off x="722376" y="6035040"/>
+            <a:ext cx="10789920" cy="475488"/>
+          </a:xfrm>
+          <a:prstGeom prst="rect">
+            <a:avLst/>
+          </a:prstGeom>
+          <a:noFill/>
+          <a:ln/>
+        </p:spPr>
+        <p:txBody>
+          <a:bodyPr wrap="square" lIns="0" tIns="0" rIns="0" bIns="0" rtlCol="0" anchor="ctr"/>
+          <a:lstStyle/>
+          <a:p>
+            <a:pPr indent="0" marL="0">
+              <a:buNone/>
+            </a:pPr>
+            <a:r>
+              <a:rPr lang="en-US" sz="1100" b="1" dirty="0">
+                <a:solidFill>
+                  <a:srgbClr val="0B6B5D"/>
+                </a:solidFill>
+                <a:latin typeface="Arial" pitchFamily="34" charset="0"/>
+                <a:ea typeface="Arial" pitchFamily="34" charset="-122"/>
+                <a:cs typeface="Arial" pitchFamily="34" charset="-120"/>
+              </a:rPr>
+              <a:t>All five hold → approved.   </a:t>
+            </a:r>
+            <a:pPr indent="0" marL="0">
+              <a:buNone/>
+            </a:pPr>
+            <a:r>
+              <a:rPr lang="en-US" sz="1100" dirty="0">
+                <a:solidFill>
+                  <a:srgbClr val="1F2A33"/>
+                </a:solidFill>
+                <a:latin typeface="Arial" pitchFamily="34" charset="0"/>
+                <a:ea typeface="Arial" pitchFamily="34" charset="-122"/>
+                <a:cs typeface="Arial" pitchFamily="34" charset="-120"/>
+              </a:rPr>
+              <a:t>Any gap → back to the team with the gap named — resubmit when it’s closed. </a:t>
+            </a:r>
+            <a:pPr indent="0" marL="0">
+              <a:buNone/>
+            </a:pPr>
+            <a:r>
+              <a:rPr lang="en-US" sz="1100" dirty="0">
+                <a:solidFill>
+                  <a:srgbClr val="5C6B77"/>
+                </a:solidFill>
+                <a:latin typeface="Arial" pitchFamily="34" charset="0"/>
+                <a:ea typeface="Arial" pitchFamily="34" charset="-122"/>
+                <a:cs typeface="Arial" pitchFamily="34" charset="-120"/>
+              </a:rPr>
+              <a:t>Financial approval runs separately.</a:t>
+            </a:r>
+            <a:endParaRPr lang="en-US" sz="1100" dirty="0"/>
+          </a:p>
+        </p:txBody>
+      </p:sp>
+      <p:sp>
+        <p:nvSpPr>
+          <p:cNvPr id="43" name="Text 40"/>
+          <p:cNvSpPr txBox="1"/>
+          <p:nvPr/>
+        </p:nvSpPr>
+        <p:spPr>
+          <a:xfrm>
+            <a:off x="502920" y="6675120"/>
+            <a:ext cx="11247120" cy="164592"/>
+          </a:xfrm>
+          <a:prstGeom prst="rect">
+            <a:avLst/>
+          </a:prstGeom>
+          <a:noFill/>
+          <a:ln/>
+        </p:spPr>
+        <p:txBody>
+          <a:bodyPr wrap="square" lIns="0" tIns="0" rIns="0" bIns="0" rtlCol="0" anchor="ctr"/>
+          <a:lstStyle/>
+          <a:p>
+            <a:pPr indent="0" marL="0">
+              <a:buNone/>
+            </a:pPr>
+            <a:r>
+              <a:rPr lang="en-US" sz="800" dirty="0">
+                <a:solidFill>
+                  <a:srgbClr val="8B98A2"/>
+                </a:solidFill>
+                <a:latin typeface="Arial" pitchFamily="34" charset="0"/>
+                <a:ea typeface="Arial" pitchFamily="34" charset="-122"/>
+                <a:cs typeface="Arial" pitchFamily="34" charset="-120"/>
+              </a:rPr>
+              <a:t>Stuck on a gate? Bring it to office hours — don’t wait for the review to find out.</a:t>
+            </a:r>
+            <a:endParaRPr lang="en-US" sz="800" dirty="0"/>
+          </a:p>
+        </p:txBody>
+      </p:sp>
+    </p:spTree>
+  </p:cSld>
+  <p:clrMapOvr>
+    <a:masterClrMapping/>
+  </p:clrMapOvr>
+</p:sld>
+</file>
+
+<file path=ppt/slides/slide3.xml><?xml version="1.0" encoding="utf-8"?>
+<p:sld xmlns:a="http://schemas.openxmlformats.org/drawingml/2006/main" xmlns:r="http://schemas.openxmlformats.org/officeDocument/2006/relationships" xmlns:p="http://schemas.openxmlformats.org/presentationml/2006/main">
+  <p:cSld name="Slide 3">
+    <p:bg>
+      <p:bgPr>
+        <a:solidFill>
+          <a:srgbClr val="FFFFFF"/>
+        </a:solidFill>
+      </p:bgPr>
+    </p:bg>
+    <p:spTree>
+      <p:nvGrpSpPr>
+        <p:cNvPr id="1" name=""/>
+        <p:cNvGrpSpPr/>
+        <p:nvPr/>
+      </p:nvGrpSpPr>
+      <p:grpSpPr>
+        <a:xfrm>
+          <a:off x="0" y="0"/>
+          <a:ext cx="0" cy="0"/>
+          <a:chOff x="0" y="0"/>
+          <a:chExt cx="0" cy="0"/>
+        </a:xfrm>
+      </p:grpSpPr>
+      <p:sp>
+        <p:nvSpPr>
+          <p:cNvPr id="3" name="Text 0"/>
+          <p:cNvSpPr txBox="1"/>
+          <p:nvPr/>
+        </p:nvSpPr>
+        <p:spPr>
+          <a:xfrm>
+            <a:off x="502920" y="237744"/>
+            <a:ext cx="7863840" cy="201168"/>
+          </a:xfrm>
+          <a:prstGeom prst="rect">
+            <a:avLst/>
+          </a:prstGeom>
+          <a:noFill/>
+          <a:ln/>
+        </p:spPr>
+        <p:txBody>
+          <a:bodyPr wrap="square" lIns="0" tIns="0" rIns="0" bIns="0" rtlCol="0" anchor="ctr"/>
+          <a:lstStyle/>
+          <a:p>
+            <a:pPr indent="0" marL="0">
+              <a:buNone/>
+            </a:pPr>
+            <a:r>
+              <a:rPr lang="en-US" sz="900" b="1" spc="200" kern="0" dirty="0">
+                <a:solidFill>
+                  <a:srgbClr val="5C6B77"/>
+                </a:solidFill>
+                <a:latin typeface="Arial" pitchFamily="34" charset="0"/>
+                <a:ea typeface="Arial" pitchFamily="34" charset="-122"/>
+                <a:cs typeface="Arial" pitchFamily="34" charset="-120"/>
+              </a:rPr>
               <a:t>BACKUP  ·  WORKED EXAMPLE — DATA SCIENTIST</a:t>
             </a:r>
             <a:endParaRPr lang="en-US" sz="900" dirty="0"/>

</xml_diff>

<commit_message>
Rewrite reviewer checklist in plain, parallel language
Gate titles are two-word noun phrases; every requirement starts with
the thing itself (clear problem statement, bottom-up sizing, full cost
picture, implementation plan reviewed, approved tools); send-back
reasons are plain sentences.

Co-Authored-By: Claude <noreply@anthropic.com>
Claude-Session: https://claude.ai/code/session_01NFmLfQt1gGoL7VkhSjRDgY
</commit_message>
<xml_diff>
--- a/docs/sizing-example/ds-sizing-example.pptx
+++ b/docs/sizing-example/ds-sizing-example.pptx
@@ -4184,7 +4184,7 @@
                 <a:ea typeface="Arial" pitchFamily="34" charset="-122"/>
                 <a:cs typeface="Arial" pitchFamily="34" charset="-120"/>
               </a:rPr>
-              <a:t>Finance approves the dollars. This review checks the AI substance — so sign-off is never a rubber stamp. Teams: run the same five gates before you submit.</a:t>
+              <a:t>Finance approves the dollars separately — this review makes sure sign-off is more than a rubber stamp. Teams: check these five before you submit.</a:t>
             </a:r>
             <a:endParaRPr lang="en-US" sz="1100" dirty="0"/>
           </a:p>
@@ -4422,7 +4422,7 @@
                 <a:ea typeface="Arial" pitchFamily="34" charset="-122"/>
                 <a:cs typeface="Arial" pitchFamily="34" charset="-120"/>
               </a:rPr>
-              <a:t>AI creates the value</a:t>
+              <a:t>Clear AI value</a:t>
             </a:r>
             <a:endParaRPr lang="en-US" sz="1250" dirty="0"/>
           </a:p>
@@ -4461,7 +4461,7 @@
                 <a:ea typeface="Arial" pitchFamily="34" charset="-122"/>
                 <a:cs typeface="Arial" pitchFamily="34" charset="-120"/>
               </a:rPr>
-              <a:t>The problem is clear and the mechanism is explicit: which workflow, what the AI or agent actually does, and why that produces the number.</a:t>
+              <a:t>Clear problem statement, and a plain explanation of what the AI actually does and where the savings come from.</a:t>
             </a:r>
             <a:endParaRPr lang="en-US" sz="1000" dirty="0"/>
           </a:p>
@@ -4500,7 +4500,7 @@
                 <a:ea typeface="Arial" pitchFamily="34" charset="-122"/>
                 <a:cs typeface="Arial" pitchFamily="34" charset="-120"/>
               </a:rPr>
-              <a:t>“AI” only appears in the title — the value really comes from ordinary process change.</a:t>
+              <a:t>AI is in the title, but the savings really come from ordinary process change.</a:t>
             </a:r>
             <a:endParaRPr lang="en-US" sz="1000" dirty="0"/>
           </a:p>
@@ -4621,7 +4621,7 @@
                 <a:ea typeface="Arial" pitchFamily="34" charset="-122"/>
                 <a:cs typeface="Arial" pitchFamily="34" charset="-120"/>
               </a:rPr>
-              <a:t>The value math holds</a:t>
+              <a:t>Sound sizing</a:t>
             </a:r>
             <a:endParaRPr lang="en-US" sz="1250" dirty="0"/>
           </a:p>
@@ -4660,7 +4660,7 @@
                 <a:ea typeface="Arial" pitchFamily="34" charset="-122"/>
                 <a:cs typeface="Arial" pitchFamily="34" charset="-120"/>
               </a:rPr>
-              <a:t>Sized bottom-up from a validated baseline with haircuts applied — and the value is claimed once, with overlaps adjusted in sequencing.</a:t>
+              <a:t>Bottom-up sizing from a baseline the team has validated, with haircuts applied — and no savings counted twice across initiatives.</a:t>
             </a:r>
             <a:endParaRPr lang="en-US" sz="1000" dirty="0"/>
           </a:p>
@@ -4699,7 +4699,7 @@
                 <a:ea typeface="Arial" pitchFamily="34" charset="-122"/>
                 <a:cs typeface="Arial" pitchFamily="34" charset="-120"/>
               </a:rPr>
-              <a:t>A top-down percentage on an unvalidated baseline, or the same savings counted by two initiatives.</a:t>
+              <a:t>A top-down percentage on a baseline nobody has checked, or savings another initiative already claims.</a:t>
             </a:r>
             <a:endParaRPr lang="en-US" sz="1000" dirty="0"/>
           </a:p>
@@ -4820,7 +4820,7 @@
                 <a:ea typeface="Arial" pitchFamily="34" charset="-122"/>
                 <a:cs typeface="Arial" pitchFamily="34" charset="-120"/>
               </a:rPr>
-              <a:t>The full AI cost is in</a:t>
+              <a:t>Complete costs</a:t>
             </a:r>
             <a:endParaRPr lang="en-US" sz="1250" dirty="0"/>
           </a:p>
@@ -4859,7 +4859,7 @@
                 <a:ea typeface="Arial" pitchFamily="34" charset="-122"/>
                 <a:cs typeface="Arial" pitchFamily="34" charset="-120"/>
               </a:rPr>
-              <a:t>One-time and recurring: build, platform and change management — plus tokens, licensing and a run team on the recurring side.</a:t>
+              <a:t>Full cost picture, one-time and recurring — build, platform and change management, plus tokens, licensing and support after go-live.</a:t>
             </a:r>
             <a:endParaRPr lang="en-US" sz="1000" dirty="0"/>
           </a:p>
@@ -4898,7 +4898,7 @@
                 <a:ea typeface="Arial" pitchFamily="34" charset="-122"/>
                 <a:cs typeface="Arial" pitchFamily="34" charset="-120"/>
               </a:rPr>
-              <a:t>No token or run-cost line — the case only prices the build.</a:t>
+              <a:t>The case prices the build but not the running costs — no line for tokens or support.</a:t>
             </a:r>
             <a:endParaRPr lang="en-US" sz="1000" dirty="0"/>
           </a:p>
@@ -5019,7 +5019,7 @@
                 <a:ea typeface="Arial" pitchFamily="34" charset="-122"/>
                 <a:cs typeface="Arial" pitchFamily="34" charset="-120"/>
               </a:rPr>
-              <a:t>Tech is pressure-tested</a:t>
+              <a:t>Tech readiness</a:t>
             </a:r>
             <a:endParaRPr lang="en-US" sz="1250" dirty="0"/>
           </a:p>
@@ -5058,7 +5058,7 @@
                 <a:ea typeface="Arial" pitchFamily="34" charset="-122"/>
                 <a:cs typeface="Arial" pitchFamily="34" charset="-120"/>
               </a:rPr>
-              <a:t>Dependencies are named, platform and engineering are engaged, and the implementation plan has been reviewed for feasibility — the CTO bar, carried here.</a:t>
+              <a:t>Implementation plan reviewed with the tech team: dependencies listed, engineering on board, feasibility confirmed.</a:t>
             </a:r>
             <a:endParaRPr lang="en-US" sz="1000" dirty="0"/>
           </a:p>
@@ -5097,7 +5097,7 @@
                 <a:ea typeface="Arial" pitchFamily="34" charset="-122"/>
                 <a:cs typeface="Arial" pitchFamily="34" charset="-120"/>
               </a:rPr>
-              <a:t>No named tech owner, or a plan engineering has never seen.</a:t>
+              <a:t>No tech owner named, or a plan the engineering team has never seen.</a:t>
             </a:r>
             <a:endParaRPr lang="en-US" sz="1000" dirty="0"/>
           </a:p>
@@ -5218,7 +5218,7 @@
                 <a:ea typeface="Arial" pitchFamily="34" charset="-122"/>
                 <a:cs typeface="Arial" pitchFamily="34" charset="-120"/>
               </a:rPr>
-              <a:t>It uses the standard stack</a:t>
+              <a:t>Standard tools</a:t>
             </a:r>
             <a:endParaRPr lang="en-US" sz="1250" dirty="0"/>
           </a:p>
@@ -5257,7 +5257,7 @@
                 <a:ea typeface="Arial" pitchFamily="34" charset="-122"/>
                 <a:cs typeface="Arial" pitchFamily="34" charset="-120"/>
               </a:rPr>
-              <a:t>Built on approved platforms and existing vendor partnerships; a new tool only where no standard exists.</a:t>
+              <a:t>Built with approved tools and existing vendor partnerships; a new tool only where nothing we have does the job.</a:t>
             </a:r>
             <a:endParaRPr lang="en-US" sz="1000" dirty="0"/>
           </a:p>
@@ -5296,7 +5296,7 @@
                 <a:ea typeface="Arial" pitchFamily="34" charset="-122"/>
                 <a:cs typeface="Arial" pitchFamily="34" charset="-120"/>
               </a:rPr>
-              <a:t>A new vendor duplicating a partnership we already have — one more random tool.</a:t>
+              <a:t>A new vendor doing what an existing partner already does.</a:t>
             </a:r>
             <a:endParaRPr lang="en-US" sz="1000" dirty="0"/>
           </a:p>
@@ -5357,7 +5357,7 @@
                 <a:ea typeface="Arial" pitchFamily="34" charset="-122"/>
                 <a:cs typeface="Arial" pitchFamily="34" charset="-120"/>
               </a:rPr>
-              <a:t>All five hold → approved.   </a:t>
+              <a:t>Pass all five → approved.   </a:t>
             </a:r>
             <a:pPr indent="0" marL="0">
               <a:buNone/>
@@ -5371,21 +5371,7 @@
                 <a:ea typeface="Arial" pitchFamily="34" charset="-122"/>
                 <a:cs typeface="Arial" pitchFamily="34" charset="-120"/>
               </a:rPr>
-              <a:t>Any gap → back to the team with the gap named — resubmit when it’s closed. </a:t>
-            </a:r>
-            <a:pPr indent="0" marL="0">
-              <a:buNone/>
-            </a:pPr>
-            <a:r>
-              <a:rPr lang="en-US" sz="1100" dirty="0">
-                <a:solidFill>
-                  <a:srgbClr val="5C6B77"/>
-                </a:solidFill>
-                <a:latin typeface="Arial" pitchFamily="34" charset="0"/>
-                <a:ea typeface="Arial" pitchFamily="34" charset="-122"/>
-                <a:cs typeface="Arial" pitchFamily="34" charset="-120"/>
-              </a:rPr>
-              <a:t>Financial approval runs separately.</a:t>
+              <a:t>Miss one → it goes back with a note on what’s missing — resubmit once it’s fixed.</a:t>
             </a:r>
             <a:endParaRPr lang="en-US" sz="1100" dirty="0"/>
           </a:p>
@@ -5424,7 +5410,7 @@
                 <a:ea typeface="Arial" pitchFamily="34" charset="-122"/>
                 <a:cs typeface="Arial" pitchFamily="34" charset="-120"/>
               </a:rPr>
-              <a:t>Stuck on a gate? Bring it to office hours — don’t wait for the review to find out.</a:t>
+              <a:t>Stuck on one of these? Bring it to office hours — don’t wait for the review to catch it.</a:t>
             </a:r>
             <a:endParaRPr lang="en-US" sz="800" dirty="0"/>
           </a:p>

</xml_diff>

<commit_message>
Reframe gate 5 as platform fit
The standardization check now reads as an architecture concern: each
initiative builds on the shared platform and existing partnerships
rather than adding a standalone tool.

Co-Authored-By: Claude <noreply@anthropic.com>
Claude-Session: https://claude.ai/code/session_01NFmLfQt1gGoL7VkhSjRDgY
</commit_message>
<xml_diff>
--- a/docs/sizing-example/ds-sizing-example.pptx
+++ b/docs/sizing-example/ds-sizing-example.pptx
@@ -5218,7 +5218,7 @@
                 <a:ea typeface="Arial" pitchFamily="34" charset="-122"/>
                 <a:cs typeface="Arial" pitchFamily="34" charset="-120"/>
               </a:rPr>
-              <a:t>Approved tooling</a:t>
+              <a:t>Platform fit</a:t>
             </a:r>
             <a:endParaRPr lang="en-US" sz="1250" dirty="0"/>
           </a:p>
@@ -5257,7 +5257,7 @@
                 <a:ea typeface="Arial" pitchFamily="34" charset="-122"/>
                 <a:cs typeface="Arial" pitchFamily="34" charset="-120"/>
               </a:rPr>
-              <a:t>Built with approved tools and existing vendor partnerships; a new tool only where nothing we have does the job.</a:t>
+              <a:t>Builds on the shared platform and existing vendor partnerships, so each initiative strengthens one backbone instead of adding another standalone tool.</a:t>
             </a:r>
             <a:endParaRPr lang="en-US" sz="1000" dirty="0"/>
           </a:p>
@@ -5296,7 +5296,7 @@
                 <a:ea typeface="Arial" pitchFamily="34" charset="-122"/>
                 <a:cs typeface="Arial" pitchFamily="34" charset="-120"/>
               </a:rPr>
-              <a:t>A new vendor doing what an existing partner already does.</a:t>
+              <a:t>A one-off build or a new vendor doing what the platform or an existing partner already does.</a:t>
             </a:r>
             <a:endParaRPr lang="en-US" sz="1000" dirty="0"/>
           </a:p>

</xml_diff>